<commit_message>
Say what the sigmoid's flat tails actually diminish in
The four artefacts justified the sigmoid's shape with "going from 0 to 4
reallocated sectors should change your mind a great deal", beside a figure
whose curve is steepest at 13.2 sectors and moves by 0.03 over the first
four. The example is right, but it belongs to the log1p transform of the
counters, not to the sigmoid: the returns diminish in the total evidence z.

State it in z, where two units from 0 buy 178 times what the same two buy
from 6, and name the apparent contradiction rather than leaving a student
to find it. Rehome the counter example in section 1.1, which never
mentioned the logarithmic scale at all despite the notebooks using it.

worked_examples.py refits the single-feature model from the raw drives and
recomputes both scales independently: 51 checks, up from 39.

Co-Authored-By: Claude Opus 5 <noreply@anthropic.com>
Claude-Session: https://claude.ai/code/session_01AGVdtkDgZ58kt68DhqnwXC
</commit_message>
<xml_diff>
--- a/Lessons/04_classification_and_metrics/Slides/classification_and_metrics_slides.pptx
+++ b/Lessons/04_classification_and_metrics/Slides/classification_and_metrics_slides.pptx
@@ -5882,7 +5882,21 @@
             </a:pPr>
             <a:r>
               <a:rPr/>
-              <a:t>Left: the curve. Steep in the middle, flat at both ends. Make the case that the flatness is the right behaviour, not a compromise - going from 0 to 4 reallocated sectors should change your mind a lot; going from 40 to 44 should barely register, because you had already concluded the drive was finished. Evidence has diminishing returns.</a:t>
+              <a:t>Left: the curve. Steep in the middle, flat at both ends. Make the case that the flatness is the right behaviour, not a compromise - and be precise about what is diminishing. It is the total evidence z, not any one counter. Two units of log-odds from z = 0 take the probability from 0.50 to 0.88; the same two from z = 6 take it from 0.9975 to 0.9997, 178 times less.</a:t>
+            </a:r>
+          </a:p>
+          <a:p>
+            <a:pPr lvl="0" indent="0" marL="0">
+              <a:buNone/>
+            </a:pPr>
+          </a:p>
+          <a:p>
+            <a:pPr lvl="0" indent="0" marL="0">
+              <a:buNone/>
+            </a:pPr>
+            <a:r>
+              <a:rPr/>
+              <a:t>Expect someone to object that the previous figure says otherwise. That curve is drawn against raw reallocated sectors, not against z, so it is steepest at 13.2 and the first four sectors move it by only 0.03. Both pictures are right: the counters act on a log scale, and on that scale four sectors are worth +4.7 in log-odds, taking a drive from a 0.01% chance of failing to 1.3%. Handout section 1.1.</a:t>
             </a:r>
           </a:p>
           <a:p>

</xml_diff>

<commit_message>
Say what classification_report is before quoting its rows
Slide 29 quotes `weighted avg` and `macro avg` F1, and its notes opened on
"classification_report prints three summary rows" - a name the deck
introduces nowhere, for an output students meet on slide 30, in notebook 2.
Section 6.4 of the handout opened on the same name, equally cold, and a
student reading only the handout has not seen the notebook at all.

Name it in both, and say in the notes that anticipating the report by one
slide is deliberate: the rule for choosing between those rows is wanted
before the notebook prints them, not after.

Co-Authored-By: Claude Opus 5 <noreply@anthropic.com>
Claude-Session: https://claude.ai/code/session_01AGVdtkDgZ58kt68DhqnwXC
</commit_message>
<xml_diff>
--- a/Lessons/04_classification_and_metrics/Slides/classification_and_metrics_slides.pptx
+++ b/Lessons/04_classification_and_metrics/Slides/classification_and_metrics_slides.pptx
@@ -2936,7 +2936,21 @@
             </a:pPr>
             <a:r>
               <a:rPr/>
-              <a:t>classification_report prints three summary rows and students quote whichever is biggest. Give them the rule.</a:t>
+              <a:t>classification_report is scikit-learn’s summary table, and they will print it themselves in notebook 2 in about five minutes: one row per class, then three summary rows - accuracy, macro avg, weighted avg. The two numbers on this slide are the f1-score column of the last two.</a:t>
+            </a:r>
+          </a:p>
+          <a:p>
+            <a:pPr lvl="0" indent="0" marL="0">
+              <a:buNone/>
+            </a:pPr>
+          </a:p>
+          <a:p>
+            <a:pPr lvl="0" indent="0" marL="0">
+              <a:buNone/>
+            </a:pPr>
+            <a:r>
+              <a:rPr/>
+              <a:t>Anticipating it by one slide is deliberate. The rule for choosing between those rows is what they need in their heads while they run the notebook, not afterwards - left to themselves they quote whichever is biggest.</a:t>
             </a:r>
           </a:p>
           <a:p>

</xml_diff>

<commit_message>
Audit every deck for gaps the week before it is taught
The eight kinds of gap lesson 1 exposed in a room become LESSON_REVIEW 2.9 and a
rule in CLAUDE.md. The acronym check now reads the slide body alone, which found
AUC and FPR in lesson 4 spelled out only in the notes.

Co-Authored-By: Claude Opus 5.5 <noreply@anthropic.com>
</commit_message>
<xml_diff>
--- a/Lessons/04_classification_and_metrics/Slides/classification_and_metrics_slides.pptx
+++ b/Lessons/04_classification_and_metrics/Slides/classification_and_metrics_slides.pptx
@@ -13286,7 +13286,7 @@
             <a:pPr lvl="0"/>
             <a:r>
               <a:rPr b="1"/>
-              <a:t>AUC = the probability that a random failing drive scores above a random healthy one</a:t>
+              <a:t>Area under the curve (AUC) = the probability that a random failing drive scores above a random healthy one</a:t>
             </a:r>
           </a:p>
           <a:p>
@@ -13550,7 +13550,7 @@
             <a:pPr lvl="0"/>
             <a:r>
               <a:rPr/>
-              <a:t>FPR divides by </a:t>
+              <a:t>False positive rate (FPR) divides by </a:t>
             </a:r>
             <a:r>
               <a:rPr b="1"/>

</xml_diff>

<commit_message>
Get lesson 4 ready: the intercept, the gaps, code anchors, plain notes
The slide and handout called the intercept "the base rate"; it is the chance
of a drive average on every counter, 0.2%, while the fleet fails at 3.8%, and
that gap is what the second half of the lesson turns on. Both now say so. The
predicted probability is p in the cross-entropy and y-hat in the gradient; the
notes and the notation table now say they are one number.

A gap audit of the slide bodies: odds defined where they are used; precision,
recall and specificity written as formulas with their counts, and TP, FP, FN,
TN named; F1 given as 2PR / (P + R); average precision on the slide that
recommends it; the train/test split stated. The three notebook slides carry
the section-to-call tables and the concept slides their In code lines. The
notes drop "sin", "marking", "antidote", "reparameterisation"; SMOTE, support
and m_k are spelled out.

Co-Authored-By: Claude Opus 5.5 <noreply@anthropic.com>
</commit_message>
<xml_diff>
--- a/Lessons/04_classification_and_metrics/Slides/classification_and_metrics_slides.pptx
+++ b/Lessons/04_classification_and_metrics/Slides/classification_and_metrics_slides.pptx
@@ -586,7 +586,7 @@
             </a:pPr>
             <a:r>
               <a:rPr/>
-              <a:t>The one to watch for: choosing the penalty by looking at the test error. It is the natural thing to do because the test error is the number they were told to care about, and it is exactly the sin lesson 1 named. Today’s lesson ends up in the same place from a different direction, when we choose a decision threshold. Lesson 5 gives them the machinery to do both honestly.</a:t>
+              <a:t>The one to watch for: choosing the penalty by looking at the test error. It is the natural thing to do because the test error is the number they were told to care about, and it is exactly the mistake lesson 1 named. Today’s lesson ends up in the same place from a different direction, when we choose a decision threshold. Lesson 5 gives them the machinery to do both honestly.</a:t>
             </a:r>
           </a:p>
         </p:txBody>
@@ -668,7 +668,7 @@
             </a:pPr>
             <a:r>
               <a:rPr/>
-              <a:t>Notebook 1, last section. This is the payoff of using synthetic data: we are not admiring the estimates, we are marking them.</a:t>
+              <a:t>Notebook 1, last section. This is the payoff of using synthetic data: we do not just look at the estimates, we check them against the truth.</a:t>
             </a:r>
           </a:p>
           <a:p>
@@ -806,6 +806,20 @@
             </a:pPr>
             <a:r>
               <a:rPr/>
+              <a:t>Say first what the intercept is NOT: it is not the base rate. The fleet fails at 3.8%; the intercept describes a drive whose every counter sits at the average, and such a drive almost never fails. The failures come from the small group of drives far above average on one or more counters. Handout section 2.4.</a:t>
+            </a:r>
+          </a:p>
+          <a:p>
+            <a:pPr lvl="0" indent="0" marL="0">
+              <a:buNone/>
+            </a:pPr>
+          </a:p>
+          <a:p>
+            <a:pPr lvl="0" indent="0" marL="0">
+              <a:buNone/>
+            </a:pPr>
+            <a:r>
+              <a:rPr/>
               <a:t>An average drive has a 0.2% chance of failing in thirty days. For the model to reach an even bet - probability one half, log-odds zero - the evidence has to move the log-odds by more than six. Only badly degraded drives manage that.</a:t>
             </a:r>
           </a:p>
@@ -1122,7 +1136,7 @@
             </a:pPr>
             <a:r>
               <a:rPr/>
-              <a:t>This is the loss on ONE example, L, not the cost over the training set. Say the missing half rather than showing it: the cost J is the average of this over the m examples, one over m times the sum. Written out in full the formula reached the slide edge and came out at 26pt, smaller than the bullets on the slide before it.</a:t>
+              <a:t>This is the loss on ONE example, L, not the cost over the training set; p is the predicted probability, the same number the next slide writes as y-hat. Say the other half aloud rather than showing it: the cost J is the average of this over the m examples, one over m times the sum. Written out in full the formula reached the slide edge and came out at 26pt, smaller than the bullets on the slide before it.</a:t>
             </a:r>
           </a:p>
           <a:p>
@@ -1618,7 +1632,7 @@
             </a:pPr>
             <a:r>
               <a:rPr/>
-              <a:t>Run notebooks/01. Twenty minutes. The parts worth stopping on:</a:t>
+              <a:t>Fifteen lines of NumPy, then one line of scikit-learn, and the same answer. Run notebook 01. Twenty minutes. The parts worth stopping on:</a:t>
             </a:r>
           </a:p>
           <a:p>
@@ -1880,7 +1894,7 @@
             </a:pPr>
             <a:r>
               <a:rPr/>
-              <a:t>Agenda. Flag the proportion out loud, because it is the point of the lesson: about a third of today is the model, two thirds is how to tell whether it works.</a:t>
+              <a:t>The agenda. Point out the proportion, because it is the point of the lesson: about a third of today is the model, two thirds is how to tell whether it works.</a:t>
             </a:r>
           </a:p>
           <a:p>
@@ -2564,7 +2578,7 @@
             </a:pPr>
             <a:r>
               <a:rPr/>
-              <a:t>This picture is the antidote to the most reliable confusion in the lesson. Both metrics divide the true positives. The difference is entirely in what goes underneath, and the shading shows it.</a:t>
+              <a:t>This picture prevents the most common confusion of the lesson. Both metrics divide the true positives. The difference is entirely in what goes underneath, and the shading shows it.</a:t>
             </a:r>
           </a:p>
           <a:p>
@@ -3074,7 +3088,7 @@
             </a:pPr>
             <a:r>
               <a:rPr/>
-              <a:t>Run notebooks/02. Twenty minutes.</a:t>
+              <a:t>The confusion matrix by hand, then from scikit-learn, then the threshold sweep. Run notebook 02. Twenty minutes.</a:t>
             </a:r>
           </a:p>
           <a:p>
@@ -3102,7 +3116,7 @@
             </a:pPr>
             <a:r>
               <a:rPr/>
-              <a:t>The cell to linger on is the threshold sweep table. Do not explain it first - let them read the columns and say what they see. Somebody will notice that accuracy barely moves. That is the moment to make the next slide.</a:t>
+              <a:t>Spend time on the threshold sweep table. Do not explain it first - let them read the columns and say what they see. Somebody will notice that accuracy barely moves. That is the moment to make the next slide.</a:t>
             </a:r>
           </a:p>
         </p:txBody>
@@ -4988,7 +5002,7 @@
             </a:pPr>
             <a:r>
               <a:rPr/>
-              <a:t>That matters because class weighting is usually presented as a REMEDY for imbalance. It is not a remedy; it is a reparameterisation of the same decision. The remedy, where one exists, is more positive examples.</a:t>
+              <a:t>That matters because class weighting is usually presented as a REMEDY for imbalance. It is not a remedy; it is another way of setting the same decision. The remedy, where one exists, is more positive examples.</a:t>
             </a:r>
           </a:p>
           <a:p>
@@ -5016,7 +5030,7 @@
             </a:pPr>
             <a:r>
               <a:rPr/>
-              <a:t>Same caution for resampling and SMOTE - and it must happen inside the cross-validation fold, for the reasons lesson 2 gave about imputation.</a:t>
+              <a:t>Same caution for resampling and for SMOTE (synthetic minority oversampling technique, which builds artificial minority examples) - and it must happen inside the cross-validation fold, for the reasons lesson 2 gave about imputation.</a:t>
             </a:r>
           </a:p>
         </p:txBody>
@@ -5098,21 +5112,21 @@
             </a:pPr>
             <a:r>
               <a:rPr/>
-              <a:t>Run notebooks/03. Twenty minutes if the clock allows, otherwise show the pairs experiment and the imbalance comparison and leave the rest for them.</a:t>
-            </a:r>
-          </a:p>
-          <a:p>
-            <a:pPr lvl="0" indent="0" marL="0">
-              <a:buNone/>
-            </a:pPr>
-          </a:p>
-          <a:p>
-            <a:pPr lvl="0" indent="0" marL="0">
-              <a:buNone/>
-            </a:pPr>
-            <a:r>
-              <a:rPr/>
-              <a:t>The pairs experiment is the cell worth protecting if time is short: it turns a definition they would otherwise memorise into something they watched happen.</a:t>
+              <a:t>The ROC curve by hand, the 200,000-pair experiment, the cost curve, then the multiclass matrix. Run notebook 03. Twenty minutes if the clock allows, otherwise show the pairs experiment and the imbalance comparison and leave the rest for them.</a:t>
+            </a:r>
+          </a:p>
+          <a:p>
+            <a:pPr lvl="0" indent="0" marL="0">
+              <a:buNone/>
+            </a:pPr>
+          </a:p>
+          <a:p>
+            <a:pPr lvl="0" indent="0" marL="0">
+              <a:buNone/>
+            </a:pPr>
+            <a:r>
+              <a:rPr/>
+              <a:t>If time is short, keep the pairs experiment: it turns a definition they would otherwise memorise into something they watched happen.</a:t>
             </a:r>
           </a:p>
         </p:txBody>
@@ -9377,7 +9391,7 @@
             <a:pPr lvl="0"/>
             <a:r>
               <a:rPr/>
-              <a:t>The model is linear in the log-odds, so </a:t>
+              <a:t>The model is linear in the log-odds, log(p ÷ (1 − p)), so </a:t>
             </a:r>
             <a:r>
               <a:rPr>
@@ -9393,6 +9407,10 @@
               <a:rPr b="1"/>
               <a:t>odds</a:t>
             </a:r>
+            <a:r>
+              <a:rPr/>
+              <a:t>, p ÷ (1 − p)</a:t>
+            </a:r>
           </a:p>
           <a:p>
             <a:pPr lvl="0"/>
@@ -9414,6 +9432,19 @@
             <a:r>
               <a:rPr/>
               <a:t> of failing</a:t>
+            </a:r>
+          </a:p>
+          <a:p>
+            <a:pPr lvl="0"/>
+            <a:r>
+              <a:rPr/>
+              <a:t>In code: </a:t>
+            </a:r>
+            <a:r>
+              <a:rPr>
+                <a:latin typeface="Courier"/>
+              </a:rPr>
+              <a:t>make_pipeline(StandardScaler(), LogisticRegression())</a:t>
             </a:r>
           </a:p>
         </p:txBody>
@@ -9985,7 +10016,7 @@
             </a:pPr>
             <a:r>
               <a:rPr/>
-              <a:t>The intercept is the base rate</a:t>
+              <a:t>The intercept is the average drive’s chance</a:t>
             </a:r>
           </a:p>
         </p:txBody>
@@ -10024,7 +10055,14 @@
             <a:pPr lvl="0"/>
             <a:r>
               <a:rPr/>
-              <a:t>σ(-6.09) = 0.0023: a 0.2% chance for an average drive</a:t>
+              <a:t>σ(-6.09) = 0.0023: a 0.2% chance for a drive average on every counter</a:t>
+            </a:r>
+          </a:p>
+          <a:p>
+            <a:pPr lvl="0"/>
+            <a:r>
+              <a:rPr/>
+              <a:t>The fleet fails at 3.8%: the failures come from the few drives far above average</a:t>
             </a:r>
           </a:p>
         </p:txBody>
@@ -10191,7 +10229,7 @@
             <a:pPr lvl="0"/>
             <a:r>
               <a:rPr/>
-              <a:t>The model has a knob; each setting assigns a probability to what happened</a:t>
+              <a:t>The parameters w and b are a knob: each setting gives a probability to what actually happened</a:t>
             </a:r>
           </a:p>
           <a:p>
@@ -10596,41 +10634,282 @@
           </a:p>
         </p:txBody>
       </p:sp>
-      <p:sp>
-        <p:nvSpPr>
-          <p:cNvPr id="3" name="Content Placeholder 2"/>
-          <p:cNvSpPr>
-            <a:spLocks noGrp="1"/>
-          </p:cNvSpPr>
+      <p:graphicFrame>
+        <p:nvGraphicFramePr>
+          <p:cNvPr id="6" name="Content Placeholder 5"/>
+          <p:cNvGraphicFramePr>
+            <a:graphicFrameLocks noGrp="1"/>
+          </p:cNvGraphicFramePr>
           <p:nvPr>
             <p:ph idx="1"/>
           </p:nvPr>
-        </p:nvSpPr>
-        <p:spPr>
-          <a:xfrm>
-            <a:off x="457200" y="1200151"/>
-            <a:ext cx="8229600" cy="3394472"/>
-          </a:xfrm>
-        </p:spPr>
-        <p:txBody>
-          <a:bodyPr/>
-          <a:lstStyle/>
-          <a:p>
-            <a:pPr lvl="0"/>
-            <a:r>
-              <a:rPr/>
-              <a:t>Fifteen lines of NumPy, then one line of scikit-learn</a:t>
-            </a:r>
-          </a:p>
-          <a:p>
-            <a:pPr lvl="0"/>
-            <a:r>
-              <a:rPr/>
-              <a:t>Same answer</a:t>
-            </a:r>
-          </a:p>
-        </p:txBody>
-      </p:sp>
+        </p:nvGraphicFramePr>
+        <p:xfrm>
+          <a:off x="457200" y="1166099"/>
+          <a:ext cx="8229600" cy="3390900"/>
+        </p:xfrm>
+        <a:graphic>
+          <a:graphicData uri="http://schemas.openxmlformats.org/drawingml/2006/table">
+            <a:tbl>
+              <a:tblPr firstRow="1" bandRow="1">
+                <a:tableStyleId>{5C22544A-7EE6-4342-B048-85BDC9FD1C3A}</a:tableStyleId>
+              </a:tblPr>
+              <a:tblGrid>
+                <a:gridCol w="4114800"/>
+                <a:gridCol w="4114800"/>
+              </a:tblGrid>
+              <a:tr h="0">
+                <a:tc>
+                  <a:txBody>
+                    <a:bodyPr/>
+                    <a:lstStyle/>
+                    <a:p>
+                      <a:pPr lvl="0" indent="0" marL="0">
+                        <a:buNone/>
+                      </a:pPr>
+                      <a:r>
+                        <a:rPr/>
+                        <a:t>section, and its slides</a:t>
+                      </a:r>
+                    </a:p>
+                  </a:txBody>
+                  <a:tcPr/>
+                </a:tc>
+                <a:tc>
+                  <a:txBody>
+                    <a:bodyPr/>
+                    <a:lstStyle/>
+                    <a:p>
+                      <a:pPr lvl="0" indent="0" marL="0">
+                        <a:buNone/>
+                      </a:pPr>
+                      <a:r>
+                        <a:rPr/>
+                        <a:t>you call (→ the number to come back with)</a:t>
+                      </a:r>
+                    </a:p>
+                  </a:txBody>
+                  <a:tcPr/>
+                </a:tc>
+              </a:tr>
+              <a:tr h="0">
+                <a:tc>
+                  <a:txBody>
+                    <a:bodyPr/>
+                    <a:lstStyle/>
+                    <a:p>
+                      <a:pPr lvl="0" indent="0" marL="0">
+                        <a:buNone/>
+                      </a:pPr>
+                      <a:r>
+                        <a:rPr/>
+                        <a:t>a line on a 0/1 label, 7</a:t>
+                      </a:r>
+                    </a:p>
+                  </a:txBody>
+                </a:tc>
+                <a:tc>
+                  <a:txBody>
+                    <a:bodyPr/>
+                    <a:lstStyle/>
+                    <a:p>
+                      <a:pPr lvl="0" indent="0" marL="0">
+                        <a:buNone/>
+                      </a:pPr>
+                      <a:r>
+                        <a:rPr>
+                          <a:latin typeface="Courier"/>
+                        </a:rPr>
+                        <a:t>LinearRegression</a:t>
+                      </a:r>
+                      <a:r>
+                        <a:rPr/>
+                        <a:t> → 3,606 negative probabilities</a:t>
+                      </a:r>
+                    </a:p>
+                  </a:txBody>
+                </a:tc>
+              </a:tr>
+              <a:tr h="0">
+                <a:tc>
+                  <a:txBody>
+                    <a:bodyPr/>
+                    <a:lstStyle/>
+                    <a:p>
+                      <a:pPr lvl="0" indent="0" marL="0">
+                        <a:buNone/>
+                      </a:pPr>
+                      <a:r>
+                        <a:rPr/>
+                        <a:t>odds, and why not squared error, 8-18</a:t>
+                      </a:r>
+                    </a:p>
+                  </a:txBody>
+                </a:tc>
+                <a:tc>
+                  <a:txBody>
+                    <a:bodyPr/>
+                    <a:lstStyle/>
+                    <a:p>
+                      <a:pPr lvl="0" indent="0" marL="0">
+                        <a:buNone/>
+                      </a:pPr>
+                      <a:r>
+                        <a:rPr/>
+                        <a:t>NumPy only: the sigmoid, the two losses, their gradients</a:t>
+                      </a:r>
+                    </a:p>
+                  </a:txBody>
+                </a:tc>
+              </a:tr>
+              <a:tr h="0">
+                <a:tc>
+                  <a:txBody>
+                    <a:bodyPr/>
+                    <a:lstStyle/>
+                    <a:p>
+                      <a:pPr lvl="0" indent="0" marL="0">
+                        <a:buNone/>
+                      </a:pPr>
+                      <a:r>
+                        <a:rPr/>
+                        <a:t>gradient descent, 16</a:t>
+                      </a:r>
+                    </a:p>
+                  </a:txBody>
+                </a:tc>
+                <a:tc>
+                  <a:txBody>
+                    <a:bodyPr/>
+                    <a:lstStyle/>
+                    <a:p>
+                      <a:pPr lvl="0" indent="0" marL="0">
+                        <a:buNone/>
+                      </a:pPr>
+                      <a:r>
+                        <a:rPr>
+                          <a:latin typeface="Courier"/>
+                        </a:rPr>
+                        <a:t>train_test_split</a:t>
+                      </a:r>
+                      <a:r>
+                        <a:rPr/>
+                        <a:t>, </a:t>
+                      </a:r>
+                      <a:r>
+                        <a:rPr>
+                          <a:latin typeface="Courier"/>
+                        </a:rPr>
+                        <a:t>StandardScaler</a:t>
+                      </a:r>
+                      <a:r>
+                        <a:rPr/>
+                        <a:t>, fifteen lines of NumPy → log loss 0.6931 to 0.0692</a:t>
+                      </a:r>
+                    </a:p>
+                  </a:txBody>
+                </a:tc>
+              </a:tr>
+              <a:tr h="0">
+                <a:tc>
+                  <a:txBody>
+                    <a:bodyPr/>
+                    <a:lstStyle/>
+                    <a:p>
+                      <a:pPr lvl="0" indent="0" marL="0">
+                        <a:buNone/>
+                      </a:pPr>
+                      <a:r>
+                        <a:rPr/>
+                        <a:t>the decision boundary, 20</a:t>
+                      </a:r>
+                    </a:p>
+                  </a:txBody>
+                </a:tc>
+                <a:tc>
+                  <a:txBody>
+                    <a:bodyPr/>
+                    <a:lstStyle/>
+                    <a:p>
+                      <a:pPr lvl="0" indent="0" marL="0">
+                        <a:buNone/>
+                      </a:pPr>
+                      <a:r>
+                        <a:rPr>
+                          <a:latin typeface="Courier"/>
+                        </a:rPr>
+                        <a:t>make_pipeline(StandardScaler(), LogisticRegression())</a:t>
+                      </a:r>
+                      <a:r>
+                        <a:rPr/>
+                        <a:t> on two features</a:t>
+                      </a:r>
+                    </a:p>
+                  </a:txBody>
+                </a:tc>
+              </a:tr>
+              <a:tr h="0">
+                <a:tc>
+                  <a:txBody>
+                    <a:bodyPr/>
+                    <a:lstStyle/>
+                    <a:p>
+                      <a:pPr lvl="0" indent="0" marL="0">
+                        <a:buNone/>
+                      </a:pPr>
+                      <a:r>
+                        <a:rPr/>
+                        <a:t>the truth, recovered, 11-12</a:t>
+                      </a:r>
+                    </a:p>
+                  </a:txBody>
+                </a:tc>
+                <a:tc>
+                  <a:txBody>
+                    <a:bodyPr/>
+                    <a:lstStyle/>
+                    <a:p>
+                      <a:pPr lvl="0" indent="0" marL="0">
+                        <a:buNone/>
+                      </a:pPr>
+                      <a:r>
+                        <a:rPr>
+                          <a:latin typeface="Courier"/>
+                        </a:rPr>
+                        <a:t>LogisticRegression</a:t>
+                      </a:r>
+                      <a:r>
+                        <a:rPr/>
+                        <a:t>, </a:t>
+                      </a:r>
+                      <a:r>
+                        <a:rPr>
+                          <a:latin typeface="Courier"/>
+                        </a:rPr>
+                        <a:t>.coef_</a:t>
+                      </a:r>
+                      <a:r>
+                        <a:rPr/>
+                        <a:t>, </a:t>
+                      </a:r>
+                      <a:r>
+                        <a:rPr>
+                          <a:latin typeface="Courier"/>
+                        </a:rPr>
+                        <a:t>.intercept_</a:t>
+                      </a:r>
+                      <a:r>
+                        <a:rPr/>
+                        <a:t> → seek_error_rate 0.02, intercept −6.09</a:t>
+                      </a:r>
+                    </a:p>
+                  </a:txBody>
+                </a:tc>
+              </a:tr>
+            </a:tbl>
+          </a:graphicData>
+        </a:graphic>
+      </p:graphicFrame>
     </p:spTree>
   </p:cSld>
 </p:sld>
@@ -11549,7 +11828,14 @@
             <a:pPr lvl="0"/>
             <a:r>
               <a:rPr/>
-              <a:t>Precision </a:t>
+              <a:t>True and false positives and negatives: TP, FP, FN, TN</a:t>
+            </a:r>
+          </a:p>
+          <a:p>
+            <a:pPr lvl="0"/>
+            <a:r>
+              <a:rPr/>
+              <a:t>Precision = TP ÷ (TP + FP) = 43 ÷ 56 = </a:t>
             </a:r>
             <a:r>
               <a:rPr b="1"/>
@@ -11557,14 +11843,14 @@
             </a:r>
             <a:r>
               <a:rPr/>
-              <a:t>: of 56 drives flagged, 43 really failed</a:t>
+              <a:t>: of the drives flagged</a:t>
             </a:r>
           </a:p>
           <a:p>
             <a:pPr lvl="0"/>
             <a:r>
               <a:rPr/>
-              <a:t>Recall </a:t>
+              <a:t>Recall = TP ÷ (TP + FN) = 43 ÷ 76 = </a:t>
             </a:r>
             <a:r>
               <a:rPr b="1"/>
@@ -11572,14 +11858,37 @@
             </a:r>
             <a:r>
               <a:rPr/>
-              <a:t>: of 76 drives that failed, we found 43</a:t>
+              <a:t>: of the drives that failed</a:t>
             </a:r>
           </a:p>
           <a:p>
             <a:pPr lvl="0"/>
             <a:r>
               <a:rPr/>
-              <a:t>Specificity 0.993: of 1,924 healthy drives, we left 1,911 alone</a:t>
+              <a:t>Specificity = TN ÷ (TN + FP) = 1,911 ÷ 1,924 = 0.993</a:t>
+            </a:r>
+          </a:p>
+          <a:p>
+            <a:pPr lvl="0"/>
+            <a:r>
+              <a:rPr/>
+              <a:t>In code: </a:t>
+            </a:r>
+            <a:r>
+              <a:rPr>
+                <a:latin typeface="Courier"/>
+              </a:rPr>
+              <a:t>precision_score</a:t>
+            </a:r>
+            <a:r>
+              <a:rPr/>
+              <a:t>, </a:t>
+            </a:r>
+            <a:r>
+              <a:rPr>
+                <a:latin typeface="Courier"/>
+              </a:rPr>
+              <a:t>recall_score</a:t>
             </a:r>
           </a:p>
         </p:txBody>
@@ -11722,7 +12031,7 @@
                       </a:pPr>
                       <a:r>
                         <a:rPr/>
-                        <a:t>Arithmetic</a:t>
+                        <a:t>Arithmetic mean</a:t>
                       </a:r>
                     </a:p>
                   </a:txBody>
@@ -11738,7 +12047,7 @@
                       </a:pPr>
                       <a:r>
                         <a:rPr/>
-                        <a:t>Harmonic</a:t>
+                        <a:t>Harmonic, F1 = 2PR ÷ (P + R)</a:t>
                       </a:r>
                     </a:p>
                   </a:txBody>
@@ -11939,6 +12248,23 @@
               <a:t> (both classes get an equal say)</a:t>
             </a:r>
           </a:p>
+          <a:p>
+            <a:pPr lvl="0"/>
+            <a:r>
+              <a:rPr/>
+              <a:t>In code: </a:t>
+            </a:r>
+            <a:r>
+              <a:rPr>
+                <a:latin typeface="Courier"/>
+              </a:rPr>
+              <a:t>classification_report(y_test, y_pred)</a:t>
+            </a:r>
+            <a:r>
+              <a:rPr/>
+              <a:t> prints both rows</a:t>
+            </a:r>
+          </a:p>
         </p:txBody>
       </p:sp>
     </p:spTree>
@@ -12101,41 +12427,308 @@
           </a:p>
         </p:txBody>
       </p:sp>
-      <p:sp>
-        <p:nvSpPr>
-          <p:cNvPr id="3" name="Content Placeholder 2"/>
-          <p:cNvSpPr>
-            <a:spLocks noGrp="1"/>
-          </p:cNvSpPr>
+      <p:graphicFrame>
+        <p:nvGraphicFramePr>
+          <p:cNvPr id="6" name="Content Placeholder 5"/>
+          <p:cNvGraphicFramePr>
+            <a:graphicFrameLocks noGrp="1"/>
+          </p:cNvGraphicFramePr>
           <p:nvPr>
             <p:ph idx="1"/>
           </p:nvPr>
-        </p:nvSpPr>
-        <p:spPr>
-          <a:xfrm>
-            <a:off x="457200" y="1200151"/>
-            <a:ext cx="8229600" cy="3394472"/>
-          </a:xfrm>
-        </p:spPr>
-        <p:txBody>
-          <a:bodyPr/>
-          <a:lstStyle/>
-          <a:p>
-            <a:pPr lvl="0"/>
-            <a:r>
-              <a:rPr/>
-              <a:t>The confusion matrix by hand, then from scikit-learn</a:t>
-            </a:r>
-          </a:p>
-          <a:p>
-            <a:pPr lvl="0"/>
-            <a:r>
-              <a:rPr/>
-              <a:t>Then the threshold sweep</a:t>
-            </a:r>
-          </a:p>
-        </p:txBody>
-      </p:sp>
+        </p:nvGraphicFramePr>
+        <p:xfrm>
+          <a:off x="457200" y="1166099"/>
+          <a:ext cx="8229600" cy="3390900"/>
+        </p:xfrm>
+        <a:graphic>
+          <a:graphicData uri="http://schemas.openxmlformats.org/drawingml/2006/table">
+            <a:tbl>
+              <a:tblPr firstRow="1" bandRow="1">
+                <a:tableStyleId>{5C22544A-7EE6-4342-B048-85BDC9FD1C3A}</a:tableStyleId>
+              </a:tblPr>
+              <a:tblGrid>
+                <a:gridCol w="4114800"/>
+                <a:gridCol w="4114800"/>
+              </a:tblGrid>
+              <a:tr h="0">
+                <a:tc>
+                  <a:txBody>
+                    <a:bodyPr/>
+                    <a:lstStyle/>
+                    <a:p>
+                      <a:pPr lvl="0" indent="0" marL="0">
+                        <a:buNone/>
+                      </a:pPr>
+                      <a:r>
+                        <a:rPr/>
+                        <a:t>section, and its slides</a:t>
+                      </a:r>
+                    </a:p>
+                  </a:txBody>
+                  <a:tcPr/>
+                </a:tc>
+                <a:tc>
+                  <a:txBody>
+                    <a:bodyPr/>
+                    <a:lstStyle/>
+                    <a:p>
+                      <a:pPr lvl="0" indent="0" marL="0">
+                        <a:buNone/>
+                      </a:pPr>
+                      <a:r>
+                        <a:rPr/>
+                        <a:t>you call (→ the number to come back with)</a:t>
+                      </a:r>
+                    </a:p>
+                  </a:txBody>
+                  <a:tcPr/>
+                </a:tc>
+              </a:tr>
+              <a:tr h="0">
+                <a:tc>
+                  <a:txBody>
+                    <a:bodyPr/>
+                    <a:lstStyle/>
+                    <a:p>
+                      <a:pPr lvl="0" indent="0" marL="0">
+                        <a:buNone/>
+                      </a:pPr>
+                      <a:r>
+                        <a:rPr/>
+                        <a:t>the number that should worry you, 22</a:t>
+                      </a:r>
+                    </a:p>
+                  </a:txBody>
+                </a:tc>
+                <a:tc>
+                  <a:txBody>
+                    <a:bodyPr/>
+                    <a:lstStyle/>
+                    <a:p>
+                      <a:pPr lvl="0" indent="0" marL="0">
+                        <a:buNone/>
+                      </a:pPr>
+                      <a:r>
+                        <a:rPr>
+                          <a:latin typeface="Courier"/>
+                        </a:rPr>
+                        <a:t>accuracy_score</a:t>
+                      </a:r>
+                      <a:r>
+                        <a:rPr/>
+                        <a:t> → 96.20% for “always healthy”</a:t>
+                      </a:r>
+                    </a:p>
+                  </a:txBody>
+                </a:tc>
+              </a:tr>
+              <a:tr h="0">
+                <a:tc>
+                  <a:txBody>
+                    <a:bodyPr/>
+                    <a:lstStyle/>
+                    <a:p>
+                      <a:pPr lvl="0" indent="0" marL="0">
+                        <a:buNone/>
+                      </a:pPr>
+                      <a:r>
+                        <a:rPr/>
+                        <a:t>the confusion matrix, 24</a:t>
+                      </a:r>
+                    </a:p>
+                  </a:txBody>
+                </a:tc>
+                <a:tc>
+                  <a:txBody>
+                    <a:bodyPr/>
+                    <a:lstStyle/>
+                    <a:p>
+                      <a:pPr lvl="0" indent="0" marL="0">
+                        <a:buNone/>
+                      </a:pPr>
+                      <a:r>
+                        <a:rPr/>
+                        <a:t>counts by hand, then </a:t>
+                      </a:r>
+                      <a:r>
+                        <a:rPr>
+                          <a:latin typeface="Courier"/>
+                        </a:rPr>
+                        <a:t>confusion_matrix</a:t>
+                      </a:r>
+                      <a:r>
+                        <a:rPr/>
+                        <a:t>, </a:t>
+                      </a:r>
+                      <a:r>
+                        <a:rPr>
+                          <a:latin typeface="Courier"/>
+                        </a:rPr>
+                        <a:t>ConfusionMatrixDisplay</a:t>
+                      </a:r>
+                      <a:r>
+                        <a:rPr/>
+                        <a:t> → TP 43</a:t>
+                      </a:r>
+                    </a:p>
+                  </a:txBody>
+                </a:tc>
+              </a:tr>
+              <a:tr h="0">
+                <a:tc>
+                  <a:txBody>
+                    <a:bodyPr/>
+                    <a:lstStyle/>
+                    <a:p>
+                      <a:pPr lvl="0" indent="0" marL="0">
+                        <a:buNone/>
+                      </a:pPr>
+                      <a:r>
+                        <a:rPr/>
+                        <a:t>precision and recall, 26-29</a:t>
+                      </a:r>
+                    </a:p>
+                  </a:txBody>
+                </a:tc>
+                <a:tc>
+                  <a:txBody>
+                    <a:bodyPr/>
+                    <a:lstStyle/>
+                    <a:p>
+                      <a:pPr lvl="0" indent="0" marL="0">
+                        <a:buNone/>
+                      </a:pPr>
+                      <a:r>
+                        <a:rPr>
+                          <a:latin typeface="Courier"/>
+                        </a:rPr>
+                        <a:t>precision_score</a:t>
+                      </a:r>
+                      <a:r>
+                        <a:rPr/>
+                        <a:t>, </a:t>
+                      </a:r>
+                      <a:r>
+                        <a:rPr>
+                          <a:latin typeface="Courier"/>
+                        </a:rPr>
+                        <a:t>recall_score</a:t>
+                      </a:r>
+                      <a:r>
+                        <a:rPr/>
+                        <a:t>, </a:t>
+                      </a:r>
+                      <a:r>
+                        <a:rPr>
+                          <a:latin typeface="Courier"/>
+                        </a:rPr>
+                        <a:t>f1_score</a:t>
+                      </a:r>
+                      <a:r>
+                        <a:rPr/>
+                        <a:t>, </a:t>
+                      </a:r>
+                      <a:r>
+                        <a:rPr>
+                          <a:latin typeface="Courier"/>
+                        </a:rPr>
+                        <a:t>classification_report</a:t>
+                      </a:r>
+                    </a:p>
+                  </a:txBody>
+                </a:tc>
+              </a:tr>
+              <a:tr h="0">
+                <a:tc>
+                  <a:txBody>
+                    <a:bodyPr/>
+                    <a:lstStyle/>
+                    <a:p>
+                      <a:pPr lvl="0" indent="0" marL="0">
+                        <a:buNone/>
+                      </a:pPr>
+                      <a:r>
+                        <a:rPr/>
+                        <a:t>the threshold sweep, 31-32</a:t>
+                      </a:r>
+                    </a:p>
+                  </a:txBody>
+                </a:tc>
+                <a:tc>
+                  <a:txBody>
+                    <a:bodyPr/>
+                    <a:lstStyle/>
+                    <a:p>
+                      <a:pPr lvl="0" indent="0" marL="0">
+                        <a:buNone/>
+                      </a:pPr>
+                      <a:r>
+                        <a:rPr>
+                          <a:latin typeface="Courier"/>
+                        </a:rPr>
+                        <a:t>predict_proba</a:t>
+                      </a:r>
+                      <a:r>
+                        <a:rPr/>
+                        <a:t>, then the metrics at each threshold</a:t>
+                      </a:r>
+                    </a:p>
+                  </a:txBody>
+                </a:tc>
+              </a:tr>
+              <a:tr h="0">
+                <a:tc>
+                  <a:txBody>
+                    <a:bodyPr/>
+                    <a:lstStyle/>
+                    <a:p>
+                      <a:pPr lvl="0" indent="0" marL="0">
+                        <a:buNone/>
+                      </a:pPr>
+                      <a:r>
+                        <a:rPr/>
+                        <a:t>the precision-recall curve, 33</a:t>
+                      </a:r>
+                    </a:p>
+                  </a:txBody>
+                </a:tc>
+                <a:tc>
+                  <a:txBody>
+                    <a:bodyPr/>
+                    <a:lstStyle/>
+                    <a:p>
+                      <a:pPr lvl="0" indent="0" marL="0">
+                        <a:buNone/>
+                      </a:pPr>
+                      <a:r>
+                        <a:rPr>
+                          <a:latin typeface="Courier"/>
+                        </a:rPr>
+                        <a:t>precision_recall_curve</a:t>
+                      </a:r>
+                      <a:r>
+                        <a:rPr/>
+                        <a:t>, </a:t>
+                      </a:r>
+                      <a:r>
+                        <a:rPr>
+                          <a:latin typeface="Courier"/>
+                        </a:rPr>
+                        <a:t>average_precision_score</a:t>
+                      </a:r>
+                      <a:r>
+                        <a:rPr/>
+                        <a:t> → 0.717 against 0.038</a:t>
+                      </a:r>
+                    </a:p>
+                  </a:txBody>
+                </a:tc>
+              </a:tr>
+            </a:tbl>
+          </a:graphicData>
+        </a:graphic>
+      </p:graphicFrame>
     </p:spTree>
   </p:cSld>
 </p:sld>
@@ -13296,6 +13889,19 @@
               <a:t>Ours: 0.949</a:t>
             </a:r>
           </a:p>
+          <a:p>
+            <a:pPr lvl="0"/>
+            <a:r>
+              <a:rPr/>
+              <a:t>In code: </a:t>
+            </a:r>
+            <a:r>
+              <a:rPr>
+                <a:latin typeface="Courier"/>
+              </a:rPr>
+              <a:t>roc_auc_score(y_test, scores)</a:t>
+            </a:r>
+          </a:p>
         </p:txBody>
       </p:sp>
     </p:spTree>
@@ -13762,6 +14368,31 @@
               <a:t>Never instead of it, and never AUC alone</a:t>
             </a:r>
           </a:p>
+          <a:p>
+            <a:pPr lvl="0"/>
+            <a:r>
+              <a:rPr/>
+              <a:t>Its area is the </a:t>
+            </a:r>
+            <a:r>
+              <a:rPr b="1"/>
+              <a:t>average precision</a:t>
+            </a:r>
+            <a:r>
+              <a:rPr/>
+              <a:t>, </a:t>
+            </a:r>
+            <a:r>
+              <a:rPr>
+                <a:latin typeface="Courier"/>
+              </a:rPr>
+              <a:t>average_precision_score</a:t>
+            </a:r>
+            <a:r>
+              <a:rPr/>
+              <a:t>: 0.717 here, against a floor of 0.038</a:t>
+            </a:r>
+          </a:p>
         </p:txBody>
       </p:sp>
     </p:spTree>
@@ -14345,7 +14976,7 @@
                       </a:pPr>
                       <a:r>
                         <a:rPr/>
-                        <a:t>Balanced weights, 0.50</a:t>
+                        <a:t>Balanced class weights, 0.50</a:t>
                       </a:r>
                     </a:p>
                   </a:txBody>
@@ -14467,41 +15098,310 @@
           </a:p>
         </p:txBody>
       </p:sp>
-      <p:sp>
-        <p:nvSpPr>
-          <p:cNvPr id="3" name="Content Placeholder 2"/>
-          <p:cNvSpPr>
-            <a:spLocks noGrp="1"/>
-          </p:cNvSpPr>
+      <p:graphicFrame>
+        <p:nvGraphicFramePr>
+          <p:cNvPr id="6" name="Content Placeholder 5"/>
+          <p:cNvGraphicFramePr>
+            <a:graphicFrameLocks noGrp="1"/>
+          </p:cNvGraphicFramePr>
           <p:nvPr>
             <p:ph idx="1"/>
           </p:nvPr>
-        </p:nvSpPr>
-        <p:spPr>
-          <a:xfrm>
-            <a:off x="457200" y="1200151"/>
-            <a:ext cx="8229600" cy="3394472"/>
-          </a:xfrm>
-        </p:spPr>
-        <p:txBody>
-          <a:bodyPr/>
-          <a:lstStyle/>
-          <a:p>
-            <a:pPr lvl="0"/>
-            <a:r>
-              <a:rPr/>
-              <a:t>ROC by hand, the 200,000-pair experiment, the cost curve</a:t>
-            </a:r>
-          </a:p>
-          <a:p>
-            <a:pPr lvl="0"/>
-            <a:r>
-              <a:rPr/>
-              <a:t>Then the multiclass matrix</a:t>
-            </a:r>
-          </a:p>
-        </p:txBody>
-      </p:sp>
+        </p:nvGraphicFramePr>
+        <p:xfrm>
+          <a:off x="457200" y="1166099"/>
+          <a:ext cx="8229600" cy="3390900"/>
+        </p:xfrm>
+        <a:graphic>
+          <a:graphicData uri="http://schemas.openxmlformats.org/drawingml/2006/table">
+            <a:tbl>
+              <a:tblPr firstRow="1" bandRow="1">
+                <a:tableStyleId>{5C22544A-7EE6-4342-B048-85BDC9FD1C3A}</a:tableStyleId>
+              </a:tblPr>
+              <a:tblGrid>
+                <a:gridCol w="4114800"/>
+                <a:gridCol w="4114800"/>
+              </a:tblGrid>
+              <a:tr h="0">
+                <a:tc>
+                  <a:txBody>
+                    <a:bodyPr/>
+                    <a:lstStyle/>
+                    <a:p>
+                      <a:pPr lvl="0" indent="0" marL="0">
+                        <a:buNone/>
+                      </a:pPr>
+                      <a:r>
+                        <a:rPr/>
+                        <a:t>section, and its slides</a:t>
+                      </a:r>
+                    </a:p>
+                  </a:txBody>
+                  <a:tcPr/>
+                </a:tc>
+                <a:tc>
+                  <a:txBody>
+                    <a:bodyPr/>
+                    <a:lstStyle/>
+                    <a:p>
+                      <a:pPr lvl="0" indent="0" marL="0">
+                        <a:buNone/>
+                      </a:pPr>
+                      <a:r>
+                        <a:rPr/>
+                        <a:t>you call (→ the number to come back with)</a:t>
+                      </a:r>
+                    </a:p>
+                  </a:txBody>
+                  <a:tcPr/>
+                </a:tc>
+              </a:tr>
+              <a:tr h="0">
+                <a:tc>
+                  <a:txBody>
+                    <a:bodyPr/>
+                    <a:lstStyle/>
+                    <a:p>
+                      <a:pPr lvl="0" indent="0" marL="0">
+                        <a:buNone/>
+                      </a:pPr>
+                      <a:r>
+                        <a:rPr/>
+                        <a:t>the ROC curve by hand, 35</a:t>
+                      </a:r>
+                    </a:p>
+                  </a:txBody>
+                </a:tc>
+                <a:tc>
+                  <a:txBody>
+                    <a:bodyPr/>
+                    <a:lstStyle/>
+                    <a:p>
+                      <a:pPr lvl="0" indent="0" marL="0">
+                        <a:buNone/>
+                      </a:pPr>
+                      <a:r>
+                        <a:rPr>
+                          <a:latin typeface="Courier"/>
+                        </a:rPr>
+                        <a:t>roc_curve</a:t>
+                      </a:r>
+                      <a:r>
+                        <a:rPr/>
+                        <a:t>, </a:t>
+                      </a:r>
+                      <a:r>
+                        <a:rPr>
+                          <a:latin typeface="Courier"/>
+                        </a:rPr>
+                        <a:t>roc_auc_score</a:t>
+                      </a:r>
+                      <a:r>
+                        <a:rPr/>
+                        <a:t> → 0.9493</a:t>
+                      </a:r>
+                    </a:p>
+                  </a:txBody>
+                </a:tc>
+              </a:tr>
+              <a:tr h="0">
+                <a:tc>
+                  <a:txBody>
+                    <a:bodyPr/>
+                    <a:lstStyle/>
+                    <a:p>
+                      <a:pPr lvl="0" indent="0" marL="0">
+                        <a:buNone/>
+                      </a:pPr>
+                      <a:r>
+                        <a:rPr/>
+                        <a:t>what AUC means, 36</a:t>
+                      </a:r>
+                    </a:p>
+                  </a:txBody>
+                </a:tc>
+                <a:tc>
+                  <a:txBody>
+                    <a:bodyPr/>
+                    <a:lstStyle/>
+                    <a:p>
+                      <a:pPr lvl="0" indent="0" marL="0">
+                        <a:buNone/>
+                      </a:pPr>
+                      <a:r>
+                        <a:rPr/>
+                        <a:t>200,000 random (failing, healthy) pairs → 0.9488</a:t>
+                      </a:r>
+                    </a:p>
+                  </a:txBody>
+                </a:tc>
+              </a:tr>
+              <a:tr h="0">
+                <a:tc>
+                  <a:txBody>
+                    <a:bodyPr/>
+                    <a:lstStyle/>
+                    <a:p>
+                      <a:pPr lvl="0" indent="0" marL="0">
+                        <a:buNone/>
+                      </a:pPr>
+                      <a:r>
+                        <a:rPr/>
+                        <a:t>the rare-positive trap, 38-39</a:t>
+                      </a:r>
+                    </a:p>
+                  </a:txBody>
+                </a:tc>
+                <a:tc>
+                  <a:txBody>
+                    <a:bodyPr/>
+                    <a:lstStyle/>
+                    <a:p>
+                      <a:pPr lvl="0" indent="0" marL="0">
+                        <a:buNone/>
+                      </a:pPr>
+                      <a:r>
+                        <a:rPr>
+                          <a:latin typeface="Courier"/>
+                        </a:rPr>
+                        <a:t>average_precision_score</a:t>
+                      </a:r>
+                      <a:r>
+                        <a:rPr/>
+                        <a:t> beside </a:t>
+                      </a:r>
+                      <a:r>
+                        <a:rPr>
+                          <a:latin typeface="Courier"/>
+                        </a:rPr>
+                        <a:t>roc_auc_score</a:t>
+                      </a:r>
+                      <a:r>
+                        <a:rPr/>
+                        <a:t> → AP 0.706 to 0.361, AUC unmoved</a:t>
+                      </a:r>
+                    </a:p>
+                  </a:txBody>
+                </a:tc>
+              </a:tr>
+              <a:tr h="0">
+                <a:tc>
+                  <a:txBody>
+                    <a:bodyPr/>
+                    <a:lstStyle/>
+                    <a:p>
+                      <a:pPr lvl="0" indent="0" marL="0">
+                        <a:buNone/>
+                      </a:pPr>
+                      <a:r>
+                        <a:rPr/>
+                        <a:t>the threshold from costs, 41-43</a:t>
+                      </a:r>
+                    </a:p>
+                  </a:txBody>
+                </a:tc>
+                <a:tc>
+                  <a:txBody>
+                    <a:bodyPr/>
+                    <a:lstStyle/>
+                    <a:p>
+                      <a:pPr lvl="0" indent="0" marL="0">
+                        <a:buNone/>
+                      </a:pPr>
+                      <a:r>
+                        <a:rPr>
+                          <a:latin typeface="Courier"/>
+                        </a:rPr>
+                        <a:t>confusion_matrix</a:t>
+                      </a:r>
+                      <a:r>
+                        <a:rPr/>
+                        <a:t> at each threshold → 45,540 EUR at 0.08, against 87,620 at 0.50</a:t>
+                      </a:r>
+                    </a:p>
+                  </a:txBody>
+                </a:tc>
+              </a:tr>
+              <a:tr h="0">
+                <a:tc>
+                  <a:txBody>
+                    <a:bodyPr/>
+                    <a:lstStyle/>
+                    <a:p>
+                      <a:pPr lvl="0" indent="0" marL="0">
+                        <a:buNone/>
+                      </a:pPr>
+                      <a:r>
+                        <a:rPr/>
+                        <a:t>class weights, 44</a:t>
+                      </a:r>
+                    </a:p>
+                  </a:txBody>
+                </a:tc>
+                <a:tc>
+                  <a:txBody>
+                    <a:bodyPr/>
+                    <a:lstStyle/>
+                    <a:p>
+                      <a:pPr lvl="0" indent="0" marL="0">
+                        <a:buNone/>
+                      </a:pPr>
+                      <a:r>
+                        <a:rPr>
+                          <a:latin typeface="Courier"/>
+                        </a:rPr>
+                        <a:t>LogisticRegression</a:t>
+                      </a:r>
+                      <a:r>
+                        <a:rPr/>
+                        <a:t> with balanced class weights → AUC 0.950</a:t>
+                      </a:r>
+                    </a:p>
+                  </a:txBody>
+                </a:tc>
+              </a:tr>
+              <a:tr h="0">
+                <a:tc>
+                  <a:txBody>
+                    <a:bodyPr/>
+                    <a:lstStyle/>
+                    <a:p>
+                      <a:pPr lvl="0" indent="0" marL="0">
+                        <a:buNone/>
+                      </a:pPr>
+                      <a:r>
+                        <a:rPr/>
+                        <a:t>three classes, 46-47</a:t>
+                      </a:r>
+                    </a:p>
+                  </a:txBody>
+                </a:tc>
+                <a:tc>
+                  <a:txBody>
+                    <a:bodyPr/>
+                    <a:lstStyle/>
+                    <a:p>
+                      <a:pPr lvl="0" indent="0" marL="0">
+                        <a:buNone/>
+                      </a:pPr>
+                      <a:r>
+                        <a:rPr>
+                          <a:latin typeface="Courier"/>
+                        </a:rPr>
+                        <a:t>classification_report</a:t>
+                      </a:r>
+                      <a:r>
+                        <a:rPr/>
+                        <a:t> → macro F1 0.707, weighted 0.883</a:t>
+                      </a:r>
+                    </a:p>
+                  </a:txBody>
+                </a:tc>
+              </a:tr>
+            </a:tbl>
+          </a:graphicData>
+        </a:graphic>
+      </p:graphicFrame>
     </p:spTree>
   </p:cSld>
 </p:sld>
@@ -14997,6 +15897,19 @@
             <a:r>
               <a:rPr/>
               <a:t>Label: did it fail within thirty days?</a:t>
+            </a:r>
+          </a:p>
+          <a:p>
+            <a:pPr lvl="0"/>
+            <a:r>
+              <a:rPr>
+                <a:latin typeface="Courier"/>
+              </a:rPr>
+              <a:t>train_test_split(..., stratify=y)</a:t>
+            </a:r>
+            <a:r>
+              <a:rPr/>
+              <a:t>: 6,000 to train, 2,000 to test</a:t>
             </a:r>
           </a:p>
         </p:txBody>

</xml_diff>

<commit_message>
Rewrite lesson 4's speaker notes in full, and correct two handout figures
The likelihood that underflows is 0.5 to the 6,000th, about 10^-1806, at the
start of descent; the fitted model's 10^-180 is representable, and the
handout's 10^-1000 over 8,000 drives was neither. Four reallocated sectors
take a drive from 0.012% to 1.3%, about a hundredfold, not 130-fold from a
rounded 0.01%. worked_examples.py now recomputes all three. In the notes: the
precision-recall dots are 0.5, 0.3 and 0.05, not the table's rows; resampling
belongs in folds only once lesson 5 has them; clock references become slide
numbers; TPR, FPR, F-beta, specificity, calibration and softmax are glossed.

Co-Authored-By: Claude Opus 5.5 <noreply@anthropic.com>
</commit_message>
<xml_diff>
--- a/Lessons/04_classification_and_metrics/Slides/classification_and_metrics_slides.pptx
+++ b/Lessons/04_classification_and_metrics/Slides/classification_and_metrics_slides.pptx
@@ -586,7 +586,7 @@
             </a:pPr>
             <a:r>
               <a:rPr/>
-              <a:t>The one to watch for: choosing the penalty by looking at the test error. It is the natural thing to do because the test error is the number they were told to care about, and it is exactly the mistake lesson 1 named. Today’s lesson ends up in the same place from a different direction, when we choose a decision threshold. Lesson 5 gives them the machinery to do both honestly.</a:t>
+              <a:t>The one to watch for: choosing the penalty by looking at the test error. It is the natural thing to do because the test error is the number they were told to care about, and it is exactly the mistake lesson 1 named. Today’s lesson ends up in the same place from a different direction, on slide 43, when we choose a decision threshold by looking at the test set. Lesson 5 gives them the machinery to do both honestly.</a:t>
             </a:r>
           </a:p>
         </p:txBody>
@@ -696,7 +696,7 @@
             </a:pPr>
             <a:r>
               <a:rPr/>
-              <a:t>Then the last row, which is the one to pause on. seek_error_rate was generated with a coefficient of exactly zero: a real-looking counter with no connection to failure. The model estimates 0.02, an odds multiplier of 1.03. It did not fall for it.</a:t>
+              <a:t>Then the last row, which is the one to pause on. seek_error_rate was generated with a coefficient of exactly zero: a real-looking counter with no connection to failure. The model estimates 0.02, an odds multiplier of 1.03 (the table rounds the coefficient; the multiplier is computed from the unrounded value). It did not fall for it.</a:t>
             </a:r>
           </a:p>
           <a:p>
@@ -1040,7 +1040,7 @@
             </a:pPr>
             <a:r>
               <a:rPr/>
-              <a:t>Two practical notes worth saying aloud. We take the logarithm because it turns the product into a sum, which differentiates one term at a time - and because with 8,000 factors below 1 the product is about 10 to the minus 1000, which a 64-bit float stores as exactly zero. Every real implementation works in log space, and not for elegance.</a:t>
+              <a:t>Two practical notes worth saying aloud. We take the logarithm because it turns the product into a sum, which differentiates one term at a time - and because the product itself is too small to store. Gradient descent starts with every probability at 0.5, and 0.5 multiplied by itself 6,000 times, once per training drive, is about 10 to the minus 1806. The smallest number a 64-bit float holds is about 10 to the minus 308, so the computer stores exactly zero. Every real implementation works in log space, and not for elegance.</a:t>
             </a:r>
           </a:p>
           <a:p>
@@ -1398,7 +1398,7 @@
             </a:pPr>
             <a:r>
               <a:rPr/>
-              <a:t>Right panel is the real argument, so spend the time here. The gradient is what the optimiser actually uses. Squared error’s gradient through the sigmoid carries a factor p times one-minus-p - which is exactly the sigmoid derivative from ten minutes ago - and that factor goes to zero as p goes to zero.</a:t>
+              <a:t>Right panel is the real argument, so spend the time here. The gradient is what the optimiser actually uses. Squared error’s gradient through the sigmoid carries a factor p times one-minus-p - which is exactly the sigmoid derivative from slide 9 - and that factor goes to zero as p goes to zero.</a:t>
             </a:r>
           </a:p>
           <a:p>
@@ -1812,7 +1812,7 @@
             </a:pPr>
             <a:r>
               <a:rPr/>
-              <a:t>Ask: is that a bad model? Take answers. Then say: the probabilities are fine. The threshold is a habit. Telling those two apart is the next two hours.</a:t>
+              <a:t>Ask: is that a bad model? Take answers. Then say: the probabilities are fine. The threshold of 0.5 is a habit. Telling those two apart is the rest of the lesson.</a:t>
             </a:r>
           </a:p>
         </p:txBody>
@@ -2248,7 +2248,7 @@
             </a:pPr>
             <a:r>
               <a:rPr/>
-              <a:t>The general statement, worth putting on the board: with a positive rate pi, the trivial always-negative classifier scores 1 minus pi. Here 96.2%. In some fraud problems, where the rate is one in a thousand, 99.9%.</a:t>
+              <a:t>The general statement, worth putting on the board: if a share pi of the cases are positive (the positive rate), the trivial always-negative classifier scores 1 minus pi. Here 96.2%. In some fraud problems, where the rate is one in a thousand, 99.9%.</a:t>
             </a:r>
           </a:p>
           <a:p>
@@ -2578,7 +2578,7 @@
             </a:pPr>
             <a:r>
               <a:rPr/>
-              <a:t>This picture prevents the most common confusion of the lesson. Both metrics divide the true positives. The difference is entirely in what goes underneath, and the shading shows it.</a:t>
+              <a:t>This picture prevents the most common confusion of the lesson. Both metrics put the true positives - failed drives we flagged - on top of the fraction. The difference is entirely in what goes underneath, and the shading shows it.</a:t>
             </a:r>
           </a:p>
           <a:p>
@@ -2716,7 +2716,7 @@
             </a:pPr>
             <a:r>
               <a:rPr/>
-              <a:t>Specificity is recall for the negative class, and one minus it is the false positive rate, which comes back in the ROC section. Mention it now so the term is not new later.</a:t>
+              <a:t>Specificity is recall for the negative class: of the healthy drives, how many did we leave alone. One minus it is the false positive rate, which comes back in the receiver operating characteristic (ROC) section. Mention it now so the term is not new later.</a:t>
             </a:r>
           </a:p>
           <a:p>
@@ -2868,7 +2868,7 @@
             </a:pPr>
             <a:r>
               <a:rPr/>
-              <a:t>Mention F-beta in one sentence: beta above 1 weights recall more, which is what you want here where misses cost nineteen times more. F2 is the usual choice.</a:t>
+              <a:t>Mention F-beta in one sentence: a version of F1 with a weight beta, where beta above 1 counts recall more than precision. That is what you want here, where a miss costs about nineteen times a false alarm (2,600 against 140 euros). F2 is the usual choice.</a:t>
             </a:r>
           </a:p>
         </p:txBody>
@@ -3556,7 +3556,7 @@
             </a:pPr>
             <a:r>
               <a:rPr/>
-              <a:t>The part to teach is the baseline. A model with random scores has precision equal to the positive rate - 0.038 here - at every recall. That flat red line, not 0.5, is what “no skill” looks like on an imbalanced problem.</a:t>
+              <a:t>The part to teach is the baseline. A model with random scores has precision equal to the positive rate - 0.038 here - at every recall. That flat dashed line, not 0.5, is what “no skill” looks like on an imbalanced problem.</a:t>
             </a:r>
           </a:p>
           <a:p>
@@ -3584,7 +3584,7 @@
             </a:pPr>
             <a:r>
               <a:rPr/>
-              <a:t>The three marked dots are the same three thresholds from the last two slides, so they can see the correspondence.</a:t>
+              <a:t>The three marked dots are thresholds 0.5, 0.3 and 0.05. The first two are rows of the table on the previous slide, so they can check the correspondence: at 0.5, recall 0.566 and precision 0.768.</a:t>
             </a:r>
           </a:p>
         </p:txBody>
@@ -3790,7 +3790,7 @@
             </a:pPr>
             <a:r>
               <a:rPr/>
-              <a:t>The two axes: true positive rate, which is recall under another name - the failures we catch. False positive rate - the healthy drives we condemn.</a:t>
+              <a:t>The two axes: the true positive rate (TPR), which is recall under another name - the share of failures we catch. The false positive rate (FPR) - the share of healthy drives we condemn.</a:t>
             </a:r>
           </a:p>
           <a:p>
@@ -4052,21 +4052,21 @@
             </a:pPr>
             <a:r>
               <a:rPr/>
-              <a:t>The consequence: AUC says nothing about whether “0.7” means anything. If you need the probabilities to be believable - because you are computing expected costs, as we will in ten minutes - AUC is not the check you want.</a:t>
-            </a:r>
-          </a:p>
-          <a:p>
-            <a:pPr lvl="0" indent="0" marL="0">
-              <a:buNone/>
-            </a:pPr>
-          </a:p>
-          <a:p>
-            <a:pPr lvl="0" indent="0" marL="0">
-              <a:buNone/>
-            </a:pPr>
-            <a:r>
-              <a:rPr/>
-              <a:t>Good place to mention calibration exists as a topic, without going into it.</a:t>
+              <a:t>The consequence: AUC says nothing about whether “0.7” means anything. If you need the probabilities to be believable - because you are computing expected costs, as slide 41 does - AUC is not the check you want.</a:t>
+            </a:r>
+          </a:p>
+          <a:p>
+            <a:pPr lvl="0" indent="0" marL="0">
+              <a:buNone/>
+            </a:pPr>
+          </a:p>
+          <a:p>
+            <a:pPr lvl="0" indent="0" marL="0">
+              <a:buNone/>
+            </a:pPr>
+            <a:r>
+              <a:rPr/>
+              <a:t>Good place to mention that calibration - whether a predicted 0.7 really comes true 70% of the time - is a topic of its own, without going into it.</a:t>
             </a:r>
           </a:p>
         </p:txBody>
@@ -4162,21 +4162,21 @@
             </a:pPr>
             <a:r>
               <a:rPr/>
-              <a:t>Left: the three ROC curves sit on top of each other. AUC 0.968, 0.965, 0.974. It reports an excellent model throughout, and at the rarest setting a marginally better one, which is sampling noise on 231 positives.</a:t>
-            </a:r>
-          </a:p>
-          <a:p>
-            <a:pPr lvl="0" indent="0" marL="0">
-              <a:buNone/>
-            </a:pPr>
-          </a:p>
-          <a:p>
-            <a:pPr lvl="0" indent="0" marL="0">
-              <a:buNone/>
-            </a:pPr>
-            <a:r>
-              <a:rPr/>
-              <a:t>Right: the precision-recall curves are in three different worlds. Average precision falls from 0.706 to 0.361, and precision at the same threshold falls from 0.79 to 0.26 - two alarms in three now false.</a:t>
+              <a:t>Left panel: the three ROC curves sit on top of each other. AUC 0.968, 0.965, 0.974. It reports an excellent model throughout, and at the rarest setting a marginally better one, which is sampling noise on 231 positives.</a:t>
+            </a:r>
+          </a:p>
+          <a:p>
+            <a:pPr lvl="0" indent="0" marL="0">
+              <a:buNone/>
+            </a:pPr>
+          </a:p>
+          <a:p>
+            <a:pPr lvl="0" indent="0" marL="0">
+              <a:buNone/>
+            </a:pPr>
+            <a:r>
+              <a:rPr/>
+              <a:t>Right panel: the precision-recall curves are in three different worlds. Average precision falls from 0.706 to 0.361, and precision at the same threshold falls from 0.79 to 0.26 - two alarms in three now false.</a:t>
             </a:r>
           </a:p>
           <a:p>
@@ -4492,7 +4492,7 @@
             </a:pPr>
             <a:r>
               <a:rPr/>
-              <a:t>SMART is the diagnostic data a drive keeps about itself: reallocated sectors, spin retries, read error rate, temperature, hours in service. Expand the acronym on the slide and out loud - it is the kind of thing that gets skipped and then quietly blocks a student for the rest of the hour.</a:t>
+              <a:t>SMART is the diagnostic data a drive keeps about itself: reallocated sectors (bad patches of the disk the drive has had to replace), spin retries, read error rate, temperature, hours in service, and seek error rate. Expand the acronym on the slide and out loud - it is the kind of thing that gets skipped and then quietly blocks a student for the rest of the hour.</a:t>
             </a:r>
           </a:p>
           <a:p>
@@ -4602,7 +4602,7 @@
             </a:pPr>
             <a:r>
               <a:rPr/>
-              <a:t>Finally, the honest way to pick a threshold. It needs one ingredient no metric can supply: what the errors cost. We wrote those down an hour ago - €140 for a needless replacement, €2,600 for a drive that dies in service.</a:t>
+              <a:t>Finally, the honest way to pick a threshold. It needs one ingredient no metric can supply: what the errors cost. We wrote those down on slide 25 - €140 for a needless replacement, €2,600 for a drive that dies in service.</a:t>
             </a:r>
           </a:p>
           <a:p>
@@ -4850,7 +4850,7 @@
             </a:pPr>
             <a:r>
               <a:rPr/>
-              <a:t>Say this out loud rather than leaving it in the handout, because it is the same mistake you may have just named to them, this morning, on exercise 3.</a:t>
+              <a:t>Say this out loud rather than leaving it in the handout, because it is the same mistake you may have named at the start of today’s lesson, in the discussion of exercise 3.</a:t>
             </a:r>
           </a:p>
           <a:p>
@@ -4974,7 +4974,7 @@
             </a:pPr>
             <a:r>
               <a:rPr/>
-              <a:t>class_weight=“balanced” makes each rare example count as many, here about 25. It changes the training rather than the decision.</a:t>
+              <a:t>class_weight=“balanced” makes each failed drive count, in the cost, as much as about 25 healthy ones - the ratio of healthy to failed drives in the training set. It changes the training rather than the decision.</a:t>
             </a:r>
           </a:p>
           <a:p>
@@ -5030,7 +5030,7 @@
             </a:pPr>
             <a:r>
               <a:rPr/>
-              <a:t>Same caution for resampling and for SMOTE (synthetic minority oversampling technique, which builds artificial minority examples) - and it must happen inside the cross-validation fold, for the reasons lesson 2 gave about imputation.</a:t>
+              <a:t>The same reading holds for resampling and for SMOTE (synthetic minority oversampling technique, which builds artificial minority examples): they move the operating point too. And both must be applied to the training rows only - inside each cross-validation fold, once lesson 5 introduces folds - for the reasons lesson 2 gave about imputation.</a:t>
             </a:r>
           </a:p>
         </p:txBody>
@@ -5222,7 +5222,7 @@
             </a:pPr>
             <a:r>
               <a:rPr/>
-              <a:t>For K classes the model produces one score per class and normalises them - the softmax, which for two classes reduces exactly to the sigmoid. The cost generalises to categorical cross-entropy, and it is the same idea: the negative log of the probability assigned to what actually happened. Handout section 10.</a:t>
+              <a:t>For K classes the model produces one score per class and turns them into K probabilities that add up to 1 - the softmax, which for two classes reduces exactly to the sigmoid. The cost generalises to categorical cross-entropy, and it is the same idea: the negative log of the probability assigned to what actually happened. Handout section 10.</a:t>
             </a:r>
           </a:p>
           <a:p>
@@ -5704,7 +5704,7 @@
             </a:pPr>
             <a:r>
               <a:rPr/>
-              <a:t>Somebody will say “healthy, every time”. Agree, and move on. Do not explain the consequence yet - it lands far harder in section 5 when they see 96.2% printed as a model’s accuracy score.</a:t>
+              <a:t>Somebody will say “healthy, every time”. Agree, and move on. Do not explain the consequence yet - it lands far harder on slide 22, after the break, when they see 96.2% printed as a model’s accuracy score.</a:t>
             </a:r>
           </a:p>
         </p:txBody>
@@ -5924,21 +5924,21 @@
             </a:pPr>
             <a:r>
               <a:rPr/>
-              <a:t>Expect someone to object that the previous figure says otherwise. That curve is drawn against raw reallocated sectors, not against z, so it is steepest at 13.2 and the first four sectors move it by only 0.03. Both pictures are right: the counters act on a log scale, and on that scale four sectors are worth +4.7 in log-odds, taking a drive from a 0.01% chance of failing to 1.3%. Handout section 1.1.</a:t>
-            </a:r>
-          </a:p>
-          <a:p>
-            <a:pPr lvl="0" indent="0" marL="0">
-              <a:buNone/>
-            </a:pPr>
-          </a:p>
-          <a:p>
-            <a:pPr lvl="0" indent="0" marL="0">
-              <a:buNone/>
-            </a:pPr>
-            <a:r>
-              <a:rPr/>
-              <a:t>Right: the same relationship inverted. This is the slide that explains WHY this particular curve and not some other S-shape. A probability is trapped in [0,1]. The odds - p over 1 minus p - remove the ceiling. The log of the odds removes the floor too, leaving something that runs over all of the real line.</a:t>
+              <a:t>Expect someone to object that the previous figure says otherwise: there the curve is flat at the START, where drives have few reallocated sectors, not only at the ends. The answer is the horizontal axis. That curve is drawn against raw reallocated sectors, not against z, so it is steepest at 13.2 sectors and the first four sectors move it by only 0.03. Both pictures are right: the counters act on a log scale, and on that scale four sectors are worth +4.7 in log-odds, taking a drive from a 0.012% chance of failing to 1.3%, about a hundred times more. Handout section 1.1.</a:t>
+            </a:r>
+          </a:p>
+          <a:p>
+            <a:pPr lvl="0" indent="0" marL="0">
+              <a:buNone/>
+            </a:pPr>
+          </a:p>
+          <a:p>
+            <a:pPr lvl="0" indent="0" marL="0">
+              <a:buNone/>
+            </a:pPr>
+            <a:r>
+              <a:rPr/>
+              <a:t>Right panel: the same relationship inverted. This is the slide that explains WHY this particular curve and not some other S-shape. A probability is trapped in [0,1]. The odds - p over 1 minus p - remove the ceiling. The log of the odds removes the floor too, leaving something that runs over all of the real line.</a:t>
             </a:r>
           </a:p>
           <a:p>
@@ -6062,7 +6062,7 @@
             </a:pPr>
             <a:r>
               <a:rPr/>
-              <a:t>That last one is the one to flag. It is largest in the middle, one quarter, and it decays to zero at both ends. In fifteen minutes that fact will be simultaneously the reason the sigmoid works and the reason squared error does not.</a:t>
+              <a:t>That last one is the one to flag. It is largest in the middle, one quarter, and it decays to zero at both ends. On slide 17 that fact will be simultaneously the reason the sigmoid works and the reason squared error does not.</a:t>
             </a:r>
           </a:p>
         </p:txBody>

</xml_diff>

<commit_message>
Give lesson 4's notebook 3 its own fifteen minutes in the plan
The last ten minutes carried slides 41 to 49 and notebook 3 together. Twenty
minutes come from the lecture segments before it (logistic regression, the
accuracy trap, precision and recall, ROC), and the multiclass slides now run
alongside the notebook's last section.

Co-Authored-By: Claude Opus 5.5 <noreply@anthropic.com>
</commit_message>
<xml_diff>
--- a/Lessons/04_classification_and_metrics/Slides/classification_and_metrics_slides.pptx
+++ b/Lessons/04_classification_and_metrics/Slides/classification_and_metrics_slides.pptx
@@ -2978,7 +2978,7 @@
             </a:pPr>
             <a:r>
               <a:rPr/>
-              <a:t>The weighted average weights each class by how common it is, so on this problem it is essentially the healthy class talking, and it reads close to accuracy - inheriting exactly the blindness we spent twenty minutes on.</a:t>
+              <a:t>The weighted average weights each class by how common it is, so on this problem it is essentially the healthy class talking, and it reads close to accuracy - inheriting exactly the blindness slides 22 to 25 were about.</a:t>
             </a:r>
           </a:p>
           <a:p>
@@ -5112,7 +5112,7 @@
             </a:pPr>
             <a:r>
               <a:rPr/>
-              <a:t>The ROC curve by hand, the 200,000-pair experiment, the cost curve, then the multiclass matrix. Run notebook 03. Twenty minutes if the clock allows, otherwise show the pairs experiment and the imbalance comparison and leave the rest for them.</a:t>
+              <a:t>The ROC curve by hand, the 200,000-pair experiment, the cost curve, then the multiclass matrix. Run notebook 03. Fifteen minutes, and the two multiclass slides that follow (46 and 47) are shown when the notebook reaches its last section, so they run alongside it rather than after it.</a:t>
             </a:r>
           </a:p>
           <a:p>

</xml_diff>

<commit_message>
Show P(y = 1 | x) bounded by 0 and 1 on lesson 4's slide 4
The slide now states what the classifier outputs before the sigmoid
appears, with y and x defined beside it. render_math learns \mid so the
formula stays inline text rather than becoming an image.

Co-Authored-By: Claude Opus 5.5 <noreply@anthropic.com>
Claude-Session: https://claude.ai/code/session_01Ckqp6tN5J2gSYBTAaXAy9d
</commit_message>
<xml_diff>
--- a/Lessons/04_classification_and_metrics/Slides/classification_and_metrics_slides.pptx
+++ b/Lessons/04_classification_and_metrics/Slides/classification_and_metrics_slides.pptx
@@ -3192,6 +3192,20 @@
         <p:txBody>
           <a:bodyPr/>
           <a:lstStyle/>
+          <a:p>
+            <a:pPr lvl="0" indent="0" marL="0">
+              <a:buNone/>
+            </a:pPr>
+            <a:r>
+              <a:rPr/>
+              <a:t>Read the third bullet aloud: “the probability that y equals 1, given x”. The vertical bar is read “given”: everything to its right is what we know about the drive, everything to its left is what we want to know. The two inequalities are the point of writing it this way - whatever the model outputs has to stay between 0 and 1, and slide 7 shows a straight line failing exactly that.</a:t>
+            </a:r>
+          </a:p>
+          <a:p>
+            <a:pPr lvl="0" indent="0" marL="0">
+              <a:buNone/>
+            </a:pPr>
+          </a:p>
           <a:p>
             <a:pPr lvl="0" indent="0" marL="0">
               <a:buNone/>
@@ -14275,6 +14289,20 @@
             <a:r>
               <a:rPr b="1"/>
               <a:t>will it fail?</a:t>
+            </a:r>
+          </a:p>
+          <a:p>
+            <a:pPr lvl="0"/>
+            <a:r>
+              <a:rPr/>
+              <a:t>Answer with a probability: 0 ≤ P(y = 1 | x) ≤ 1</a:t>
+            </a:r>
+          </a:p>
+          <a:p>
+            <a:pPr lvl="0"/>
+            <a:r>
+              <a:rPr/>
+              <a:t>y = 1 if the drive failed, y = 0 if not; x holds its six counters</a:t>
             </a:r>
           </a:p>
         </p:txBody>

</xml_diff>

<commit_message>
Show maximum likelihood on three drives, on slide 16 and in section 3.1
Slide 16 said only "turn the knob so that what happened is least
surprising". It is now a table: three drives, two settings of w and b,
each P(fail) turned into the probability of what actually happened and
multiplied, 0.576 against 0.060. The notes walk through it and bridge to
the cost: minus the log, 0.55 against 2.81, is the surprise, and its
average is slide 17's log loss.

Handout section 3.1 carries the same example; worked_examples.py
recomputes the products, the summed surprises both ways and the 9.6
ratio from the P(fail) values (68 to 75 checks).

Co-Authored-By: Claude Opus 5.5 <noreply@anthropic.com>
Claude-Session: https://claude.ai/code/session_01Ckqp6tN5J2gSYBTAaXAy9d
</commit_message>
<xml_diff>
--- a/Lessons/04_classification_and_metrics/Slides/classification_and_metrics_slides.pptx
+++ b/Lessons/04_classification_and_metrics/Slides/classification_and_metrics_slides.pptx
@@ -1262,49 +1262,91 @@
             </a:pPr>
             <a:r>
               <a:rPr/>
-              <a:t>Say this before any algebra. It is the whole idea, and once they have it the derivation is bookkeeping.</a:t>
-            </a:r>
-          </a:p>
-          <a:p>
-            <a:pPr lvl="0" indent="0" marL="0">
-              <a:buNone/>
-            </a:pPr>
-          </a:p>
-          <a:p>
-            <a:pPr lvl="0" indent="0" marL="0">
-              <a:buNone/>
-            </a:pPr>
-            <a:r>
-              <a:rPr/>
-              <a:t>Each drive contributes one factor: the probability the model gave to what actually occurred. Multiply across the fleet and you have the probability of the whole dataset under that setting of the parameters. Choose the setting that makes it largest.</a:t>
-            </a:r>
-          </a:p>
-          <a:p>
-            <a:pPr lvl="0" indent="0" marL="0">
-              <a:buNone/>
-            </a:pPr>
-          </a:p>
-          <a:p>
-            <a:pPr lvl="0" indent="0" marL="0">
-              <a:buNone/>
-            </a:pPr>
-            <a:r>
-              <a:rPr/>
-              <a:t>Two practical notes worth saying aloud. We take the logarithm because it turns the product into a sum, which differentiates one term at a time - and because the product itself is too small to store. Gradient descent starts with all weights at zero, so z is 0 for every drive and every probability is 0.5; 0.5 multiplied by itself 6,000 times, once per training drive, is about 10 to the minus 1806. The smallest number a 64-bit float holds is about 10 to the minus 308, so the computer stores exactly zero. Every real implementation therefore adds up the logarithms of the probabilities instead of multiplying the probabilities, and not for elegance.</a:t>
-            </a:r>
-          </a:p>
-          <a:p>
-            <a:pPr lvl="0" indent="0" marL="0">
-              <a:buNone/>
-            </a:pPr>
-          </a:p>
-          <a:p>
-            <a:pPr lvl="0" indent="0" marL="0">
-              <a:buNone/>
-            </a:pPr>
-            <a:r>
-              <a:rPr/>
-              <a:t>Then negate, so we minimise as in lesson 3.</a:t>
+              <a:t>This is the whole idea of how logistic regression is fitted, so say it before any algebra, and say it on these three drives. The numbers are made up for the example; the three drives are not from the dataset.</a:t>
+            </a:r>
+          </a:p>
+          <a:p>
+            <a:pPr lvl="0" indent="0" marL="0">
+              <a:buNone/>
+            </a:pPr>
+          </a:p>
+          <a:p>
+            <a:pPr lvl="0" indent="0" marL="0">
+              <a:buNone/>
+            </a:pPr>
+            <a:r>
+              <a:rPr/>
+              <a:t>A “setting” is one choice of the coefficients w and the intercept b. Plug a drive’s counters into the model of slide 11 and the setting gives that drive a probability of failing, P(fail). Two settings, two columns.</a:t>
+            </a:r>
+          </a:p>
+          <a:p>
+            <a:pPr lvl="0" indent="0" marL="0">
+              <a:buNone/>
+            </a:pPr>
+          </a:p>
+          <a:p>
+            <a:pPr lvl="0" indent="0" marL="0">
+              <a:buNone/>
+            </a:pPr>
+            <a:r>
+              <a:rPr/>
+              <a:t>Now score each setting against what actually happened. Drive A failed, so the relevant number is the probability the setting gave to failing: 0.8 under setting 1, 0.3 under setting 2. Drives B and C stayed healthy, so the relevant number is the probability of staying healthy, 1 minus P(fail): under setting 1, 0.9 and 0.8; under setting 2, 0.4 and 0.5. That is what each arrow in the table does - it turns P(fail) into the probability of the outcome that really occurred.</a:t>
+            </a:r>
+          </a:p>
+          <a:p>
+            <a:pPr lvl="0" indent="0" marL="0">
+              <a:buNone/>
+            </a:pPr>
+          </a:p>
+          <a:p>
+            <a:pPr lvl="0" indent="0" marL="0">
+              <a:buNone/>
+            </a:pPr>
+            <a:r>
+              <a:rPr/>
+              <a:t>Multiply down each column, treating the drives as independent. The product is the probability that setting assigns to the whole dataset, exactly as it was observed: 0.576 for setting 1, 0.060 for setting 2. That product is called the likelihood. What actually happened is about ten times more probable under setting 1 (9.6 times), so setting 1 is the better explanation of the data.</a:t>
+            </a:r>
+          </a:p>
+          <a:p>
+            <a:pPr lvl="0" indent="0" marL="0">
+              <a:buNone/>
+            </a:pPr>
+          </a:p>
+          <a:p>
+            <a:pPr lvl="0" indent="0" marL="0">
+              <a:buNone/>
+            </a:pPr>
+            <a:r>
+              <a:rPr/>
+              <a:t>Maximum likelihood is this comparison, done over every possible setting rather than two: choose the w and b that make the likelihood as large as possible. Gradient descent does the searching, as in lesson 3.</a:t>
+            </a:r>
+          </a:p>
+          <a:p>
+            <a:pPr lvl="0" indent="0" marL="0">
+              <a:buNone/>
+            </a:pPr>
+          </a:p>
+          <a:p>
+            <a:pPr lvl="0" indent="0" marL="0">
+              <a:buNone/>
+            </a:pPr>
+            <a:r>
+              <a:rPr/>
+              <a:t>Why the products are never used as they are, and the bridge to the next slide. Take minus the logarithm of each factor and add, instead of multiplying: 0.55 for setting 1, 2.81 for setting 2. That is minus the log of the likelihood, so the order is the same, reversed - the better setting now has the SMALLER number, which gives us something to minimise, as in lesson 3. Minus the log of a probability is called the surprise: 0 for something you were certain of, large for something you said was unlikely. “Most likely” and “least surprising” are the same choice. Averaged over the drives instead of summed, it is the cost on the next slide.</a:t>
+            </a:r>
+          </a:p>
+          <a:p>
+            <a:pPr lvl="0" indent="0" marL="0">
+              <a:buNone/>
+            </a:pPr>
+          </a:p>
+          <a:p>
+            <a:pPr lvl="0" indent="0" marL="0">
+              <a:buNone/>
+            </a:pPr>
+            <a:r>
+              <a:rPr/>
+              <a:t>Two reasons for the logarithm, worth saying aloud. It turns the product into a sum, which differentiates one term at a time. And the product itself is too small to store. Gradient descent starts with all weights at zero, so z is 0 for every drive and every probability is 0.5; 0.5 multiplied by itself 6,000 times, once per training drive, is about 10 to the minus 1806. The smallest number a 64-bit float holds is about 10 to the minus 308, so the computer stores exactly zero. Every real implementation therefore adds up the logarithms of the probabilities instead of multiplying the probabilities, and not for elegance. Handout sections 3.1 to 3.3.</a:t>
             </a:r>
           </a:p>
         </p:txBody>
@@ -10805,46 +10847,343 @@
             </a:pPr>
             <a:r>
               <a:rPr/>
-              <a:t>Maximum likelihood, in one sentence</a:t>
-            </a:r>
-          </a:p>
-        </p:txBody>
-      </p:sp>
-      <p:sp>
-        <p:nvSpPr>
-          <p:cNvPr id="3" name="Content Placeholder 2"/>
-          <p:cNvSpPr>
-            <a:spLocks noGrp="1"/>
-          </p:cNvSpPr>
+              <a:t>Maximum likelihood, on three drives</a:t>
+            </a:r>
+          </a:p>
+        </p:txBody>
+      </p:sp>
+      <p:graphicFrame>
+        <p:nvGraphicFramePr>
+          <p:cNvPr id="6" name="Content Placeholder 5"/>
+          <p:cNvGraphicFramePr>
+            <a:graphicFrameLocks noGrp="1"/>
+          </p:cNvGraphicFramePr>
           <p:nvPr>
             <p:ph idx="1"/>
           </p:nvPr>
-        </p:nvSpPr>
-        <p:spPr>
-          <a:xfrm>
-            <a:off x="457200" y="1200151"/>
-            <a:ext cx="8229600" cy="3394472"/>
-          </a:xfrm>
-        </p:spPr>
-        <p:txBody>
-          <a:bodyPr/>
-          <a:lstStyle/>
-          <a:p>
-            <a:pPr lvl="0"/>
-            <a:r>
-              <a:rPr/>
-              <a:t>The parameters w and b are a knob: each setting gives a probability to what actually happened</a:t>
-            </a:r>
-          </a:p>
-          <a:p>
-            <a:pPr lvl="0"/>
-            <a:r>
-              <a:rPr b="1"/>
-              <a:t>Turn the knob so that what actually happened is least surprising</a:t>
-            </a:r>
-          </a:p>
-        </p:txBody>
-      </p:sp>
+        </p:nvGraphicFramePr>
+        <p:xfrm>
+          <a:off x="457200" y="1166099"/>
+          <a:ext cx="8229600" cy="3390900"/>
+        </p:xfrm>
+        <a:graphic>
+          <a:graphicData uri="http://schemas.openxmlformats.org/drawingml/2006/table">
+            <a:tbl>
+              <a:tblPr firstRow="1" bandRow="1">
+                <a:tableStyleId>{5C22544A-7EE6-4342-B048-85BDC9FD1C3A}</a:tableStyleId>
+              </a:tblPr>
+              <a:tblGrid>
+                <a:gridCol w="2743200"/>
+                <a:gridCol w="2743200"/>
+                <a:gridCol w="2743200"/>
+              </a:tblGrid>
+              <a:tr h="0">
+                <a:tc>
+                  <a:txBody>
+                    <a:bodyPr/>
+                    <a:lstStyle/>
+                    <a:p>
+                      <a:pPr lvl="0" indent="0" marL="0">
+                        <a:buNone/>
+                      </a:pPr>
+                      <a:r>
+                        <a:rPr/>
+                        <a:t>Drive, what happened</a:t>
+                      </a:r>
+                    </a:p>
+                  </a:txBody>
+                  <a:tcPr/>
+                </a:tc>
+                <a:tc>
+                  <a:txBody>
+                    <a:bodyPr/>
+                    <a:lstStyle/>
+                    <a:p>
+                      <a:pPr lvl="0" indent="0" marL="0">
+                        <a:buNone/>
+                      </a:pPr>
+                      <a:r>
+                        <a:rPr/>
+                        <a:t>Setting 1 of w, b: P(fail) → P(what happened)</a:t>
+                      </a:r>
+                    </a:p>
+                  </a:txBody>
+                  <a:tcPr/>
+                </a:tc>
+                <a:tc>
+                  <a:txBody>
+                    <a:bodyPr/>
+                    <a:lstStyle/>
+                    <a:p>
+                      <a:pPr lvl="0" indent="0" marL="0">
+                        <a:buNone/>
+                      </a:pPr>
+                      <a:r>
+                        <a:rPr/>
+                        <a:t>Setting 2 of w, b: P(fail) → P(what happened)</a:t>
+                      </a:r>
+                    </a:p>
+                  </a:txBody>
+                  <a:tcPr/>
+                </a:tc>
+              </a:tr>
+              <a:tr h="0">
+                <a:tc>
+                  <a:txBody>
+                    <a:bodyPr/>
+                    <a:lstStyle/>
+                    <a:p>
+                      <a:pPr lvl="0" indent="0" marL="0">
+                        <a:buNone/>
+                      </a:pPr>
+                      <a:r>
+                        <a:rPr/>
+                        <a:t>A, failed</a:t>
+                      </a:r>
+                    </a:p>
+                  </a:txBody>
+                </a:tc>
+                <a:tc>
+                  <a:txBody>
+                    <a:bodyPr/>
+                    <a:lstStyle/>
+                    <a:p>
+                      <a:pPr lvl="0" indent="0" marL="0">
+                        <a:buNone/>
+                      </a:pPr>
+                      <a:r>
+                        <a:rPr/>
+                        <a:t>0.8 → </a:t>
+                      </a:r>
+                      <a:r>
+                        <a:rPr b="1"/>
+                        <a:t>0.8</a:t>
+                      </a:r>
+                    </a:p>
+                  </a:txBody>
+                </a:tc>
+                <a:tc>
+                  <a:txBody>
+                    <a:bodyPr/>
+                    <a:lstStyle/>
+                    <a:p>
+                      <a:pPr lvl="0" indent="0" marL="0">
+                        <a:buNone/>
+                      </a:pPr>
+                      <a:r>
+                        <a:rPr/>
+                        <a:t>0.3 → </a:t>
+                      </a:r>
+                      <a:r>
+                        <a:rPr b="1"/>
+                        <a:t>0.3</a:t>
+                      </a:r>
+                    </a:p>
+                  </a:txBody>
+                </a:tc>
+              </a:tr>
+              <a:tr h="0">
+                <a:tc>
+                  <a:txBody>
+                    <a:bodyPr/>
+                    <a:lstStyle/>
+                    <a:p>
+                      <a:pPr lvl="0" indent="0" marL="0">
+                        <a:buNone/>
+                      </a:pPr>
+                      <a:r>
+                        <a:rPr/>
+                        <a:t>B, healthy</a:t>
+                      </a:r>
+                    </a:p>
+                  </a:txBody>
+                </a:tc>
+                <a:tc>
+                  <a:txBody>
+                    <a:bodyPr/>
+                    <a:lstStyle/>
+                    <a:p>
+                      <a:pPr lvl="0" indent="0" marL="0">
+                        <a:buNone/>
+                      </a:pPr>
+                      <a:r>
+                        <a:rPr/>
+                        <a:t>0.1 → </a:t>
+                      </a:r>
+                      <a:r>
+                        <a:rPr b="1"/>
+                        <a:t>0.9</a:t>
+                      </a:r>
+                    </a:p>
+                  </a:txBody>
+                </a:tc>
+                <a:tc>
+                  <a:txBody>
+                    <a:bodyPr/>
+                    <a:lstStyle/>
+                    <a:p>
+                      <a:pPr lvl="0" indent="0" marL="0">
+                        <a:buNone/>
+                      </a:pPr>
+                      <a:r>
+                        <a:rPr/>
+                        <a:t>0.6 → </a:t>
+                      </a:r>
+                      <a:r>
+                        <a:rPr b="1"/>
+                        <a:t>0.4</a:t>
+                      </a:r>
+                    </a:p>
+                  </a:txBody>
+                </a:tc>
+              </a:tr>
+              <a:tr h="0">
+                <a:tc>
+                  <a:txBody>
+                    <a:bodyPr/>
+                    <a:lstStyle/>
+                    <a:p>
+                      <a:pPr lvl="0" indent="0" marL="0">
+                        <a:buNone/>
+                      </a:pPr>
+                      <a:r>
+                        <a:rPr/>
+                        <a:t>C, healthy</a:t>
+                      </a:r>
+                    </a:p>
+                  </a:txBody>
+                </a:tc>
+                <a:tc>
+                  <a:txBody>
+                    <a:bodyPr/>
+                    <a:lstStyle/>
+                    <a:p>
+                      <a:pPr lvl="0" indent="0" marL="0">
+                        <a:buNone/>
+                      </a:pPr>
+                      <a:r>
+                        <a:rPr/>
+                        <a:t>0.2 → </a:t>
+                      </a:r>
+                      <a:r>
+                        <a:rPr b="1"/>
+                        <a:t>0.8</a:t>
+                      </a:r>
+                    </a:p>
+                  </a:txBody>
+                </a:tc>
+                <a:tc>
+                  <a:txBody>
+                    <a:bodyPr/>
+                    <a:lstStyle/>
+                    <a:p>
+                      <a:pPr lvl="0" indent="0" marL="0">
+                        <a:buNone/>
+                      </a:pPr>
+                      <a:r>
+                        <a:rPr/>
+                        <a:t>0.5 → </a:t>
+                      </a:r>
+                      <a:r>
+                        <a:rPr b="1"/>
+                        <a:t>0.5</a:t>
+                      </a:r>
+                    </a:p>
+                  </a:txBody>
+                </a:tc>
+              </a:tr>
+              <a:tr h="0">
+                <a:tc>
+                  <a:txBody>
+                    <a:bodyPr/>
+                    <a:lstStyle/>
+                    <a:p>
+                      <a:pPr lvl="0" indent="0" marL="0">
+                        <a:buNone/>
+                      </a:pPr>
+                      <a:r>
+                        <a:rPr/>
+                        <a:t>Multiplied: the likelihood</a:t>
+                      </a:r>
+                    </a:p>
+                  </a:txBody>
+                </a:tc>
+                <a:tc>
+                  <a:txBody>
+                    <a:bodyPr/>
+                    <a:lstStyle/>
+                    <a:p>
+                      <a:pPr lvl="0" indent="0" marL="0">
+                        <a:buNone/>
+                      </a:pPr>
+                      <a:r>
+                        <a:rPr b="1"/>
+                        <a:t>0.576</a:t>
+                      </a:r>
+                    </a:p>
+                  </a:txBody>
+                </a:tc>
+                <a:tc>
+                  <a:txBody>
+                    <a:bodyPr/>
+                    <a:lstStyle/>
+                    <a:p>
+                      <a:pPr lvl="0" indent="0" marL="0">
+                        <a:buNone/>
+                      </a:pPr>
+                      <a:r>
+                        <a:rPr b="1"/>
+                        <a:t>0.060</a:t>
+                      </a:r>
+                    </a:p>
+                  </a:txBody>
+                </a:tc>
+              </a:tr>
+              <a:tr h="0">
+                <a:tc>
+                  <a:txBody>
+                    <a:bodyPr/>
+                    <a:lstStyle/>
+                    <a:p>
+                      <a:pPr lvl="0" indent="0" marL="0">
+                        <a:buNone/>
+                      </a:pPr>
+                      <a:r>
+                        <a:rPr/>
+                        <a:t>Maximum likelihood keeps</a:t>
+                      </a:r>
+                    </a:p>
+                  </a:txBody>
+                </a:tc>
+                <a:tc>
+                  <a:txBody>
+                    <a:bodyPr/>
+                    <a:lstStyle/>
+                    <a:p>
+                      <a:pPr lvl="0" indent="0" marL="0">
+                        <a:buNone/>
+                      </a:pPr>
+                      <a:r>
+                        <a:rPr b="1"/>
+                        <a:t>setting 1</a:t>
+                      </a:r>
+                    </a:p>
+                  </a:txBody>
+                </a:tc>
+                <a:tc>
+                  <a:txBody>
+                    <a:bodyPr/>
+                    <a:lstStyle/>
+                    <a:p>
+                      <a:endParaRPr/>
+                    </a:p>
+                  </a:txBody>
+                </a:tc>
+              </a:tr>
+            </a:tbl>
+          </a:graphicData>
+        </a:graphic>
+      </p:graphicFrame>
     </p:spTree>
   </p:cSld>
 </p:sld>

</xml_diff>

<commit_message>
Reread lesson 4's notes on slides 15 to 22 after the likelihood rebuild
Slide 21's notes still said not to derive the loss and spoke of bullets on
the slide before; slide 15 now points to slide 23 for the answer; slide 20
names the average cost J rather than calling it log loss beside slide 21's L.
The smallest 64-bit float is 5e-324, not 1e-308: fixed in the notes and in
handout section 3.3, and both limits are now read off the machine in
worked_examples.py.

Co-Authored-By: Claude Opus 5.5 <noreply@anthropic.com>
</commit_message>
<xml_diff>
--- a/Lessons/04_classification_and_metrics/Slides/classification_and_metrics_slides.pptx
+++ b/Lessons/04_classification_and_metrics/Slides/classification_and_metrics_slides.pptx
@@ -1184,7 +1184,7 @@
             </a:pPr>
             <a:r>
               <a:rPr/>
-              <a:t>Squared error on the sigmoid IS differentiable, and it does produce a working model on easy problems. The reason to reject it is subtler and more interesting, which is what makes it worth ten minutes.</a:t>
+              <a:t>Squared error on the sigmoid IS differentiable, and it does produce a working model on easy problems. The reason to reject it is subtler, so do not give it yet. Slides 16 to 20 first build, on three drives, the cost that logistic regression does minimise; slide 23 then comes back to squared error and shows what goes wrong with it, on a drive the model is confidently wrong about.</a:t>
             </a:r>
           </a:p>
         </p:txBody>
@@ -1804,21 +1804,21 @@
             </a:pPr>
             <a:r>
               <a:rPr/>
-              <a:t>Two reasons we always work with the logarithm, worth saying aloud. A sum differentiates one term at a time. And the product itself is too small to store: gradient descent starts with all weights at zero, so z is 0 for every drive and every p is 0.5; 0.5 multiplied by itself 6,000 times, once per training drive, is about 10 to the minus 1806, while the smallest number a 64-bit float holds is about 10 to the minus 308. The computer would store exactly zero.</a:t>
-            </a:r>
-          </a:p>
-          <a:p>
-            <a:pPr lvl="0" indent="0" marL="0">
-              <a:buNone/>
-            </a:pPr>
-          </a:p>
-          <a:p>
-            <a:pPr lvl="0" indent="0" marL="0">
-              <a:buNone/>
-            </a:pPr>
-            <a:r>
-              <a:rPr/>
-              <a:t>Divide the sum by the number of drives and you have the average surprise: that is the log loss, and the next slide writes it as a formula. Handout sections 3.1 to 3.3.</a:t>
+              <a:t>Two reasons we always work with the logarithm, worth saying aloud. A sum differentiates one term at a time. And the product itself is too small to store. Notebook 1’s gradient descent starts with every coefficient and the intercept at zero, so z is 0 for every drive and every p is 0.5. 0.5 multiplied by itself 6,000 times, once per training drive, is about 10 to the minus 1806, while the smallest positive number a 64-bit float can hold is about 5 times 10 to the minus 324. The computer would store exactly zero.</a:t>
+            </a:r>
+          </a:p>
+          <a:p>
+            <a:pPr lvl="0" indent="0" marL="0">
+              <a:buNone/>
+            </a:pPr>
+          </a:p>
+          <a:p>
+            <a:pPr lvl="0" indent="0" marL="0">
+              <a:buNone/>
+            </a:pPr>
+            <a:r>
+              <a:rPr/>
+              <a:t>Divide the sum by the number of drives and you have the average surprise: that is the cost J that fitting minimises, and scikit-learn’s log_loss computes exactly this average. The next slide writes the surprise of one drive as a formula, the loss L; J is its average over the drives. Handout sections 3.1 to 3.3.</a:t>
             </a:r>
           </a:p>
         </p:txBody>
@@ -2010,21 +2010,21 @@
             </a:pPr>
             <a:r>
               <a:rPr/>
-              <a:t>This is the loss on ONE example, L, not the cost over the training set; p is the predicted probability, the same number the next slide writes as y-hat. Say the other half aloud rather than showing it: the cost J is the average of this over the m examples, one over m times the sum. Written out in full the formula reached the slide edge and came out at 26pt, smaller than the bullets on the slide before it.</a:t>
-            </a:r>
-          </a:p>
-          <a:p>
-            <a:pPr lvl="0" indent="0" marL="0">
-              <a:buNone/>
-            </a:pPr>
-          </a:p>
-          <a:p>
-            <a:pPr lvl="0" indent="0" marL="0">
-              <a:buNone/>
-            </a:pPr>
-            <a:r>
-              <a:rPr/>
-              <a:t>Do not derive it here - the handout, section 3, does it in full. Show it and read it.</a:t>
+              <a:t>This is the loss on ONE example, L, not the cost over the training set; p is the predicted probability, the same number the next slide writes as y-hat. Say the other half aloud rather than showing it: the cost J is the average of this over the m examples, one over m times the sum. It is left off the slide because, written out in full, the formula does not fit at a readable size.</a:t>
+            </a:r>
+          </a:p>
+          <a:p>
+            <a:pPr lvl="0" indent="0" marL="0">
+              <a:buNone/>
+            </a:pPr>
+          </a:p>
+          <a:p>
+            <a:pPr lvl="0" indent="0" marL="0">
+              <a:buNone/>
+            </a:pPr>
+            <a:r>
+              <a:rPr/>
+              <a:t>Nothing new to derive: this is slides 16 to 20 written for one drive in symbols. Check it on drive B of slide 16: y = 0 and p = 0.1, so the first term vanishes and L = -log(1 - 0.1) = -log 0.9 = 0.11, the number slide 20 gave B under setting 1. The handout, section 3, does it for m drives in full.</a:t>
             </a:r>
           </a:p>
           <a:p>

</xml_diff>

<commit_message>
Reread all 55 of lesson 4's notes a third time
Say "calibrated" with its meaning instead of "trustworthy", and replace
"every alarm it drops was a possible false positive" with the count it
hides (22 alarms dropped from 0.30 to 0.50: 12 false, 10 caught
failures), in the notes, handout, notebook 2 and quiz. Slide 26 and
notebook 1 now say the drawn model uses two counters; slide 54 no longer
claims every metric needs a threshold; slide 44 explains the average
precision gap as well as the AUC one.

Co-Authored-By: Claude Opus 5.5 <noreply@anthropic.com>
</commit_message>
<xml_diff>
--- a/Lessons/04_classification_and_metrics/Slides/classification_and_metrics_slides.pptx
+++ b/Lessons/04_classification_and_metrics/Slides/classification_and_metrics_slides.pptx
@@ -2466,7 +2466,7 @@
             </a:pPr>
             <a:r>
               <a:rPr/>
-              <a:t>Now the caution that catches people, and it is worth ten seconds because they will hit it in the notebook. Convex does NOT mean there is a closed-form solution. Setting the gradient to zero gives X-transpose times sigma of Xw minus y equals zero, which is not linear in w - the sigmoid is in the way.</a:t>
+              <a:t>Now the caution that catches people, and it is worth ten seconds because they will see max_iter set in notebook 1 and wonder why. Convex does NOT mean there is a closed-form solution. Setting the gradient to zero gives X-transpose times the vector of errors, sigma(Xw + b) minus y, equal to zero. That equation is not linear in w - the sigmoid is in the way - so it cannot be solved in one step as lesson 3’s normal equation was.</a:t>
             </a:r>
           </a:p>
           <a:p>
@@ -2728,7 +2728,7 @@
             </a:pPr>
             <a:r>
               <a:rPr/>
-              <a:t>Second observation, and this is the bridge to the rest of the lesson: almost every gold point - every drive that actually failed - is on the blue side of the line. At a threshold of 0.5 this model calls nearly the whole fleet healthy, including most of the drives that failed.</a:t>
+              <a:t>Second observation, and this is the bridge to the rest of the lesson: most of the gold points - the drives that actually failed - are on the blue side of the line. At a threshold of 0.5 this two-feature model calls nearly the whole fleet healthy, including most of the drives that failed. It uses two counters only, so that it can be drawn; the six-counter model of slide 28 does better at the same 0.5, and still misses 33 of the 76 test failures.</a:t>
             </a:r>
           </a:p>
           <a:p>
@@ -2958,7 +2958,7 @@
             </a:pPr>
             <a:r>
               <a:rPr/>
-              <a:t>This is the 306 from the first ten minutes, coming back as an accuracy score.</a:t>
+              <a:t>This is the 306 of slide 6 coming back as an accuracy score: 96.20% is simply the share of test drives that are healthy.</a:t>
             </a:r>
           </a:p>
         </p:txBody>
@@ -4060,7 +4060,7 @@
             </a:pPr>
             <a:r>
               <a:rPr/>
-              <a:t>Spend time on the threshold sweep table. Do not explain it first - let them read the columns and say what they see. Somebody will notice that accuracy barely moves. That is the moment to make the next slide.</a:t>
+              <a:t>Spend time on the threshold sweep table. Do not explain it first - let them read the columns and say what they see. Somebody will notice that accuracy barely moves. That is the moment to show the next slide.</a:t>
             </a:r>
           </a:p>
         </p:txBody>
@@ -4156,7 +4156,7 @@
             </a:pPr>
             <a:r>
               <a:rPr/>
-              <a:t>That 0.5 is predict()’s default and nothing more. It is the right choice only when the two errors cost the same and the probabilities are trustworthy - slide 48 derives the threshold from the costs, and it is 0.5 exactly when they are equal. Here a miss costs about nineteen times a false alarm, and in most real problems the costs differ too.</a:t>
+              <a:t>That 0.5 is predict()’s default and nothing more. It is the right choice only when the two errors cost the same and the probabilities are calibrated: among drives given 0.3, about 30% really fail (slide 43 names the property). Slide 48 derives the threshold from the costs, and it is 0.5 exactly when they are equal. Here a miss costs about nineteen times a false alarm, and in most real problems the costs differ too.</a:t>
             </a:r>
           </a:p>
           <a:p>
@@ -4294,7 +4294,7 @@
             </a:pPr>
             <a:r>
               <a:rPr/>
-              <a:t>Say the consequence plainly: tune on accuracy and it will quietly recommend catching fewer failures, because every alarm it drops was a possible false positive.</a:t>
+              <a:t>Say the consequence plainly: tune on accuracy and it will quietly recommend catching fewer failures. Most of the alarms a higher threshold drops are false ones, so accuracy rises with each drop, even though some of the dropped alarms were failures being caught. From 0.30 to 0.50 the model drops 22 alarms: 12 were false and 10 were caught failures. Accuracy counts that as two more right answers, 0.976 to 0.977.</a:t>
             </a:r>
           </a:p>
         </p:txBody>
@@ -4886,7 +4886,7 @@
             </a:pPr>
             <a:r>
               <a:rPr/>
-              <a:t>The identity with the Mann-Whitney U statistic is in the handout, section 8.2, for anyone who wants the proof. But notebook 3 does something better than a proof for this audience: it draws 200,000 random pairs and counts. 0.9488 against roc_auc_score’s 0.9493.</a:t>
+              <a:t>The identity with the Mann-Whitney U statistic - a classical test that compares two groups by counting, over every pair, which member ranks higher - is in the handout, section 8.2, for anyone who wants the proof. But notebook 3 does something better than a proof for this audience: it draws 200,000 random pairs and counts. 0.9488 against roc_auc_score’s 0.9493.</a:t>
             </a:r>
           </a:p>
         </p:txBody>
@@ -4968,7 +4968,7 @@
             </a:pPr>
             <a:r>
               <a:rPr/>
-              <a:t>Short slide, important consequence. AUC depends only on the ordering, so it is invariant under any monotone transformation of the scores.</a:t>
+              <a:t>Short slide, important consequence. AUC depends only on the ordering, so it is unchanged by anything done to the scores that keeps their order.</a:t>
             </a:r>
           </a:p>
           <a:p>
@@ -5106,7 +5106,7 @@
             </a:pPr>
             <a:r>
               <a:rPr/>
-              <a:t>Someone will notice that at 3.8% the AUC reads 0.968, not the 0.949 of slide 42. Different drives: 0.949 rests on the 76 failures of our 2,000-drive test set, 0.968 on a fleet thirty times larger. Both are estimates of the same ranking ability.</a:t>
+              <a:t>Someone will notice that at 3.8% the AUC reads 0.968, not the 0.949 of slide 42. Different drives: 0.949 rests on the 76 failures of our 2,000-drive test set, 0.968 on a fleet thirty times larger. Both are estimates of the same ranking ability. The same goes for average precision: 0.706 on the large fleet, against slide 39’s 0.717 on the test set.</a:t>
             </a:r>
           </a:p>
           <a:p>
@@ -5134,7 +5134,7 @@
             </a:pPr>
             <a:r>
               <a:rPr/>
-              <a:t>Right panel: the precision-recall curves are in three different worlds. Average precision falls from 0.706 to 0.361, and precision at the same threshold falls from 0.79 to 0.26 - three alarms in four now false.</a:t>
+              <a:t>Right panel: the precision-recall curves are in three different worlds. Average precision falls from 0.706 to 0.361, and precision at the threshold of 0.5 falls from 0.79 to 0.26 - three alarms in four now false.</a:t>
             </a:r>
           </a:p>
           <a:p>
@@ -5272,7 +5272,7 @@
             </a:pPr>
             <a:r>
               <a:rPr/>
-              <a:t>This is the second predictable mistake of the lesson, and again defend the instinct: AUC is threshold-free, comparable across models and datasets, bounded in a familiar range. Those are real virtues. It simply answers a question about ranking when the question was about the alarm queue.</a:t>
+              <a:t>This is the lesson’s second big predictable mistake, after trusting accuracy on slide 28, and again defend the instinct: AUC is threshold-free, comparable across models and datasets, bounded in a familiar range. Those are real virtues. It simply answers a question about ranking when the question was about the alarm queue.</a:t>
             </a:r>
           </a:p>
         </p:txBody>
@@ -5892,7 +5892,7 @@
             </a:pPr>
             <a:r>
               <a:rPr/>
-              <a:t>The same reading holds for resampling and for SMOTE (synthetic minority oversampling technique, which builds artificial minority examples): they move the operating point too. And both must be applied to the training rows only - inside each cross-validation fold, once lesson 5 introduces folds - for the reasons lesson 2 gave about imputation.</a:t>
+              <a:t>The same reading holds for resampling and for SMOTE (synthetic minority oversampling technique, which builds artificial minority examples): they move the operating point too. And both must be applied to the training rows only - inside each cross-validation fold, once lesson 5 introduces folds. Duplicated or synthetic failures in the test set would be scored as if they were real drives, and the test score would stop describing the real fleet; lesson 2 made the same argument for fitting the imputer on the training rows only.</a:t>
             </a:r>
           </a:p>
         </p:txBody>
@@ -6442,7 +6442,7 @@
             </a:pPr>
             <a:r>
               <a:rPr/>
-              <a:t>The second thing: every metric on the slide depended on a threshold, and the threshold has an answer - C-FP over C-FP plus C-FN, for honest probabilities - that comes from the business, not from the data.</a:t>
+              <a:t>The second thing: accuracy, precision, recall and F1 all depended on a threshold, and the threshold has an answer - C-FP over C-FP plus C-FN, for honest probabilities - that comes from the business, not from the data.</a:t>
             </a:r>
           </a:p>
         </p:txBody>

</xml_diff>

<commit_message>
Date lesson 4 on 30 October and exercise 4 on 6 November
Lesson 4 moved from 23 to 30 October, so its exercise is now discussed
at the start of lesson 5, Friday 6 November: slide 55 and its notes,
handout, exercise, notebook 3, and the date line of the concepts index,
notebook guide and supplementary reading. The course schedule and the
later lessons' dates are left for the pending schedule decision.

Co-Authored-By: Claude Opus 5.5 <noreply@anthropic.com>
</commit_message>
<xml_diff>
--- a/Lessons/04_classification_and_metrics/Slides/classification_and_metrics_slides.pptx
+++ b/Lessons/04_classification_and_metrics/Slides/classification_and_metrics_slides.pptx
@@ -6524,7 +6524,7 @@
             </a:pPr>
             <a:r>
               <a:rPr/>
-              <a:t>Set it explicitly and say out loud when it comes back: the first ten minutes of next Friday, 30 October.</a:t>
+              <a:t>Set it explicitly and say out loud when it comes back: the first ten minutes of next Friday, 6 November.</a:t>
             </a:r>
           </a:p>
           <a:p>
@@ -10265,7 +10265,7 @@
             </a:pPr>
             <a:r>
               <a:rPr/>
-              <a:t>23 October 2026</a:t>
+              <a:t>30 October 2026</a:t>
             </a:r>
           </a:p>
         </p:txBody>
@@ -18673,7 +18673,7 @@
             </a:r>
             <a:r>
               <a:rPr b="1"/>
-              <a:t>Friday 30 October</a:t>
+              <a:t>Friday 6 November</a:t>
             </a:r>
           </a:p>
           <a:p>

</xml_diff>

<commit_message>
Stack lesson 4's two likelihood formulas on slide 18
Side by side they were scaled to 21pt to fit the width. render_math.py
now reads \\ in a display equation as a line break and draws one
mathtext line per piece, so each formula gets the full width. The notes
say "top line" and "bottom line" instead of "left" and "right".

Co-Authored-By: Claude Opus 5.5 <noreply@anthropic.com>
</commit_message>
<xml_diff>
--- a/Lessons/04_classification_and_metrics/Slides/classification_and_metrics_slides.pptx
+++ b/Lessons/04_classification_and_metrics/Slides/classification_and_metrics_slides.pptx
@@ -1528,21 +1528,21 @@
             </a:pPr>
             <a:r>
               <a:rPr/>
-              <a:t>Left: the probability of what happened to one drive. It is the rule “p if y = 1, 1 - p if y = 0” in a single expression. Check it with y = 1: p to the power 1 is p, and (1 - p) to the power 0 is 1, so it gives p. With y = 0 it gives 1 times (1 - p). Do drive B on the board: 0.1 to the power 0 times 0.9 to the power 1 is 0.9, the number in the table. The exponents are just a way of writing an if-statement.</a:t>
-            </a:r>
-          </a:p>
-          <a:p>
-            <a:pPr lvl="0" indent="0" marL="0">
-              <a:buNone/>
-            </a:pPr>
-          </a:p>
-          <a:p>
-            <a:pPr lvl="0" indent="0" marL="0">
-              <a:buNone/>
-            </a:pPr>
-            <a:r>
-              <a:rPr/>
-              <a:t>Right: the likelihood, script L, of a setting (w, b). The capital pi means “multiply over all the drives”, i from 1 to m, the way a capital sigma means “add”. Each drive contributes its factor from the left formula; the superscript (i) says which drive. For our three drives, m = 3 and the product is 0.8 times 0.9 times 0.8 = 0.576.</a:t>
+              <a:t>Top line: the probability of what happened to one drive. It is the rule “p if y = 1, 1 - p if y = 0” in a single expression. Check it with y = 1: p to the power 1 is p, and (1 - p) to the power 0 is 1, so it gives p. With y = 0 it gives 1 times (1 - p). Do drive B on the board: 0.1 to the power 0 times 0.9 to the power 1 is 0.9, the number in the table. The exponents are just a way of writing an if-statement.</a:t>
+            </a:r>
+          </a:p>
+          <a:p>
+            <a:pPr lvl="0" indent="0" marL="0">
+              <a:buNone/>
+            </a:pPr>
+          </a:p>
+          <a:p>
+            <a:pPr lvl="0" indent="0" marL="0">
+              <a:buNone/>
+            </a:pPr>
+            <a:r>
+              <a:rPr/>
+              <a:t>Bottom line: the likelihood, script L, of a setting (w, b). The capital pi means “multiply over all the drives”, i from 1 to m, the way a capital sigma means “add”. Each drive contributes its factor from the top line; the superscript (i) says which drive. For our three drives, m = 3 and the product is 0.8 times 0.9 times 0.8 = 0.576.</a:t>
             </a:r>
           </a:p>
           <a:p>
@@ -12048,7 +12048,7 @@
       </p:sp>
       <p:pic>
         <p:nvPicPr>
-          <p:cNvPr descr="eq_f8ebc3d590.png" id="0" name="Picture 1"/>
+          <p:cNvPr descr="eq_4374b8da02.png" id="0" name="Picture 1"/>
           <p:cNvPicPr>
             <a:picLocks noGrp="1" noChangeAspect="1"/>
           </p:cNvPicPr>
@@ -12062,8 +12062,8 @@
         </p:blipFill>
         <p:spPr bwMode="auto">
           <a:xfrm>
-            <a:off x="457200" y="2484239"/>
-            <a:ext cx="8229600" cy="723900"/>
+            <a:off x="457200" y="1512689"/>
+            <a:ext cx="8229600" cy="2667000"/>
           </a:xfrm>
           <a:prstGeom prst="rect">
             <a:avLst/>

</xml_diff>

<commit_message>
Name the six SMART counters on lesson 4's slide 5
The slide said only "six SMART counters"; the names were in the notes,
which a student reading the deck never sees. The notes now describe each
counter and point to the table in handout section 1.1.

Co-Authored-By: Claude Opus 5.5 <noreply@anthropic.com>
</commit_message>
<xml_diff>
--- a/Lessons/04_classification_and_metrics/Slides/classification_and_metrics_slides.pptx
+++ b/Lessons/04_classification_and_metrics/Slides/classification_and_metrics_slides.pptx
@@ -4610,7 +4610,7 @@
             </a:pPr>
             <a:r>
               <a:rPr/>
-              <a:t>SMART is the diagnostic data a drive keeps about itself: reallocated sectors (bad patches of the disk the drive has had to replace), spin retries, read error rate, temperature, hours in service, and seek error rate. Expand the acronym on the slide and out loud - it is the kind of thing that gets skipped and then quietly blocks a student for the rest of the hour.</a:t>
+              <a:t>SMART is the diagnostic data a drive keeps about itself. The third bullet names the six: reallocated sectors (bad patches of the disk the drive has retired and replaced with spare ones), spin retries (times the motor needed a second attempt to bring the platters up to speed), the share of reads and of head movements that hit an error, temperature, and hours in service. Handout section 1.1 has them in a table, with a typical drive’s values. Expand the acronym on the slide and out loud - it is the kind of thing that gets skipped and then quietly blocks a student for the rest of the hour.</a:t>
             </a:r>
           </a:p>
           <a:p>
@@ -17550,6 +17550,13 @@
             <a:r>
               <a:rPr/>
               <a:t>Six SMART counters each: Self-Monitoring, Analysis and Reporting Technology</a:t>
+            </a:r>
+          </a:p>
+          <a:p>
+            <a:pPr lvl="0"/>
+            <a:r>
+              <a:rPr/>
+              <a:t>Reallocated sectors, spin retries, read and seek error rates, temperature, hours in service</a:t>
             </a:r>
           </a:p>
           <a:p>

</xml_diff>

<commit_message>
Count the drives on lesson 4's slide 10
The odds table showed results without their calculations. Slide 10 and
handout section 2.3 now follow 1,000 drives at 50% and at 95% risk through
a reading six times more common among failing drives, every cell with its
arithmetic; the handout keeps the general table after it.

Co-Authored-By: Claude Opus 5.5 <noreply@anthropic.com>
Claude-Session: https://claude.ai/code/session_01BdugDqEmUaYq1vzEjdPDKj
</commit_message>
<xml_diff>
--- a/Lessons/04_classification_and_metrics/Slides/classification_and_metrics_slides.pptx
+++ b/Lessons/04_classification_and_metrics/Slides/classification_and_metrics_slides.pptx
@@ -7251,77 +7251,105 @@
             </a:pPr>
             <a:r>
               <a:rPr/>
-              <a:t>Slide 9 said the log-odds has the range a line needs. That is true, but it is not a reason: plenty of other functions also stretch (0, 1) onto the whole line. This slide gives the reason, and it is about how evidence combines.</a:t>
-            </a:r>
-          </a:p>
-          <a:p>
-            <a:pPr lvl="0" indent="0" marL="0">
-              <a:buNone/>
-            </a:pPr>
-          </a:p>
-          <a:p>
-            <a:pPr lvl="0" indent="0" marL="0">
-              <a:buNone/>
-            </a:pPr>
-            <a:r>
-              <a:rPr/>
-              <a:t>Start from what a linear model does. It adds one contribution per feature, and each contribution is the same whatever the other features say. So we want the same evidence - say, one standard deviation more of reallocated sectors - to raise the risk by the same amount on every drive.</a:t>
-            </a:r>
-          </a:p>
-          <a:p>
-            <a:pPr lvl="0" indent="0" marL="0">
-              <a:buNone/>
-            </a:pPr>
-          </a:p>
-          <a:p>
-            <a:pPr lvl="0" indent="0" marL="0">
-              <a:buNone/>
-            </a:pPr>
-            <a:r>
-              <a:rPr/>
-              <a:t>Last column first. Try a fixed step in probability: plus 0.10. A drive at 50% goes to 60%, fine. A drive at 95% goes to 105%, which is not a probability. No step is small enough to be safe for every drive.</a:t>
-            </a:r>
-          </a:p>
-          <a:p>
-            <a:pPr lvl="0" indent="0" marL="0">
-              <a:buNone/>
-            </a:pPr>
-          </a:p>
-          <a:p>
-            <a:pPr lvl="0" indent="0" marL="0">
-              <a:buNone/>
-            </a:pPr>
-            <a:r>
-              <a:rPr/>
-              <a:t>Now the odds: the probability of failing divided by the probability of not failing, p over 1 minus p. Bayes’ rule, written with odds, says exactly how evidence acts on them: the odds after seeing a reading are the odds before, times how much more common that reading is among drives that fail than among drives that do not. That ratio is called the likelihood ratio. A reading six times more common among failing drives multiplies the odds by 6 - whatever they were. Six is realistic here: the coefficient of reallocated sectors used to generate the labels is 1.80 per standard deviation, and e to the 1.80 is 6.05 (slide 13 reads coefficients this way; slide 14 shows the true ones).</a:t>
-            </a:r>
-          </a:p>
-          <a:p>
-            <a:pPr lvl="0" indent="0" marL="0">
-              <a:buNone/>
-            </a:pPr>
-          </a:p>
-          <a:p>
-            <a:pPr lvl="0" indent="0" marL="0">
-              <a:buNone/>
-            </a:pPr>
-            <a:r>
-              <a:rPr/>
-              <a:t>Go along the rows. A factor never breaks anything: odds times 6 are still positive odds, so the last-but-one column is always a probability. And read how much it moves: 36 points at 50%, but 1 point at 0.2% and 4 points at 95%. Steep in the middle, flat at both ends - that is slide 8’s sigmoid, and nobody chose it. It is what multiplying the odds looks like on the probability scale.</a:t>
-            </a:r>
-          </a:p>
-          <a:p>
-            <a:pPr lvl="0" indent="0" marL="0">
-              <a:buNone/>
-            </a:pPr>
-          </a:p>
-          <a:p>
-            <a:pPr lvl="0" indent="0" marL="0">
-              <a:buNone/>
-            </a:pPr>
-            <a:r>
-              <a:rPr/>
-              <a:t>Then the step to the next slide. Several readings, if independent given the class, multiply the odds by one factor each. Take the logarithm and the factors become terms that add: log of the odds after equals log of the odds before plus one log-factor per reading. A starting value plus one term per feature is exactly w-transpose-x plus b. The intercept is the log-odds of an average drive, minus 6.20, which is the 0.2% in the first row; each term is the log of the factor its feature multiplies the odds by - log 6 is 1.79. That is why slide 11 puts the line on the log-odds. Handout section 2.3.</a:t>
+              <a:t>Slide 9 said the log-odds has the range a line needs. That is true, but it is not a reason: plenty of other functions also stretch (0, 1) onto the whole line. This slide gives the reason, by counting drives.</a:t>
+            </a:r>
+          </a:p>
+          <a:p>
+            <a:pPr lvl="0" indent="0" marL="0">
+              <a:buNone/>
+            </a:pPr>
+          </a:p>
+          <a:p>
+            <a:pPr lvl="0" indent="0" marL="0">
+              <a:buNone/>
+            </a:pPr>
+            <a:r>
+              <a:rPr/>
+              <a:t>Start from what a linear model does. It adds one contribution per feature, and each contribution is the same whatever the other features say. So we want the same evidence to act on every drive in the same way, whatever its risk.</a:t>
+            </a:r>
+          </a:p>
+          <a:p>
+            <a:pPr lvl="0" indent="0" marL="0">
+              <a:buNone/>
+            </a:pPr>
+          </a:p>
+          <a:p>
+            <a:pPr lvl="0" indent="0" marL="0">
+              <a:buNone/>
+            </a:pPr>
+            <a:r>
+              <a:rPr/>
+              <a:t>Read the table one column at a time, top to bottom. Take 1,000 drives that each have a 50% risk: 500 will fail and 500 will not. A reading arrives - say a high count of reallocated sectors - that shows up on 60% of the drives that are going to fail and on 10% of the healthy ones: six times more often. Among the drives that show it, 60% of 500 is 300 failing and 10% of 500 is 50 healthy. The risk after the reading is 300 out of 350, 86%.</a:t>
+            </a:r>
+          </a:p>
+          <a:p>
+            <a:pPr lvl="0" indent="0" marL="0">
+              <a:buNone/>
+            </a:pPr>
+          </a:p>
+          <a:p>
+            <a:pPr lvl="0" indent="0" marL="0">
+              <a:buNone/>
+            </a:pPr>
+            <a:r>
+              <a:rPr/>
+              <a:t>Same reading, drives at 95%: 950 will fail and 50 will not. Showing the reading: 60% of 950 is 570, 10% of 50 is 5. Risk after: 570 out of 575, 99.1%. It cannot pass 100%, because it is a count out of a total.</a:t>
+            </a:r>
+          </a:p>
+          <a:p>
+            <a:pPr lvl="0" indent="0" marL="0">
+              <a:buNone/>
+            </a:pPr>
+          </a:p>
+          <a:p>
+            <a:pPr lvl="0" indent="0" marL="0">
+              <a:buNone/>
+            </a:pPr>
+            <a:r>
+              <a:rPr/>
+              <a:t>Fourth row: try instead a fixed step in probability, plus 0.10. The drives at 50% go to 60%, fine; the drives at 95% go to 105%, which is not a probability. No step is small enough to be safe for every drive.</a:t>
+            </a:r>
+          </a:p>
+          <a:p>
+            <a:pPr lvl="0" indent="0" marL="0">
+              <a:buNone/>
+            </a:pPr>
+          </a:p>
+          <a:p>
+            <a:pPr lvl="0" indent="0" marL="0">
+              <a:buNone/>
+            </a:pPr>
+            <a:r>
+              <a:rPr/>
+              <a:t>Last row, the one that gives the slide its title. The odds are the failing drives divided by the healthy ones - the same thing as p divided by 1 minus p. Before the reading they are 500 over 500 = 1 and 950 over 50 = 19; after it, 6 and 114. Both multiplied by 6, which is 60% divided by 10%: the failing count is scaled by 0.6 and the healthy count by 0.1, whatever they were. That is Bayes’ rule written with odds: the odds after are the odds before times the likelihood ratio, how much more common the reading is among failing drives than among healthy ones. The 60% and 10% are only an illustration - any pair with ratio 6 gives the same risks. Six itself is realistic: the coefficient of reallocated sectors used to generate the labels is 1.80 per standard deviation, and e to the 1.80 is 6.05 (slide 13 reads coefficients this way; slide 14 shows the true ones).</a:t>
+            </a:r>
+          </a:p>
+          <a:p>
+            <a:pPr lvl="0" indent="0" marL="0">
+              <a:buNone/>
+            </a:pPr>
+          </a:p>
+          <a:p>
+            <a:pPr lvl="0" indent="0" marL="0">
+              <a:buNone/>
+            </a:pPr>
+            <a:r>
+              <a:rPr/>
+              <a:t>Now compare how far the same reading moved the risk: 36 points at 50%, 4 points at 95%. An average drive, at 0.2%, goes to 1.2% - one point (the handout’s table in section 2.3). Steep in the middle, flat at both ends: that is slide 8’s sigmoid, and nobody chose it. It is what multiplying the odds looks like on the probability scale.</a:t>
+            </a:r>
+          </a:p>
+          <a:p>
+            <a:pPr lvl="0" indent="0" marL="0">
+              <a:buNone/>
+            </a:pPr>
+          </a:p>
+          <a:p>
+            <a:pPr lvl="0" indent="0" marL="0">
+              <a:buNone/>
+            </a:pPr>
+            <a:r>
+              <a:rPr/>
+              <a:t>Then the step to the next slide. Several readings, if independent given the class, multiply the odds by one factor each. Take the logarithm and the factors become terms that add: log of the odds after equals log of the odds before plus one log-factor per reading. A starting value plus one term per feature is exactly w-transpose-x plus b. The intercept is the log-odds of an average drive, minus 6.20, which is the 0.2% above; each term is the log of the factor its feature multiplies the odds by - log 6 is 1.79. That is why slide 11 puts the line on the log-odds. Handout section 2.3.</a:t>
             </a:r>
           </a:p>
         </p:txBody>
@@ -10538,11 +10566,9 @@
                 <a:tableStyleId>{5C22544A-7EE6-4342-B048-85BDC9FD1C3A}</a:tableStyleId>
               </a:tblPr>
               <a:tblGrid>
-                <a:gridCol w="1645920"/>
-                <a:gridCol w="1645920"/>
-                <a:gridCol w="1645920"/>
-                <a:gridCol w="1645920"/>
-                <a:gridCol w="1645920"/>
+                <a:gridCol w="2743200"/>
+                <a:gridCol w="2743200"/>
+                <a:gridCol w="2743200"/>
               </a:tblGrid>
               <a:tr h="0">
                 <a:tc>
@@ -10555,7 +10581,7 @@
                       </a:pPr>
                       <a:r>
                         <a:rPr/>
-                        <a:t>Risk before, p</a:t>
+                        <a:t>One reading, 6 times more common among failing drives</a:t>
                       </a:r>
                     </a:p>
                   </a:txBody>
@@ -10571,7 +10597,7 @@
                       </a:pPr>
                       <a:r>
                         <a:rPr/>
-                        <a:t>Odds before, p ÷ (1 − p)</a:t>
+                        <a:t>Drives at 50% risk</a:t>
                       </a:r>
                     </a:p>
                   </a:txBody>
@@ -10587,39 +10613,7 @@
                       </a:pPr>
                       <a:r>
                         <a:rPr/>
-                        <a:t>A reading 6 times more common among failing drives: odds × 6</a:t>
-                      </a:r>
-                    </a:p>
-                  </a:txBody>
-                  <a:tcPr/>
-                </a:tc>
-                <a:tc>
-                  <a:txBody>
-                    <a:bodyPr/>
-                    <a:lstStyle/>
-                    <a:p>
-                      <a:pPr lvl="0" indent="0" marL="0">
-                        <a:buNone/>
-                      </a:pPr>
-                      <a:r>
-                        <a:rPr/>
-                        <a:t>Risk after, odds ÷ (1 + odds)</a:t>
-                      </a:r>
-                    </a:p>
-                  </a:txBody>
-                  <a:tcPr/>
-                </a:tc>
-                <a:tc>
-                  <a:txBody>
-                    <a:bodyPr/>
-                    <a:lstStyle/>
-                    <a:p>
-                      <a:pPr lvl="0" indent="0" marL="0">
-                        <a:buNone/>
-                      </a:pPr>
-                      <a:r>
-                        <a:rPr/>
-                        <a:t>Adding 0.10 to the risk instead</a:t>
+                        <a:t>Drives at 95% risk</a:t>
                       </a:r>
                     </a:p>
                   </a:txBody>
@@ -10637,67 +10631,37 @@
                       </a:pPr>
                       <a:r>
                         <a:rPr/>
-                        <a:t>0.2% (an average drive)</a:t>
-                      </a:r>
-                    </a:p>
-                  </a:txBody>
-                </a:tc>
-                <a:tc>
-                  <a:txBody>
-                    <a:bodyPr/>
-                    <a:lstStyle/>
-                    <a:p>
-                      <a:pPr lvl="0" indent="0" marL="0">
-                        <a:buNone/>
-                      </a:pPr>
-                      <a:r>
-                        <a:rPr/>
-                        <a:t>0.002</a:t>
-                      </a:r>
-                    </a:p>
-                  </a:txBody>
-                </a:tc>
-                <a:tc>
-                  <a:txBody>
-                    <a:bodyPr/>
-                    <a:lstStyle/>
-                    <a:p>
-                      <a:pPr lvl="0" indent="0" marL="0">
-                        <a:buNone/>
-                      </a:pPr>
-                      <a:r>
-                        <a:rPr/>
-                        <a:t>0.012</a:t>
-                      </a:r>
-                    </a:p>
-                  </a:txBody>
-                </a:tc>
-                <a:tc>
-                  <a:txBody>
-                    <a:bodyPr/>
-                    <a:lstStyle/>
-                    <a:p>
-                      <a:pPr lvl="0" indent="0" marL="0">
-                        <a:buNone/>
-                      </a:pPr>
-                      <a:r>
-                        <a:rPr/>
-                        <a:t>1.2%</a:t>
-                      </a:r>
-                    </a:p>
-                  </a:txBody>
-                </a:tc>
-                <a:tc>
-                  <a:txBody>
-                    <a:bodyPr/>
-                    <a:lstStyle/>
-                    <a:p>
-                      <a:pPr lvl="0" indent="0" marL="0">
-                        <a:buNone/>
-                      </a:pPr>
-                      <a:r>
-                        <a:rPr/>
-                        <a:t>10.2%</a:t>
+                        <a:t>1,000 such drives: will fail / stay healthy</a:t>
+                      </a:r>
+                    </a:p>
+                  </a:txBody>
+                </a:tc>
+                <a:tc>
+                  <a:txBody>
+                    <a:bodyPr/>
+                    <a:lstStyle/>
+                    <a:p>
+                      <a:pPr lvl="0" indent="0" marL="0">
+                        <a:buNone/>
+                      </a:pPr>
+                      <a:r>
+                        <a:rPr/>
+                        <a:t>500 / 500</a:t>
+                      </a:r>
+                    </a:p>
+                  </a:txBody>
+                </a:tc>
+                <a:tc>
+                  <a:txBody>
+                    <a:bodyPr/>
+                    <a:lstStyle/>
+                    <a:p>
+                      <a:pPr lvl="0" indent="0" marL="0">
+                        <a:buNone/>
+                      </a:pPr>
+                      <a:r>
+                        <a:rPr/>
+                        <a:t>950 / 50</a:t>
                       </a:r>
                     </a:p>
                   </a:txBody>
@@ -10714,67 +10678,37 @@
                       </a:pPr>
                       <a:r>
                         <a:rPr/>
-                        <a:t>50%</a:t>
-                      </a:r>
-                    </a:p>
-                  </a:txBody>
-                </a:tc>
-                <a:tc>
-                  <a:txBody>
-                    <a:bodyPr/>
-                    <a:lstStyle/>
-                    <a:p>
-                      <a:pPr lvl="0" indent="0" marL="0">
-                        <a:buNone/>
-                      </a:pPr>
-                      <a:r>
-                        <a:rPr/>
-                        <a:t>1</a:t>
-                      </a:r>
-                    </a:p>
-                  </a:txBody>
-                </a:tc>
-                <a:tc>
-                  <a:txBody>
-                    <a:bodyPr/>
-                    <a:lstStyle/>
-                    <a:p>
-                      <a:pPr lvl="0" indent="0" marL="0">
-                        <a:buNone/>
-                      </a:pPr>
-                      <a:r>
-                        <a:rPr/>
-                        <a:t>6</a:t>
-                      </a:r>
-                    </a:p>
-                  </a:txBody>
-                </a:tc>
-                <a:tc>
-                  <a:txBody>
-                    <a:bodyPr/>
-                    <a:lstStyle/>
-                    <a:p>
-                      <a:pPr lvl="0" indent="0" marL="0">
-                        <a:buNone/>
-                      </a:pPr>
-                      <a:r>
-                        <a:rPr/>
-                        <a:t>86%</a:t>
-                      </a:r>
-                    </a:p>
-                  </a:txBody>
-                </a:tc>
-                <a:tc>
-                  <a:txBody>
-                    <a:bodyPr/>
-                    <a:lstStyle/>
-                    <a:p>
-                      <a:pPr lvl="0" indent="0" marL="0">
-                        <a:buNone/>
-                      </a:pPr>
-                      <a:r>
-                        <a:rPr/>
-                        <a:t>60%</a:t>
+                        <a:t>Those showing the reading: 60% of failing, 10% of healthy</a:t>
+                      </a:r>
+                    </a:p>
+                  </a:txBody>
+                </a:tc>
+                <a:tc>
+                  <a:txBody>
+                    <a:bodyPr/>
+                    <a:lstStyle/>
+                    <a:p>
+                      <a:pPr lvl="0" indent="0" marL="0">
+                        <a:buNone/>
+                      </a:pPr>
+                      <a:r>
+                        <a:rPr/>
+                        <a:t>300 / 50</a:t>
+                      </a:r>
+                    </a:p>
+                  </a:txBody>
+                </a:tc>
+                <a:tc>
+                  <a:txBody>
+                    <a:bodyPr/>
+                    <a:lstStyle/>
+                    <a:p>
+                      <a:pPr lvl="0" indent="0" marL="0">
+                        <a:buNone/>
+                      </a:pPr>
+                      <a:r>
+                        <a:rPr/>
+                        <a:t>570 / 5</a:t>
                       </a:r>
                     </a:p>
                   </a:txBody>
@@ -10791,52 +10725,69 @@
                       </a:pPr>
                       <a:r>
                         <a:rPr/>
-                        <a:t>95%</a:t>
-                      </a:r>
-                    </a:p>
-                  </a:txBody>
-                </a:tc>
-                <a:tc>
-                  <a:txBody>
-                    <a:bodyPr/>
-                    <a:lstStyle/>
-                    <a:p>
-                      <a:pPr lvl="0" indent="0" marL="0">
-                        <a:buNone/>
-                      </a:pPr>
-                      <a:r>
-                        <a:rPr/>
-                        <a:t>19</a:t>
-                      </a:r>
-                    </a:p>
-                  </a:txBody>
-                </a:tc>
-                <a:tc>
-                  <a:txBody>
-                    <a:bodyPr/>
-                    <a:lstStyle/>
-                    <a:p>
-                      <a:pPr lvl="0" indent="0" marL="0">
-                        <a:buNone/>
-                      </a:pPr>
-                      <a:r>
-                        <a:rPr/>
-                        <a:t>114</a:t>
-                      </a:r>
-                    </a:p>
-                  </a:txBody>
-                </a:tc>
-                <a:tc>
-                  <a:txBody>
-                    <a:bodyPr/>
-                    <a:lstStyle/>
-                    <a:p>
-                      <a:pPr lvl="0" indent="0" marL="0">
-                        <a:buNone/>
-                      </a:pPr>
-                      <a:r>
-                        <a:rPr/>
-                        <a:t>99.1%</a:t>
+                        <a:t>Risk after the reading: failing ÷ all showing it</a:t>
+                      </a:r>
+                    </a:p>
+                  </a:txBody>
+                </a:tc>
+                <a:tc>
+                  <a:txBody>
+                    <a:bodyPr/>
+                    <a:lstStyle/>
+                    <a:p>
+                      <a:pPr lvl="0" indent="0" marL="0">
+                        <a:buNone/>
+                      </a:pPr>
+                      <a:r>
+                        <a:rPr/>
+                        <a:t>300 ÷ 350 = 86%</a:t>
+                      </a:r>
+                    </a:p>
+                  </a:txBody>
+                </a:tc>
+                <a:tc>
+                  <a:txBody>
+                    <a:bodyPr/>
+                    <a:lstStyle/>
+                    <a:p>
+                      <a:pPr lvl="0" indent="0" marL="0">
+                        <a:buNone/>
+                      </a:pPr>
+                      <a:r>
+                        <a:rPr/>
+                        <a:t>570 ÷ 575 = 99.1%</a:t>
+                      </a:r>
+                    </a:p>
+                  </a:txBody>
+                </a:tc>
+              </a:tr>
+              <a:tr h="0">
+                <a:tc>
+                  <a:txBody>
+                    <a:bodyPr/>
+                    <a:lstStyle/>
+                    <a:p>
+                      <a:pPr lvl="0" indent="0" marL="0">
+                        <a:buNone/>
+                      </a:pPr>
+                      <a:r>
+                        <a:rPr/>
+                        <a:t>Adding 0.10 to the risk instead</a:t>
+                      </a:r>
+                    </a:p>
+                  </a:txBody>
+                </a:tc>
+                <a:tc>
+                  <a:txBody>
+                    <a:bodyPr/>
+                    <a:lstStyle/>
+                    <a:p>
+                      <a:pPr lvl="0" indent="0" marL="0">
+                        <a:buNone/>
+                      </a:pPr>
+                      <a:r>
+                        <a:rPr/>
+                        <a:t>60%</a:t>
                       </a:r>
                     </a:p>
                   </a:txBody>
@@ -10852,6 +10803,53 @@
                       <a:r>
                         <a:rPr/>
                         <a:t>105%: impossible</a:t>
+                      </a:r>
+                    </a:p>
+                  </a:txBody>
+                </a:tc>
+              </a:tr>
+              <a:tr h="0">
+                <a:tc>
+                  <a:txBody>
+                    <a:bodyPr/>
+                    <a:lstStyle/>
+                    <a:p>
+                      <a:pPr lvl="0" indent="0" marL="0">
+                        <a:buNone/>
+                      </a:pPr>
+                      <a:r>
+                        <a:rPr/>
+                        <a:t>Odds = failing ÷ healthy, before and after</a:t>
+                      </a:r>
+                    </a:p>
+                  </a:txBody>
+                </a:tc>
+                <a:tc>
+                  <a:txBody>
+                    <a:bodyPr/>
+                    <a:lstStyle/>
+                    <a:p>
+                      <a:pPr lvl="0" indent="0" marL="0">
+                        <a:buNone/>
+                      </a:pPr>
+                      <a:r>
+                        <a:rPr/>
+                        <a:t>1, then 300 ÷ 50 = 6: × 6</a:t>
+                      </a:r>
+                    </a:p>
+                  </a:txBody>
+                </a:tc>
+                <a:tc>
+                  <a:txBody>
+                    <a:bodyPr/>
+                    <a:lstStyle/>
+                    <a:p>
+                      <a:pPr lvl="0" indent="0" marL="0">
+                        <a:buNone/>
+                      </a:pPr>
+                      <a:r>
+                        <a:rPr/>
+                        <a:t>19, then 570 ÷ 5 = 114: × 6</a:t>
                       </a:r>
                     </a:p>
                   </a:txBody>

</xml_diff>

<commit_message>
Show lesson 4's slide 10 as a figure, not a table
The counted table was still too hard to talk through. The slide now shows
three drives on the sigmoid receiving the same reading: equal steps in
log-odds, +1, +36 and +4 points in probability. The handout carries the
figure after its tables.

Co-Authored-By: Claude Opus 5.5 <noreply@anthropic.com>
Claude-Session: https://claude.ai/code/session_01BdugDqEmUaYq1vzEjdPDKj
</commit_message>
<xml_diff>
--- a/Lessons/04_classification_and_metrics/Slides/classification_and_metrics_slides.pptx
+++ b/Lessons/04_classification_and_metrics/Slides/classification_and_metrics_slides.pptx
@@ -7251,7 +7251,7 @@
             </a:pPr>
             <a:r>
               <a:rPr/>
-              <a:t>Slide 9 said the log-odds has the range a line needs. That is true, but it is not a reason: plenty of other functions also stretch (0, 1) onto the whole line. This slide gives the reason, by counting drives.</a:t>
+              <a:t>Slide 9 said the log-odds has the range a line needs. That is true, but it is not a reason: plenty of other functions also stretch (0, 1) onto the whole line. This picture gives the reason.</a:t>
             </a:r>
           </a:p>
           <a:p>
@@ -7279,77 +7279,49 @@
             </a:pPr>
             <a:r>
               <a:rPr/>
-              <a:t>Read the table one column at a time, top to bottom. Take 1,000 drives that each have a 50% risk: 500 will fail and 500 will not. A reading arrives - say a high count of reallocated sectors - that shows up on 60% of the drives that are going to fail and on 10% of the healthy ones: six times more often. Among the drives that show it, 60% of 500 is 300 failing and 10% of 500 is 50 healthy. The risk after the reading is 300 out of 350, 86%.</a:t>
-            </a:r>
-          </a:p>
-          <a:p>
-            <a:pPr lvl="0" indent="0" marL="0">
-              <a:buNone/>
-            </a:pPr>
-          </a:p>
-          <a:p>
-            <a:pPr lvl="0" indent="0" marL="0">
-              <a:buNone/>
-            </a:pPr>
-            <a:r>
-              <a:rPr/>
-              <a:t>Same reading, drives at 95%: 950 will fail and 50 will not. Showing the reading: 60% of 950 is 570, 10% of 50 is 5. Risk after: 570 out of 575, 99.1%. It cannot pass 100%, because it is a count out of a total.</a:t>
-            </a:r>
-          </a:p>
-          <a:p>
-            <a:pPr lvl="0" indent="0" marL="0">
-              <a:buNone/>
-            </a:pPr>
-          </a:p>
-          <a:p>
-            <a:pPr lvl="0" indent="0" marL="0">
-              <a:buNone/>
-            </a:pPr>
-            <a:r>
-              <a:rPr/>
-              <a:t>Fourth row: try instead a fixed step in probability, plus 0.10. The drives at 50% go to 60%, fine; the drives at 95% go to 105%, which is not a probability. No step is small enough to be safe for every drive.</a:t>
-            </a:r>
-          </a:p>
-          <a:p>
-            <a:pPr lvl="0" indent="0" marL="0">
-              <a:buNone/>
-            </a:pPr>
-          </a:p>
-          <a:p>
-            <a:pPr lvl="0" indent="0" marL="0">
-              <a:buNone/>
-            </a:pPr>
-            <a:r>
-              <a:rPr/>
-              <a:t>Last row, the one that gives the slide its title. The odds are the failing drives divided by the healthy ones - the same thing as p divided by 1 minus p. Before the reading they are 500 over 500 = 1 and 950 over 50 = 19; after it, 6 and 114. Both multiplied by 6, which is 60% divided by 10%: the failing count is scaled by 0.6 and the healthy count by 0.1, whatever they were. That is Bayes’ rule written with odds: the odds after are the odds before times the likelihood ratio, how much more common the reading is among failing drives than among healthy ones. The 60% and 10% are only an illustration - any pair with ratio 6 gives the same risks. Six itself is realistic: the coefficient of reallocated sectors used to generate the labels is 1.80 per standard deviation, and e to the 1.80 is 6.05 (slide 13 reads coefficients this way; slide 14 shows the true ones).</a:t>
-            </a:r>
-          </a:p>
-          <a:p>
-            <a:pPr lvl="0" indent="0" marL="0">
-              <a:buNone/>
-            </a:pPr>
-          </a:p>
-          <a:p>
-            <a:pPr lvl="0" indent="0" marL="0">
-              <a:buNone/>
-            </a:pPr>
-            <a:r>
-              <a:rPr/>
-              <a:t>Now compare how far the same reading moved the risk: 36 points at 50%, 4 points at 95%. An average drive, at 0.2%, goes to 1.2% - one point (the handout’s table in section 2.3). Steep in the middle, flat at both ends: that is slide 8’s sigmoid, and nobody chose it. It is what multiplying the odds looks like on the probability scale.</a:t>
-            </a:r>
-          </a:p>
-          <a:p>
-            <a:pPr lvl="0" indent="0" marL="0">
-              <a:buNone/>
-            </a:pPr>
-          </a:p>
-          <a:p>
-            <a:pPr lvl="0" indent="0" marL="0">
-              <a:buNone/>
-            </a:pPr>
-            <a:r>
-              <a:rPr/>
-              <a:t>Then the step to the next slide. Several readings, if independent given the class, multiply the odds by one factor each. Take the logarithm and the factors become terms that add: log of the odds after equals log of the odds before plus one log-factor per reading. A starting value plus one term per feature is exactly w-transpose-x plus b. The intercept is the log-odds of an average drive, minus 6.20, which is the 0.2% above; each term is the log of the factor its feature multiplies the odds by - log 6 is 1.79. That is why slide 11 puts the line on the log-odds. Handout section 2.3.</a:t>
+              <a:t>The picture shows three drives, marked by the yellow dots: an average drive at 0.2%, one at 50% and one at 95%. Each receives the same reading, one that is six times more common among drives that fail than among healthy ones. Bayes’ rule says such a reading multiplies the odds - the probability of failing divided by the probability of not failing - by 6, whatever they were before (handout section 2.3 shows it by counting 1,000 drives). On the horizontal axis, the log-odds, multiplying by 6 is always the same step: the three teal arrows have the same length.</a:t>
+            </a:r>
+          </a:p>
+          <a:p>
+            <a:pPr lvl="0" indent="0" marL="0">
+              <a:buNone/>
+            </a:pPr>
+          </a:p>
+          <a:p>
+            <a:pPr lvl="0" indent="0" marL="0">
+              <a:buNone/>
+            </a:pPr>
+            <a:r>
+              <a:rPr/>
+              <a:t>Now the rust arrows: what that same step does to the probability. 36 points for the drive at 50%, 4 points for the drive at 95%, 1 point for the average drive. And it never passes 100%, because the curve cannot. A fixed step in probability would: plus 0.10 takes the drive at 95% to 105%.</a:t>
+            </a:r>
+          </a:p>
+          <a:p>
+            <a:pPr lvl="0" indent="0" marL="0">
+              <a:buNone/>
+            </a:pPr>
+          </a:p>
+          <a:p>
+            <a:pPr lvl="0" indent="0" marL="0">
+              <a:buNone/>
+            </a:pPr>
+            <a:r>
+              <a:rPr/>
+              <a:t>So nobody chose the S-shape of slide 8. It is what “evidence multiplies the odds” looks like when it is drawn as a probability: steep in the middle, flat at both ends.</a:t>
+            </a:r>
+          </a:p>
+          <a:p>
+            <a:pPr lvl="0" indent="0" marL="0">
+              <a:buNone/>
+            </a:pPr>
+          </a:p>
+          <a:p>
+            <a:pPr lvl="0" indent="0" marL="0">
+              <a:buNone/>
+            </a:pPr>
+            <a:r>
+              <a:rPr/>
+              <a:t>The step to the next slide: on the log-odds axis, evidence simply adds. Several readings, if independent given the class, are one fixed step each, starting from the average drive at minus 6.20. A starting value plus one step per feature is exactly w-transpose-x plus b, which is why slide 11 puts the line on the log-odds. Six is a realistic factor: the coefficient of reallocated sectors used to generate the labels is 1.80 per standard deviation, and e to the 1.80 is 6.05 (slide 13 reads coefficients this way; slide 14 shows the true ones).</a:t>
             </a:r>
           </a:p>
         </p:txBody>
@@ -10545,320 +10517,36 @@
           </a:p>
         </p:txBody>
       </p:sp>
-      <p:graphicFrame>
-        <p:nvGraphicFramePr>
-          <p:cNvPr id="6" name="Content Placeholder 5"/>
-          <p:cNvGraphicFramePr>
-            <a:graphicFrameLocks noGrp="1"/>
-          </p:cNvGraphicFramePr>
-          <p:nvPr>
-            <p:ph idx="1"/>
-          </p:nvPr>
-        </p:nvGraphicFramePr>
-        <p:xfrm>
-          <a:off x="457200" y="1166099"/>
-          <a:ext cx="8229600" cy="3390900"/>
-        </p:xfrm>
-        <a:graphic>
-          <a:graphicData uri="http://schemas.openxmlformats.org/drawingml/2006/table">
-            <a:tbl>
-              <a:tblPr firstRow="1" bandRow="1">
-                <a:tableStyleId>{5C22544A-7EE6-4342-B048-85BDC9FD1C3A}</a:tableStyleId>
-              </a:tblPr>
-              <a:tblGrid>
-                <a:gridCol w="2743200"/>
-                <a:gridCol w="2743200"/>
-                <a:gridCol w="2743200"/>
-              </a:tblGrid>
-              <a:tr h="0">
-                <a:tc>
-                  <a:txBody>
-                    <a:bodyPr/>
-                    <a:lstStyle/>
-                    <a:p>
-                      <a:pPr lvl="0" indent="0" marL="0">
-                        <a:buNone/>
-                      </a:pPr>
-                      <a:r>
-                        <a:rPr/>
-                        <a:t>One reading, 6 times more common among failing drives</a:t>
-                      </a:r>
-                    </a:p>
-                  </a:txBody>
-                  <a:tcPr/>
-                </a:tc>
-                <a:tc>
-                  <a:txBody>
-                    <a:bodyPr/>
-                    <a:lstStyle/>
-                    <a:p>
-                      <a:pPr lvl="0" indent="0" marL="0">
-                        <a:buNone/>
-                      </a:pPr>
-                      <a:r>
-                        <a:rPr/>
-                        <a:t>Drives at 50% risk</a:t>
-                      </a:r>
-                    </a:p>
-                  </a:txBody>
-                  <a:tcPr/>
-                </a:tc>
-                <a:tc>
-                  <a:txBody>
-                    <a:bodyPr/>
-                    <a:lstStyle/>
-                    <a:p>
-                      <a:pPr lvl="0" indent="0" marL="0">
-                        <a:buNone/>
-                      </a:pPr>
-                      <a:r>
-                        <a:rPr/>
-                        <a:t>Drives at 95% risk</a:t>
-                      </a:r>
-                    </a:p>
-                  </a:txBody>
-                  <a:tcPr/>
-                </a:tc>
-              </a:tr>
-              <a:tr h="0">
-                <a:tc>
-                  <a:txBody>
-                    <a:bodyPr/>
-                    <a:lstStyle/>
-                    <a:p>
-                      <a:pPr lvl="0" indent="0" marL="0">
-                        <a:buNone/>
-                      </a:pPr>
-                      <a:r>
-                        <a:rPr/>
-                        <a:t>1,000 such drives: will fail / stay healthy</a:t>
-                      </a:r>
-                    </a:p>
-                  </a:txBody>
-                </a:tc>
-                <a:tc>
-                  <a:txBody>
-                    <a:bodyPr/>
-                    <a:lstStyle/>
-                    <a:p>
-                      <a:pPr lvl="0" indent="0" marL="0">
-                        <a:buNone/>
-                      </a:pPr>
-                      <a:r>
-                        <a:rPr/>
-                        <a:t>500 / 500</a:t>
-                      </a:r>
-                    </a:p>
-                  </a:txBody>
-                </a:tc>
-                <a:tc>
-                  <a:txBody>
-                    <a:bodyPr/>
-                    <a:lstStyle/>
-                    <a:p>
-                      <a:pPr lvl="0" indent="0" marL="0">
-                        <a:buNone/>
-                      </a:pPr>
-                      <a:r>
-                        <a:rPr/>
-                        <a:t>950 / 50</a:t>
-                      </a:r>
-                    </a:p>
-                  </a:txBody>
-                </a:tc>
-              </a:tr>
-              <a:tr h="0">
-                <a:tc>
-                  <a:txBody>
-                    <a:bodyPr/>
-                    <a:lstStyle/>
-                    <a:p>
-                      <a:pPr lvl="0" indent="0" marL="0">
-                        <a:buNone/>
-                      </a:pPr>
-                      <a:r>
-                        <a:rPr/>
-                        <a:t>Those showing the reading: 60% of failing, 10% of healthy</a:t>
-                      </a:r>
-                    </a:p>
-                  </a:txBody>
-                </a:tc>
-                <a:tc>
-                  <a:txBody>
-                    <a:bodyPr/>
-                    <a:lstStyle/>
-                    <a:p>
-                      <a:pPr lvl="0" indent="0" marL="0">
-                        <a:buNone/>
-                      </a:pPr>
-                      <a:r>
-                        <a:rPr/>
-                        <a:t>300 / 50</a:t>
-                      </a:r>
-                    </a:p>
-                  </a:txBody>
-                </a:tc>
-                <a:tc>
-                  <a:txBody>
-                    <a:bodyPr/>
-                    <a:lstStyle/>
-                    <a:p>
-                      <a:pPr lvl="0" indent="0" marL="0">
-                        <a:buNone/>
-                      </a:pPr>
-                      <a:r>
-                        <a:rPr/>
-                        <a:t>570 / 5</a:t>
-                      </a:r>
-                    </a:p>
-                  </a:txBody>
-                </a:tc>
-              </a:tr>
-              <a:tr h="0">
-                <a:tc>
-                  <a:txBody>
-                    <a:bodyPr/>
-                    <a:lstStyle/>
-                    <a:p>
-                      <a:pPr lvl="0" indent="0" marL="0">
-                        <a:buNone/>
-                      </a:pPr>
-                      <a:r>
-                        <a:rPr/>
-                        <a:t>Risk after the reading: failing ÷ all showing it</a:t>
-                      </a:r>
-                    </a:p>
-                  </a:txBody>
-                </a:tc>
-                <a:tc>
-                  <a:txBody>
-                    <a:bodyPr/>
-                    <a:lstStyle/>
-                    <a:p>
-                      <a:pPr lvl="0" indent="0" marL="0">
-                        <a:buNone/>
-                      </a:pPr>
-                      <a:r>
-                        <a:rPr/>
-                        <a:t>300 ÷ 350 = 86%</a:t>
-                      </a:r>
-                    </a:p>
-                  </a:txBody>
-                </a:tc>
-                <a:tc>
-                  <a:txBody>
-                    <a:bodyPr/>
-                    <a:lstStyle/>
-                    <a:p>
-                      <a:pPr lvl="0" indent="0" marL="0">
-                        <a:buNone/>
-                      </a:pPr>
-                      <a:r>
-                        <a:rPr/>
-                        <a:t>570 ÷ 575 = 99.1%</a:t>
-                      </a:r>
-                    </a:p>
-                  </a:txBody>
-                </a:tc>
-              </a:tr>
-              <a:tr h="0">
-                <a:tc>
-                  <a:txBody>
-                    <a:bodyPr/>
-                    <a:lstStyle/>
-                    <a:p>
-                      <a:pPr lvl="0" indent="0" marL="0">
-                        <a:buNone/>
-                      </a:pPr>
-                      <a:r>
-                        <a:rPr/>
-                        <a:t>Adding 0.10 to the risk instead</a:t>
-                      </a:r>
-                    </a:p>
-                  </a:txBody>
-                </a:tc>
-                <a:tc>
-                  <a:txBody>
-                    <a:bodyPr/>
-                    <a:lstStyle/>
-                    <a:p>
-                      <a:pPr lvl="0" indent="0" marL="0">
-                        <a:buNone/>
-                      </a:pPr>
-                      <a:r>
-                        <a:rPr/>
-                        <a:t>60%</a:t>
-                      </a:r>
-                    </a:p>
-                  </a:txBody>
-                </a:tc>
-                <a:tc>
-                  <a:txBody>
-                    <a:bodyPr/>
-                    <a:lstStyle/>
-                    <a:p>
-                      <a:pPr lvl="0" indent="0" marL="0">
-                        <a:buNone/>
-                      </a:pPr>
-                      <a:r>
-                        <a:rPr/>
-                        <a:t>105%: impossible</a:t>
-                      </a:r>
-                    </a:p>
-                  </a:txBody>
-                </a:tc>
-              </a:tr>
-              <a:tr h="0">
-                <a:tc>
-                  <a:txBody>
-                    <a:bodyPr/>
-                    <a:lstStyle/>
-                    <a:p>
-                      <a:pPr lvl="0" indent="0" marL="0">
-                        <a:buNone/>
-                      </a:pPr>
-                      <a:r>
-                        <a:rPr/>
-                        <a:t>Odds = failing ÷ healthy, before and after</a:t>
-                      </a:r>
-                    </a:p>
-                  </a:txBody>
-                </a:tc>
-                <a:tc>
-                  <a:txBody>
-                    <a:bodyPr/>
-                    <a:lstStyle/>
-                    <a:p>
-                      <a:pPr lvl="0" indent="0" marL="0">
-                        <a:buNone/>
-                      </a:pPr>
-                      <a:r>
-                        <a:rPr/>
-                        <a:t>1, then 300 ÷ 50 = 6: × 6</a:t>
-                      </a:r>
-                    </a:p>
-                  </a:txBody>
-                </a:tc>
-                <a:tc>
-                  <a:txBody>
-                    <a:bodyPr/>
-                    <a:lstStyle/>
-                    <a:p>
-                      <a:pPr lvl="0" indent="0" marL="0">
-                        <a:buNone/>
-                      </a:pPr>
-                      <a:r>
-                        <a:rPr/>
-                        <a:t>19, then 570 ÷ 5 = 114: × 6</a:t>
-                      </a:r>
-                    </a:p>
-                  </a:txBody>
-                </a:tc>
-              </a:tr>
-            </a:tbl>
-          </a:graphicData>
-        </a:graphic>
-      </p:graphicFrame>
+      <p:pic>
+        <p:nvPicPr>
+          <p:cNvPr descr="evidence_on_the_sigmoid.png" id="0" name="Picture 1"/>
+          <p:cNvPicPr>
+            <a:picLocks noGrp="1" noChangeAspect="1"/>
+          </p:cNvPicPr>
+          <p:nvPr/>
+        </p:nvPicPr>
+        <p:blipFill>
+          <a:blip r:embed="rId3"/>
+          <a:stretch>
+            <a:fillRect/>
+          </a:stretch>
+        </p:blipFill>
+        <p:spPr bwMode="auto">
+          <a:xfrm>
+            <a:off x="1016752" y="1166099"/>
+            <a:ext cx="7110495" cy="3360181"/>
+          </a:xfrm>
+          <a:prstGeom prst="rect">
+            <a:avLst/>
+          </a:prstGeom>
+          <a:noFill/>
+          <a:ln w="9525">
+            <a:noFill/>
+            <a:headEnd/>
+            <a:tailEnd/>
+          </a:ln>
+        </p:spPr>
+      </p:pic>
     </p:spTree>
   </p:cSld>
 </p:sld>

</xml_diff>

<commit_message>
Show why a coefficient multiplies the odds on lesson 4's slide 13
The slide stated that exp(1.80) multiplies the odds by six without the
step that gives it. It now shows the sum on the log-odds becoming a product
on the odds; the handout's section 2.4 derives it and checks it on an
average drive.

Co-Authored-By: Claude Opus 5.5 <noreply@anthropic.com>
Claude-Session: https://claude.ai/code/session_01BdugDqEmUaYq1vzEjdPDKj
</commit_message>
<xml_diff>
--- a/Lessons/04_classification_and_metrics/Slides/classification_and_metrics_slides.pptx
+++ b/Lessons/04_classification_and_metrics/Slides/classification_and_metrics_slides.pptx
@@ -923,21 +923,63 @@
             </a:pPr>
             <a:r>
               <a:rPr/>
-              <a:t>This is the interpretability that keeps logistic regression in production in medicine and credit scoring. Standardising first (StandardScaler, lesson 3) puts every feature in the same unit, one standard deviation, so the coefficients can be compared with each other.</a:t>
-            </a:r>
-          </a:p>
-          <a:p>
-            <a:pPr lvl="0" indent="0" marL="0">
-              <a:buNone/>
-            </a:pPr>
-          </a:p>
-          <a:p>
-            <a:pPr lvl="0" indent="0" marL="0">
-              <a:buNone/>
-            </a:pPr>
-            <a:r>
-              <a:rPr/>
-              <a:t>1.80 is the true coefficient of reallocated_sectors, the one the data was generated with (next slide). It means: a drive one standard deviation worse on that counter has exp(1.80), about six times, the odds of failing. The fitted coefficient on the next slide is 1.66, a multiplier of 5.28.</a:t>
+              <a:t>This is the interpretability that keeps logistic regression in production in medicine and credit scoring. Three steps, one per bullet.</a:t>
+            </a:r>
+          </a:p>
+          <a:p>
+            <a:pPr lvl="0" indent="0" marL="0">
+              <a:buNone/>
+            </a:pPr>
+          </a:p>
+          <a:p>
+            <a:pPr lvl="0" indent="0" marL="0">
+              <a:buNone/>
+            </a:pPr>
+            <a:r>
+              <a:rPr/>
+              <a:t>First bullet, its first half. Standardising first (StandardScaler, lesson 3) puts every feature in the same unit, one standard deviation, so the coefficients can be compared with each other. For the four counters that the data puts on a logarithmic scale, it is one standard deviation of the transformed column.</a:t>
+            </a:r>
+          </a:p>
+          <a:p>
+            <a:pPr lvl="0" indent="0" marL="0">
+              <a:buNone/>
+            </a:pPr>
+          </a:p>
+          <a:p>
+            <a:pPr lvl="0" indent="0" marL="0">
+              <a:buNone/>
+            </a:pPr>
+            <a:r>
+              <a:rPr/>
+              <a:t>First bullet, its second half: this is slide 11’s line, log-odds = b + w1 x1 + … + w6 x6. Each feature contributes its coefficient times its value, so raising reallocated sectors by one standard deviation adds exactly its coefficient to the log-odds - 1.80 is the true coefficient, the one the data was generated with (next slide) - and it adds 1.80 whatever the other five counters say. That is what “linear” buys.</a:t>
+            </a:r>
+          </a:p>
+          <a:p>
+            <a:pPr lvl="0" indent="0" marL="0">
+              <a:buNone/>
+            </a:pPr>
+          </a:p>
+          <a:p>
+            <a:pPr lvl="0" indent="0" marL="0">
+              <a:buNone/>
+            </a:pPr>
+            <a:r>
+              <a:rPr/>
+              <a:t>Second bullet: why a sum on the log-odds becomes a product on the odds. The logarithm turns products into sums, log of a times b is log a plus log b. Read it backwards: adding 1.80 to the logarithm of the odds is the same as multiplying the odds by exp(1.80), which is 6.05. Check it on an average drive: its log-odds are the intercept, minus 6.20, so its odds are exp(-6.20) = 0.0020. One standard deviation more of reallocated sectors: log-odds minus 4.40, odds exp(-4.40) = 0.0123. Divide: 6.05.</a:t>
+            </a:r>
+          </a:p>
+          <a:p>
+            <a:pPr lvl="0" indent="0" marL="0">
+              <a:buNone/>
+            </a:pPr>
+          </a:p>
+          <a:p>
+            <a:pPr lvl="0" indent="0" marL="0">
+              <a:buNone/>
+            </a:pPr>
+            <a:r>
+              <a:rPr/>
+              <a:t>Third bullet: that is the arrow of slide 10’s figure. Every teal arrow was a multiplication of the odds by 6, and on the log-odds axis it had the same length - 1.79, almost exactly this coefficient. The fitted coefficient on the next slide is 1.66, a multiplier of 5.28.</a:t>
             </a:r>
           </a:p>
           <a:p>
@@ -10786,17 +10828,14 @@
             <a:pPr lvl="0"/>
             <a:r>
               <a:rPr/>
-              <a:t>The model is linear in the log-odds, log(p ÷ (1 − p)), so </a:t>
-            </a:r>
-            <a:r>
-              <a:rPr>
-                <a:latin typeface="Courier"/>
-              </a:rPr>
-              <a:t>exp(coefficient)</a:t>
-            </a:r>
-            <a:r>
-              <a:rPr/>
-              <a:t> multiplies the </a:t>
+              <a:t>Standardised: one standard deviation more of reallocated sectors adds 1.80 to the log-odds</a:t>
+            </a:r>
+          </a:p>
+          <a:p>
+            <a:pPr lvl="0"/>
+            <a:r>
+              <a:rPr/>
+              <a:t>Adding to a log multiplies the </a:t>
             </a:r>
             <a:r>
               <a:rPr b="1"/>
@@ -10804,21 +10843,14 @@
             </a:r>
             <a:r>
               <a:rPr/>
-              <a:t>, p ÷ (1 − p)</a:t>
+              <a:t>: log(odds) + 1.80 = log(odds × 6.05), since exp(1.80) = 6.05</a:t>
             </a:r>
           </a:p>
           <a:p>
             <a:pPr lvl="0"/>
             <a:r>
               <a:rPr/>
-              <a:t>Features standardised, so one unit = one standard deviation</a:t>
-            </a:r>
-          </a:p>
-          <a:p>
-            <a:pPr lvl="0"/>
-            <a:r>
-              <a:rPr/>
-              <a:t>A coefficient of 1.80 means </a:t>
+              <a:t>So: </a:t>
             </a:r>
             <a:r>
               <a:rPr b="1"/>
@@ -10826,7 +10858,7 @@
             </a:r>
             <a:r>
               <a:rPr/>
-              <a:t> of failing</a:t>
+              <a:t> of failing, slide 10’s teal step</a:t>
             </a:r>
           </a:p>
           <a:p>

</xml_diff>

<commit_message>
Show where every number in lesson 4 comes from
Slides, notes and handout now give each number its formula or its source:
306 / 8,000 = 3.8%, accuracy as right answers over 2,000, macro and
weighted F1 as the averages they are, costs as FN x 2,600 + FP x 140, the
generating formula behind the hundredfold rise. Also fixes the notebook-3
note pointing at slides 52 and 53 (now 53 and 54) and the handout's 'five
drives in six', which holds only for three classes.

Co-Authored-By: Claude Opus 5.5 <noreply@anthropic.com>
Claude-Session: https://claude.ai/code/session_01BdugDqEmUaYq1vzEjdPDKj
</commit_message>
<xml_diff>
--- a/Lessons/04_classification_and_metrics/Slides/classification_and_metrics_slides.pptx
+++ b/Lessons/04_classification_and_metrics/Slides/classification_and_metrics_slides.pptx
@@ -717,7 +717,7 @@
             </a:pPr>
             <a:r>
               <a:rPr/>
-              <a:t>Check it with a number from the handout’s table in section 2.3: a log-odds of +2.20 gives back 1 over (1 plus e to the minus 2.2), which is 0.90. A log-odds of 0 gives back exactly a half.</a:t>
+              <a:t>Check it with a number: a log-odds of +2.20 gives back 1 over (1 plus e to the minus 2.2) = 1 over (1 + 0.111) = 0.90. Going the other way, a probability of 0.90 is odds of 0.9 divided by 0.1 = 9, and log 9 = 2.20. A log-odds of 0 gives back exactly a half.</a:t>
             </a:r>
           </a:p>
           <a:p>
@@ -841,7 +841,7 @@
             </a:pPr>
             <a:r>
               <a:rPr/>
-              <a:t>That last one is the one to flag. It is largest in the middle, one quarter, and it decays to zero at both ends. That one fact does two jobs later. It is why the sigmoid behaves well: flat ends mean that once the model is sure, extra evidence changes little (slide 8). And it is why squared error fails with it: slide 24 shows that the same factor ends up inside squared error’s gradient and switches learning off exactly when the model is confidently wrong.</a:t>
+              <a:t>That last one is the one to flag. It is largest in the middle, at sigma = 0.5, where it is 0.5 times 0.5 = one quarter, and it decays to zero at both ends. That one fact does two jobs later. It is why the sigmoid behaves well: flat ends mean that once the model is sure, extra evidence changes little (slide 8). And it is why squared error fails with it: slide 24 shows that the same factor ends up inside squared error’s gradient and switches learning off exactly when the model is confidently wrong.</a:t>
             </a:r>
           </a:p>
         </p:txBody>
@@ -1007,7 +1007,7 @@
             </a:pPr>
             <a:r>
               <a:rPr/>
-              <a:t>Give them the counterexample out loud: odds of 9, a probability of 0.90, multiplied by 5 gives odds of 45 - a probability of 0.978. The odds went up fivefold; the probability moved eight points. Odds ratios multiply odds.</a:t>
+              <a:t>Give them the counterexample out loud: a probability of 0.90 is odds of 0.9 divided by 0.1 = 9; multiplied by 5 that gives odds of 45, which is a probability of 45 divided by 46 = 0.978. The odds went up fivefold; the probability moved eight points. Odds ratios multiply odds.</a:t>
             </a:r>
           </a:p>
         </p:txBody>
@@ -1117,7 +1117,7 @@
             </a:pPr>
             <a:r>
               <a:rPr/>
-              <a:t>Go down the column. Everything is close. Nothing is exact, and say why - 6,000 training drives carrying 230 failures is a modest amount of evidence, and 230 is the number that matters, not 6,000.</a:t>
+              <a:t>Go down the column. Everything is close. Nothing is exact, and say why - 6,000 training drives carrying 230 failures (306 in the fleet minus the 76 kept for the test set) is a modest amount of evidence, and 230 is the number that matters, not 6,000.</a:t>
             </a:r>
           </a:p>
           <a:p>
@@ -1847,7 +1847,7 @@
             </a:pPr>
             <a:r>
               <a:rPr/>
-              <a:t>Compare: 0.576 against 0.060. What actually happened is 9.6 times more probable under setting 1, so setting 1 explains the data better. Keep it.</a:t>
+              <a:t>Compare: 0.576 against 0.060. What actually happened is 0.576 divided by 0.060 = 9.6 times more probable under setting 1, so setting 1 explains the data better. Keep it.</a:t>
             </a:r>
           </a:p>
           <a:p>
@@ -2095,7 +2095,7 @@
             </a:pPr>
             <a:r>
               <a:rPr/>
-              <a:t>Two reasons we always work with the logarithm, worth saying aloud. A sum differentiates one term at a time. And the product itself is too small to store. Notebook 1’s gradient descent starts with every coefficient and the intercept at zero, so z is 0 for every drive and every p is 0.5. 0.5 multiplied by itself 6,000 times, once per training drive, is about 10 to the minus 1806, while the smallest positive number a 64-bit float can hold is about 5 times 10 to the minus 324. The computer would store exactly zero.</a:t>
+              <a:t>Two reasons we always work with the logarithm, worth saying aloud. A sum differentiates one term at a time. And the product itself is too small to store. Notebook 1’s gradient descent starts with every coefficient and the intercept at zero, so z is 0 for every drive and every p is 0.5. 0.5 multiplied by itself 6,000 times, once per training drive, is 10 to the power 6,000 times log10 of 0.5 = 6,000 times minus 0.301 = minus 1806, while the smallest positive number a 64-bit float can hold is about 5 times 10 to the minus 324. The computer would store exactly zero.</a:t>
             </a:r>
           </a:p>
           <a:p>
@@ -2495,7 +2495,7 @@
             </a:pPr>
             <a:r>
               <a:rPr/>
-              <a:t>Left panel, the costs. A drive failed and the model said 0.0001. Squared error charges 0.9998. An honest “don’t know” - 0.5 - costs 0.25. So the worst possible answer is four times worse than a shrug. Log loss charges 9.2 against 0.69, and the ratio grows without bound.</a:t>
+              <a:t>Left panel, the costs. A drive failed and the model said 0.0001. Squared error charges (0.0001 - 1) squared = 0.9998. An honest “don’t know” - 0.5 - costs (0.5 - 1) squared = 0.25. So the worst possible answer is four times worse than a shrug. Log loss charges minus log 0.0001 = 9.2 against minus log 0.5 = 0.69, and the ratio grows without bound.</a:t>
             </a:r>
           </a:p>
           <a:p>
@@ -2523,7 +2523,7 @@
             </a:pPr>
             <a:r>
               <a:rPr/>
-              <a:t>Say it as a sentence: the wronger the model gets, the less squared error asks it to change. At p = 0.001 the gradient is a five-hundredth of log loss’s. Log loss goes the other way, approaching its maximum push exactly where the error is worst.</a:t>
+              <a:t>Say it as a sentence: the wronger the model gets, the less squared error asks it to change. Divide one gradient by the other: squared error’s is log loss’s times 2p(1 - p). At p = 0.001 that factor is 2 times 0.001 times 0.999 = 0.002, a five-hundredth. Log loss goes the other way, approaching its maximum push exactly where the error is worst.</a:t>
             </a:r>
           </a:p>
           <a:p>
@@ -3111,21 +3111,21 @@
             </a:r>
             <a:r>
               <a:rPr/>
-              <a:t> - no learning, no data, no features - scores 96.20%. The model they just built, which finds more than half the failing drives, scores 97.70%. One and a half percentage points separate a real model from a worthless one.</a:t>
-            </a:r>
-          </a:p>
-          <a:p>
-            <a:pPr lvl="0" indent="0" marL="0">
-              <a:buNone/>
-            </a:pPr>
-          </a:p>
-          <a:p>
-            <a:pPr lvl="0" indent="0" marL="0">
-              <a:buNone/>
-            </a:pPr>
-            <a:r>
-              <a:rPr/>
-              <a:t>The arithmetic is not subtle: 1,924 of the 2,000 test drives are healthy, so answering “healthy” collects them all for free. Only 3.8% of the test set is left to compete over.</a:t>
+              <a:t> - no learning, no data, no features - scores 96.20%. The model they just built, which finds more than half the failing drives, scores 97.70%. 97.70 minus 96.20: one and a half percentage points separate a real model from a worthless one.</a:t>
+            </a:r>
+          </a:p>
+          <a:p>
+            <a:pPr lvl="0" indent="0" marL="0">
+              <a:buNone/>
+            </a:pPr>
+          </a:p>
+          <a:p>
+            <a:pPr lvl="0" indent="0" marL="0">
+              <a:buNone/>
+            </a:pPr>
+            <a:r>
+              <a:rPr/>
+              <a:t>The arithmetic is not subtle: 1,924 of the 2,000 test drives are healthy, so answering “healthy” collects them all for free. Only the 76 failures, 76 divided by 2,000 = 3.8% of the test set, are left to compete over.</a:t>
             </a:r>
           </a:p>
           <a:p>
@@ -3249,7 +3249,7 @@
             </a:pPr>
             <a:r>
               <a:rPr/>
-              <a:t>The general statement, worth putting on the board: if a share pi of the cases are positive (the positive rate), the trivial always-negative classifier scores 1 minus pi. Here 96.2%. In some fraud problems, where the rate is one in a thousand, 99.9%.</a:t>
+              <a:t>The general statement, worth putting on the board: if a share pi of the cases are positive (the positive rate), the trivial always-negative classifier scores 1 minus pi. Here 1 - 0.038 = 96.2%. In some fraud problems, where the rate is one in a thousand, 1 - 0.001 = 99.9%.</a:t>
             </a:r>
           </a:p>
           <a:p>
@@ -3993,7 +3993,7 @@
             </a:pPr>
             <a:r>
               <a:rPr/>
-              <a:t>Mention F-beta in one sentence: a version of F1 with a weight beta, where beta above 1 counts recall more than precision. That is what you want here, where a miss costs about nineteen times a false alarm (2,600 against 140 euros). F2 is the usual choice.</a:t>
+              <a:t>Mention F-beta in one sentence: a version of F1 with a weight beta, where beta above 1 counts recall more than precision. That is what you want here, where a miss costs about nineteen times a false alarm (2,600 divided by 140 = 18.6). F2 is the usual choice.</a:t>
             </a:r>
           </a:p>
         </p:txBody>
@@ -4337,7 +4337,7 @@
             </a:pPr>
             <a:r>
               <a:rPr/>
-              <a:t>That 0.5 is predict()’s default and nothing more. It is the right choice only when the two errors cost the same and the probabilities are calibrated: among drives given 0.3, about 30% really fail (slide 44 names the property). Slide 49 derives the threshold from the costs, and it is 0.5 exactly when they are equal. Here a miss costs about nineteen times a false alarm, and in most real problems the costs differ too.</a:t>
+              <a:t>That 0.5 is predict()’s default and nothing more. It is the right choice only when the two errors cost the same and the probabilities are calibrated: among drives given 0.3, about 30% really fail (slide 44 names the property). Slide 49 derives the threshold from the costs, and it is 0.5 exactly when they are equal. Here a miss costs about nineteen times a false alarm (2,600 divided by 140 = 18.6), and in most real problems the costs differ too.</a:t>
             </a:r>
           </a:p>
           <a:p>
@@ -4447,35 +4447,35 @@
             </a:pPr>
             <a:r>
               <a:rPr/>
-              <a:t>Lower the threshold: recall rises, precision falls. At 0.02 we catch 69 of 76 failures and replace 284 healthy drives to do it. At 0.90 every alarm is justified and we catch fewer than a quarter.</a:t>
-            </a:r>
-          </a:p>
-          <a:p>
-            <a:pPr lvl="0" indent="0" marL="0">
-              <a:buNone/>
-            </a:pPr>
-          </a:p>
-          <a:p>
-            <a:pPr lvl="0" indent="0" marL="0">
-              <a:buNone/>
-            </a:pPr>
-            <a:r>
-              <a:rPr/>
-              <a:t>Now the accuracy column, which is the slide’s real argument. From 0.10 upwards it moves by three and a half percentage points, 0.942 to 0.977, while recall falls from 0.803 to 0.184. And its maximum is at 0.5 - the threshold that misses 33 of the 76 failures.</a:t>
-            </a:r>
-          </a:p>
-          <a:p>
-            <a:pPr lvl="0" indent="0" marL="0">
-              <a:buNone/>
-            </a:pPr>
-          </a:p>
-          <a:p>
-            <a:pPr lvl="0" indent="0" marL="0">
-              <a:buNone/>
-            </a:pPr>
-            <a:r>
-              <a:rPr/>
-              <a:t>Say the consequence plainly: tune on accuracy and it will quietly recommend catching fewer failures. Most of the alarms a higher threshold drops are false ones, so accuracy rises with each drop, even though some of the dropped alarms were failures being caught. From 0.30 to 0.50 the model drops 22 alarms: 12 were false and 10 were caught failures. Accuracy counts that as two more right answers, 0.976 to 0.977.</a:t>
+              <a:t>Lower the threshold: recall rises, precision falls. At 0.02 we catch 69 of 76 failures and replace 284 healthy drives to do it. At 0.90 every alarm is justified and we catch 14 of 76, fewer than a quarter.</a:t>
+            </a:r>
+          </a:p>
+          <a:p>
+            <a:pPr lvl="0" indent="0" marL="0">
+              <a:buNone/>
+            </a:pPr>
+          </a:p>
+          <a:p>
+            <a:pPr lvl="0" indent="0" marL="0">
+              <a:buNone/>
+            </a:pPr>
+            <a:r>
+              <a:rPr/>
+              <a:t>Now the accuracy column, which is the slide’s real argument. From 0.10 upwards it moves by 0.977 - 0.942 = 0.035, three and a half percentage points, while recall falls from 0.803 to 0.184. And its maximum is at 0.5 - the threshold that misses 33 of the 76 failures.</a:t>
+            </a:r>
+          </a:p>
+          <a:p>
+            <a:pPr lvl="0" indent="0" marL="0">
+              <a:buNone/>
+            </a:pPr>
+          </a:p>
+          <a:p>
+            <a:pPr lvl="0" indent="0" marL="0">
+              <a:buNone/>
+            </a:pPr>
+            <a:r>
+              <a:rPr/>
+              <a:t>Say the consequence plainly: tune on accuracy and it will quietly recommend catching fewer failures. Most of the alarms a higher threshold drops are false ones, so accuracy rises with each drop, even though some of the dropped alarms were failures being caught. From 0.30 to 0.50 the alarms go from 53 + 25 = 78 to 43 + 13 = 56, 22 fewer: 25 - 13 = 12 were false and 53 - 43 = 10 were caught failures. Accuracy gains 12 right answers and loses 10, two more in all, 0.976 to 0.977.</a:t>
             </a:r>
           </a:p>
         </p:txBody>
@@ -4571,7 +4571,7 @@
             </a:pPr>
             <a:r>
               <a:rPr/>
-              <a:t>The part to teach is the baseline. A model with random scores has precision equal to the positive rate - 0.038 here - at every recall. That flat dashed line, not 0.5, is what “no skill” looks like on an imbalanced problem.</a:t>
+              <a:t>The part to teach is the baseline. A model with random scores has precision equal to the positive rate - 76 failures divided by 2,000 drives = 0.038 here - at every recall. That flat dashed line, not 0.5, is what “no skill” looks like on an imbalanced problem.</a:t>
             </a:r>
           </a:p>
           <a:p>
@@ -5315,7 +5315,7 @@
             </a:pPr>
             <a:r>
               <a:rPr/>
-              <a:t>Right panel: the precision-recall curves are in three different worlds. Average precision falls from 0.706 to 0.361, and precision at the threshold of 0.5 falls from 0.79 to 0.26 - three alarms in four now false.</a:t>
+              <a:t>Right panel: the precision-recall curves are in three different worlds. Average precision falls from 0.706 to 0.361, and precision at the threshold of 0.5 falls from 0.79 to 0.26 - 1 - 0.26 = 0.74, three alarms in four now false.</a:t>
             </a:r>
           </a:p>
           <a:p>
@@ -5659,7 +5659,7 @@
             </a:pPr>
             <a:r>
               <a:rPr/>
-              <a:t>Choosing the threshold on purpose HALVED the cost of the same model. No retraining, no new features, no better algorithm. One number, taken from the economics instead of from the library default.</a:t>
+              <a:t>Choosing the threshold on purpose HALVED the cost of the same model: 45,540 divided by 87,620 is 0.52. No retraining, no new features, no better algorithm. One number, taken from the economics instead of from the library default.</a:t>
             </a:r>
           </a:p>
           <a:p>
@@ -6127,7 +6127,7 @@
             </a:pPr>
             <a:r>
               <a:rPr/>
-              <a:t>class_weight=“balanced” makes each failed drive count, in the cost, as much as about 25 healthy ones - the ratio of healthy to failed drives in the training set. It changes the training rather than the decision.</a:t>
+              <a:t>class_weight=“balanced” makes each failed drive count, in the cost, as much as about 25 healthy ones - the ratio of healthy to failed drives in the training set, (6,000 - 230) divided by 230 = 25. It changes the training rather than the decision.</a:t>
             </a:r>
           </a:p>
           <a:p>
@@ -6265,7 +6265,7 @@
             </a:pPr>
             <a:r>
               <a:rPr/>
-              <a:t>The ROC curve by hand, the 200,000-pair experiment, the cost curve, then the multiclass matrix. Run notebook 03. Fifteen minutes, and the two multiclass slides that follow (52 and 53) are shown when the notebook reaches its last section, so they run alongside it rather than after it.</a:t>
+              <a:t>The ROC curve by hand, the 200,000-pair experiment, the cost curve, then the multiclass matrix. Run notebook 03. Fifteen minutes, and the two multiclass slides that follow (53 and 54) are shown when the notebook reaches its last section, so they run alongside it rather than after it.</a:t>
             </a:r>
           </a:p>
           <a:p>
@@ -6499,7 +6499,7 @@
             </a:pPr>
             <a:r>
               <a:rPr/>
-              <a:t>Macro treats the three conditions as equally important. Weighted lets the healthy class - five drives in six - do most of the talking.</a:t>
+              <a:t>Macro treats the three conditions as equally important. Weighted lets the healthy class - 1,665 of 2,000, five drives in six - do most of the talking.</a:t>
             </a:r>
           </a:p>
           <a:p>
@@ -6843,7 +6843,7 @@
             </a:pPr>
             <a:r>
               <a:rPr/>
-              <a:t>The left panel: the fitted line gives a NEGATIVE probability to 3,606 of the 8,000 drives - 45% of the fleet. Not a small negative number. A negative probability. And extend it slightly past the data, to 32 reallocated sectors, and it predicts more than 1.</a:t>
+              <a:t>The left panel: the fitted line gives a NEGATIVE probability to 3,606 of the 8,000 drives - 3,606 divided by 8,000 is 45% of the fleet. Not a small negative number. A negative probability. And extend it slightly past the data, to 32 reallocated sectors, and it predicts more than 1 (notebook 1 prints the line; the worst drive has 28).</a:t>
             </a:r>
           </a:p>
           <a:p>
@@ -6967,49 +6967,49 @@
             </a:pPr>
             <a:r>
               <a:rPr/>
-              <a:t>Steep in the middle, flat at both ends. Make the case that the flatness is the right behaviour, not a compromise - and be precise about what is diminishing. It is the total evidence z, not any one counter. Two more units of z starting from z = 0 take the probability from 0.50 to 0.88; the same two units starting from z = 6 take it from 0.9975 to 0.9997, 178 times less. Once the model is nearly sure, more evidence barely changes its answer.</a:t>
-            </a:r>
-          </a:p>
-          <a:p>
-            <a:pPr lvl="0" indent="0" marL="0">
-              <a:buNone/>
-            </a:pPr>
-          </a:p>
-          <a:p>
-            <a:pPr lvl="0" indent="0" marL="0">
-              <a:buNone/>
-            </a:pPr>
-            <a:r>
-              <a:rPr/>
-              <a:t>Expect someone to object with slide 7’s right panel. That curve barely moves over the first few reallocated sectors, where 90% of the drives sit - the first four move it by 0.03 - and it is steepest at 13.2 sectors. So do the first sectors say little? Two separate answers, in this order.</a:t>
-            </a:r>
-          </a:p>
-          <a:p>
-            <a:pPr lvl="0" indent="0" marL="0">
-              <a:buNone/>
-            </a:pPr>
-          </a:p>
-          <a:p>
-            <a:pPr lvl="0" indent="0" marL="0">
-              <a:buNone/>
-            </a:pPr>
-            <a:r>
-              <a:rPr/>
-              <a:t>First, it is the same sigmoid, drawn against a different axis. Slide 7’s model has one input, the raw count of reallocated sectors, so its z is a straight line in the count: z = 0.336 times the count, minus 4.43. With no sectors z is already -4.43, deep in the flat left end of this slide’s curve; z reaches 0, the steep middle, at 13.2 sectors. The flat start of slide 7 is the flat left end of slide 8, with sectors on the axis instead of z.</a:t>
-            </a:r>
-          </a:p>
-          <a:p>
-            <a:pPr lvl="0" indent="0" marL="0">
-              <a:buNone/>
-            </a:pPr>
-          </a:p>
-          <a:p>
-            <a:pPr lvl="0" indent="0" marL="0">
-              <a:buNone/>
-            </a:pPr>
-            <a:r>
-              <a:rPr/>
-              <a:t>Second, the flat start comes from using the raw count, not from the drives. A straight line gives every sector the same 0.336 of z, so for that model the first four sectors add 1.34 to z and take a drive from 1.2% to 4.4%. But the labels were generated from log(1 + count), on which the first sectors weigh the most (handout section 1.1): for a drive whose other counters are average, the first four sectors add 4.7 to z and take it from 0.012% to 1.3%, about a hundred times more. That is why the six-counter model of slide 12 onwards takes log(1 + count) as its input.</a:t>
+              <a:t>Steep in the middle, flat at both ends. Make the case that the flatness is the right behaviour, not a compromise - and be precise about what is diminishing. It is the total evidence z, not any one counter. Two more units of z starting from z = 0 take the probability from sigma(0) = 0.50 to sigma(2) = 1 over (1 + e to the minus 2) = 0.88, a rise of 0.38; the same two units starting from z = 6 take it from sigma(6) = 0.9975 to sigma(8) = 0.9997, a rise of 0.0021 - 0.38 divided by 0.0021 is 178 times less. Once the model is nearly sure, more evidence barely changes its answer.</a:t>
+            </a:r>
+          </a:p>
+          <a:p>
+            <a:pPr lvl="0" indent="0" marL="0">
+              <a:buNone/>
+            </a:pPr>
+          </a:p>
+          <a:p>
+            <a:pPr lvl="0" indent="0" marL="0">
+              <a:buNone/>
+            </a:pPr>
+            <a:r>
+              <a:rPr/>
+              <a:t>Expect someone to object with slide 7’s right panel. That curve barely moves over the first few reallocated sectors, where 90% of the drives sit (handout section 1.1) - the first four move it from 1.2% to 4.4%, by 0.03 - and it is steepest at 13.2 sectors. So do the first sectors say little? Two separate answers, in this order.</a:t>
+            </a:r>
+          </a:p>
+          <a:p>
+            <a:pPr lvl="0" indent="0" marL="0">
+              <a:buNone/>
+            </a:pPr>
+          </a:p>
+          <a:p>
+            <a:pPr lvl="0" indent="0" marL="0">
+              <a:buNone/>
+            </a:pPr>
+            <a:r>
+              <a:rPr/>
+              <a:t>First, it is the same sigmoid, drawn against a different axis. Slide 7’s model has one input, the raw count of reallocated sectors, so its z is a straight line in the count: z = 0.336 times the count, minus 4.43. With no sectors z is already -4.43, deep in the flat left end of this slide’s curve; z reaches 0, the steep middle, where 0.336 times the count equals 4.43: at 4.43 divided by 0.336 = 13.2 sectors. The flat start of slide 7 is the flat left end of slide 8, with sectors on the axis instead of z.</a:t>
+            </a:r>
+          </a:p>
+          <a:p>
+            <a:pPr lvl="0" indent="0" marL="0">
+              <a:buNone/>
+            </a:pPr>
+          </a:p>
+          <a:p>
+            <a:pPr lvl="0" indent="0" marL="0">
+              <a:buNone/>
+            </a:pPr>
+            <a:r>
+              <a:rPr/>
+              <a:t>Second, the flat start comes from using the raw count, not from the drives. A straight line gives every sector the same 0.336 of z, so for that model the first four sectors add 4 times 0.336 = 1.34 to z and take a drive from sigma(-4.43) = 1.2% to sigma(-4.43 + 1.34) = sigma(-3.09) = 4.4%. But the labels were generated from log(1 + count), on which the first sectors weigh the most (handout section 1.1): for a drive whose other counters are average, the first four sectors add 4.7 to z and take it from 0.012% to 1.3%, about a hundred times more. That is why the six-counter model of slide 12 onwards takes log(1 + count) as its input.</a:t>
             </a:r>
           </a:p>
           <a:p>
@@ -7133,7 +7133,7 @@
             </a:pPr>
             <a:r>
               <a:rPr/>
-              <a:t>This slide puts in words what the right panel of slide 8 shows. Go through the two steps slowly; each removes one limit. Odds: a probability of 0.2 is odds of 0.25, and as the probability approaches 1 the odds run off to infinity - no ceiling. But odds are never negative, so there is still a floor at 0. The logarithm sends 0 to minus infinity, and the floor is gone too.</a:t>
+              <a:t>This slide puts in words what the right panel of slide 8 shows. Go through the two steps slowly; each removes one limit. Odds: a probability of 0.2 is odds of 0.2 divided by 0.8 = 0.25, and as the probability approaches 1 the odds run off to infinity - no ceiling. But odds are never negative, so there is still a floor at 0. The logarithm sends 0 to minus infinity, and the floor is gone too.</a:t>
             </a:r>
           </a:p>
           <a:p>
@@ -10997,7 +10997,7 @@
                       </a:pPr>
                       <a:r>
                         <a:rPr/>
-                        <a:t>Fitted</a:t>
+                        <a:t>Fitted, notebook 1</a:t>
                       </a:r>
                     </a:p>
                   </a:txBody>
@@ -11013,7 +11013,7 @@
                       </a:pPr>
                       <a:r>
                         <a:rPr/>
-                        <a:t>Odds ×</a:t>
+                        <a:t>Odds ×, exp(Fitted)</a:t>
                       </a:r>
                     </a:p>
                   </a:txBody>
@@ -11477,19 +11477,23 @@
               <a:rPr b="1"/>
               <a:t>−6.09</a:t>
             </a:r>
+            <a:r>
+              <a:rPr/>
+              <a:t>, the log-odds of a drive average on every counter (all x = 0)</a:t>
+            </a:r>
           </a:p>
           <a:p>
             <a:pPr lvl="0"/>
             <a:r>
               <a:rPr/>
-              <a:t>σ(-6.09) = 0.0023: a 0.2% chance for a drive average on every counter</a:t>
+              <a:t>σ(−6.09) = 1 ÷ (1 + exp(6.09)) = 1 ÷ 442 = 0.0023: a 0.2% chance</a:t>
             </a:r>
           </a:p>
           <a:p>
             <a:pPr lvl="0"/>
             <a:r>
               <a:rPr/>
-              <a:t>The fleet fails at 3.8%: the failures come from the few drives far above average</a:t>
+              <a:t>The fleet fails at 3.8% (slide 6): the failures come from the few drives far above average</a:t>
             </a:r>
           </a:p>
         </p:txBody>
@@ -12798,7 +12802,7 @@
                       </a:pPr>
                       <a:r>
                         <a:rPr/>
-                        <a:t>0.9</a:t>
+                        <a:t>1 − 0.1 = 0.9</a:t>
                       </a:r>
                     </a:p>
                   </a:txBody>
@@ -12828,7 +12832,7 @@
                       </a:pPr>
                       <a:r>
                         <a:rPr/>
-                        <a:t>0.4</a:t>
+                        <a:t>1 − 0.6 = 0.4</a:t>
                       </a:r>
                     </a:p>
                   </a:txBody>
@@ -12890,7 +12894,7 @@
                       </a:pPr>
                       <a:r>
                         <a:rPr/>
-                        <a:t>0.8</a:t>
+                        <a:t>1 − 0.2 = 0.8</a:t>
                       </a:r>
                     </a:p>
                   </a:txBody>
@@ -12920,7 +12924,7 @@
                       </a:pPr>
                       <a:r>
                         <a:rPr/>
-                        <a:t>0.5</a:t>
+                        <a:t>1 − 0.5 = 0.5</a:t>
                       </a:r>
                     </a:p>
                   </a:txBody>
@@ -12969,6 +12973,10 @@
                         <a:buNone/>
                       </a:pPr>
                       <a:r>
+                        <a:rPr/>
+                        <a:t>0.8 × 0.9 × 0.8 = </a:t>
+                      </a:r>
+                      <a:r>
                         <a:rPr b="1"/>
                         <a:t>0.576</a:t>
                       </a:r>
@@ -12992,6 +13000,10 @@
                       <a:pPr lvl="0" indent="0" marL="0">
                         <a:buNone/>
                       </a:pPr>
+                      <a:r>
+                        <a:rPr/>
+                        <a:t>0.3 × 0.4 × 0.5 = </a:t>
+                      </a:r>
                       <a:r>
                         <a:rPr b="1"/>
                         <a:t>0.060</a:t>
@@ -13368,6 +13380,10 @@
                         <a:buNone/>
                       </a:pPr>
                       <a:r>
+                        <a:rPr/>
+                        <a:t>0.22 + 0.11 + 0.22 = </a:t>
+                      </a:r>
+                      <a:r>
                         <a:rPr b="1"/>
                         <a:t>0.55</a:t>
                       </a:r>
@@ -13382,6 +13398,10 @@
                       <a:pPr lvl="0" indent="0" marL="0">
                         <a:buNone/>
                       </a:pPr>
+                      <a:r>
+                        <a:rPr/>
+                        <a:t>1.20 + 0.92 + 0.69 = </a:t>
+                      </a:r>
                       <a:r>
                         <a:rPr b="1"/>
                         <a:t>2.81</a:t>
@@ -14313,7 +14333,7 @@
                       </a:pPr>
                       <a:r>
                         <a:rPr/>
-                        <a:t>Model</a:t>
+                        <a:t>Model, on the 2,000 test drives (76 fail)</a:t>
                       </a:r>
                     </a:p>
                   </a:txBody>
@@ -14329,7 +14349,7 @@
                       </a:pPr>
                       <a:r>
                         <a:rPr/>
-                        <a:t>Accuracy</a:t>
+                        <a:t>Accuracy = right ÷ 2,000</a:t>
                       </a:r>
                     </a:p>
                   </a:txBody>
@@ -14377,6 +14397,10 @@
                         <a:buNone/>
                       </a:pPr>
                       <a:r>
+                        <a:rPr/>
+                        <a:t>every healthy drive: 1,924 ÷ 2,000 = </a:t>
+                      </a:r>
+                      <a:r>
                         <a:rPr b="1"/>
                         <a:t>96.20%</a:t>
                       </a:r>
@@ -14425,7 +14449,7 @@
                       </a:pPr>
                       <a:r>
                         <a:rPr/>
-                        <a:t>97.70%</a:t>
+                        <a:t>43 failures + 1,911 healthy: 1,954 ÷ 2,000 = 97.70%</a:t>
                       </a:r>
                     </a:p>
                   </a:txBody>
@@ -14843,6 +14867,13 @@
               <a:t>: a drive dies in service. Callout, rebuild, risk, €2,600</a:t>
             </a:r>
           </a:p>
+          <a:p>
+            <a:pPr lvl="0"/>
+            <a:r>
+              <a:rPr/>
+              <a:t>Both costs are assumptions supplied from outside the data, not measured</a:t>
+            </a:r>
+          </a:p>
         </p:txBody>
       </p:sp>
     </p:spTree>
@@ -15009,7 +15040,7 @@
             <a:pPr lvl="0"/>
             <a:r>
               <a:rPr/>
-              <a:t>Precision = TP ÷ (TP + FP) = 43 ÷ 56 = </a:t>
+              <a:t>Precision = TP ÷ (TP + FP) = 43 ÷ (43 + 13) = </a:t>
             </a:r>
             <a:r>
               <a:rPr b="1"/>
@@ -15024,7 +15055,7 @@
             <a:pPr lvl="0"/>
             <a:r>
               <a:rPr/>
-              <a:t>Recall = TP ÷ (TP + FN) = 43 ÷ 76 = </a:t>
+              <a:t>Recall = TP ÷ (TP + FN) = 43 ÷ (43 + 33) = </a:t>
             </a:r>
             <a:r>
               <a:rPr b="1"/>
@@ -15039,7 +15070,7 @@
             <a:pPr lvl="0"/>
             <a:r>
               <a:rPr/>
-              <a:t>Specificity = TN ÷ (TN + FP) = 1,911 ÷ 1,924 = 0.993</a:t>
+              <a:t>Specificity = TN ÷ (TN + FP) = 1,911 ÷ (1,911 + 13) = 0.993</a:t>
             </a:r>
           </a:p>
           <a:p>
@@ -15254,49 +15285,53 @@
                       </a:pPr>
                       <a:r>
                         <a:rPr/>
-                        <a:t>0.038</a:t>
-                      </a:r>
-                    </a:p>
-                  </a:txBody>
-                </a:tc>
-                <a:tc>
-                  <a:txBody>
-                    <a:bodyPr/>
-                    <a:lstStyle/>
-                    <a:p>
-                      <a:pPr lvl="0" indent="0" marL="0">
-                        <a:buNone/>
-                      </a:pPr>
-                      <a:r>
-                        <a:rPr/>
-                        <a:t>1.000</a:t>
-                      </a:r>
-                    </a:p>
-                  </a:txBody>
-                </a:tc>
-                <a:tc>
-                  <a:txBody>
-                    <a:bodyPr/>
-                    <a:lstStyle/>
-                    <a:p>
-                      <a:pPr lvl="0" indent="0" marL="0">
-                        <a:buNone/>
-                      </a:pPr>
-                      <a:r>
-                        <a:rPr/>
-                        <a:t>0.519</a:t>
-                      </a:r>
-                    </a:p>
-                  </a:txBody>
-                </a:tc>
-                <a:tc>
-                  <a:txBody>
-                    <a:bodyPr/>
-                    <a:lstStyle/>
-                    <a:p>
-                      <a:pPr lvl="0" indent="0" marL="0">
-                        <a:buNone/>
-                      </a:pPr>
+                        <a:t>76 ÷ 2,000 = 0.038</a:t>
+                      </a:r>
+                    </a:p>
+                  </a:txBody>
+                </a:tc>
+                <a:tc>
+                  <a:txBody>
+                    <a:bodyPr/>
+                    <a:lstStyle/>
+                    <a:p>
+                      <a:pPr lvl="0" indent="0" marL="0">
+                        <a:buNone/>
+                      </a:pPr>
+                      <a:r>
+                        <a:rPr/>
+                        <a:t>76 ÷ 76 = 1</a:t>
+                      </a:r>
+                    </a:p>
+                  </a:txBody>
+                </a:tc>
+                <a:tc>
+                  <a:txBody>
+                    <a:bodyPr/>
+                    <a:lstStyle/>
+                    <a:p>
+                      <a:pPr lvl="0" indent="0" marL="0">
+                        <a:buNone/>
+                      </a:pPr>
+                      <a:r>
+                        <a:rPr/>
+                        <a:t>(0.038 + 1) ÷ 2 = 0.519</a:t>
+                      </a:r>
+                    </a:p>
+                  </a:txBody>
+                </a:tc>
+                <a:tc>
+                  <a:txBody>
+                    <a:bodyPr/>
+                    <a:lstStyle/>
+                    <a:p>
+                      <a:pPr lvl="0" indent="0" marL="0">
+                        <a:buNone/>
+                      </a:pPr>
+                      <a:r>
+                        <a:rPr/>
+                        <a:t>2 × 0.038 × 1 ÷ 1.038 = </a:t>
+                      </a:r>
                       <a:r>
                         <a:rPr b="1"/>
                         <a:t>0.073</a:t>
@@ -15383,6 +15418,34 @@
           <a:p>
             <a:pPr lvl="0"/>
             <a:r>
+              <a:rPr/>
+              <a:t>F1 per class: healthy 0.988 (1,924 drives), failed 0.652 (76 drives)</a:t>
+            </a:r>
+          </a:p>
+          <a:p>
+            <a:pPr lvl="0"/>
+            <a:r>
+              <a:rPr>
+                <a:latin typeface="Courier"/>
+              </a:rPr>
+              <a:t>macro avg</a:t>
+            </a:r>
+            <a:r>
+              <a:rPr/>
+              <a:t> F1 = (0.988 + 0.652) ÷ 2 = </a:t>
+            </a:r>
+            <a:r>
+              <a:rPr b="1"/>
+              <a:t>0.820</a:t>
+            </a:r>
+            <a:r>
+              <a:rPr/>
+              <a:t>: both classes count the same</a:t>
+            </a:r>
+          </a:p>
+          <a:p>
+            <a:pPr lvl="0"/>
+            <a:r>
               <a:rPr>
                 <a:latin typeface="Courier"/>
               </a:rPr>
@@ -15390,7 +15453,7 @@
             </a:r>
             <a:r>
               <a:rPr/>
-              <a:t> F1: </a:t>
+              <a:t> F1 = (1,924 × 0.988 + 76 × 0.652) ÷ 2,000 = </a:t>
             </a:r>
             <a:r>
               <a:rPr b="1"/>
@@ -15398,28 +15461,7 @@
             </a:r>
             <a:r>
               <a:rPr/>
-              <a:t> (dominated by the healthy class)</a:t>
-            </a:r>
-          </a:p>
-          <a:p>
-            <a:pPr lvl="0"/>
-            <a:r>
-              <a:rPr>
-                <a:latin typeface="Courier"/>
-              </a:rPr>
-              <a:t>macro avg</a:t>
-            </a:r>
-            <a:r>
-              <a:rPr/>
-              <a:t> F1: </a:t>
-            </a:r>
-            <a:r>
-              <a:rPr b="1"/>
-              <a:t>0.820</a:t>
-            </a:r>
-            <a:r>
-              <a:rPr/>
-              <a:t> (both classes get an equal say)</a:t>
+              <a:t>: the healthy class dominates</a:t>
             </a:r>
           </a:p>
           <a:p>
@@ -16033,7 +16075,7 @@
                       </a:pPr>
                       <a:r>
                         <a:rPr/>
-                        <a:t>Precision</a:t>
+                        <a:t>Precision, TP ÷ (TP + FP)</a:t>
                       </a:r>
                     </a:p>
                   </a:txBody>
@@ -16049,7 +16091,7 @@
                       </a:pPr>
                       <a:r>
                         <a:rPr/>
-                        <a:t>Recall</a:t>
+                        <a:t>Recall, TP ÷ (TP + FN)</a:t>
                       </a:r>
                     </a:p>
                   </a:txBody>
@@ -16065,7 +16107,7 @@
                       </a:pPr>
                       <a:r>
                         <a:rPr/>
-                        <a:t>Accuracy</a:t>
+                        <a:t>Accuracy, (TP + TN) ÷ 2,000</a:t>
                       </a:r>
                     </a:p>
                   </a:txBody>
@@ -17061,7 +17103,24 @@
             <a:pPr lvl="0"/>
             <a:r>
               <a:rPr/>
-              <a:t>Ours: 0.949</a:t>
+              <a:t>Ours: 0.949 (</a:t>
+            </a:r>
+            <a:r>
+              <a:rPr>
+                <a:latin typeface="Courier"/>
+              </a:rPr>
+              <a:t>roc_auc_score</a:t>
+            </a:r>
+            <a:r>
+              <a:rPr/>
+              <a:t>, notebook 3)</a:t>
+            </a:r>
+          </a:p>
+          <a:p>
+            <a:pPr lvl="0"/>
+            <a:r>
+              <a:rPr/>
+              <a:t>Check: in 200,000 random pairs, the failing drive scores higher 94.9% of the time</a:t>
             </a:r>
           </a:p>
           <a:p>
@@ -17470,7 +17529,7 @@
             </a:r>
             <a:r>
               <a:rPr/>
-              <a:t>: 0.717 here, against a floor of 0.038</a:t>
+              <a:t>: 0.717 here, against 0.038 = 76 ÷ 2,000 for a model that ranks at random</a:t>
             </a:r>
           </a:p>
         </p:txBody>
@@ -17954,7 +18013,7 @@
                       </a:pPr>
                       <a:r>
                         <a:rPr/>
-                        <a:t>Recall</a:t>
+                        <a:t>Failures missed, FN</a:t>
                       </a:r>
                     </a:p>
                   </a:txBody>
@@ -17970,7 +18029,7 @@
                       </a:pPr>
                       <a:r>
                         <a:rPr/>
-                        <a:t>Precision</a:t>
+                        <a:t>False alarms, FP</a:t>
                       </a:r>
                     </a:p>
                   </a:txBody>
@@ -17986,23 +18045,23 @@
                       </a:pPr>
                       <a:r>
                         <a:rPr/>
+                        <a:t>Cost = FN × €2,600 + FP × €140</a:t>
+                      </a:r>
+                    </a:p>
+                  </a:txBody>
+                  <a:tcPr/>
+                </a:tc>
+                <a:tc>
+                  <a:txBody>
+                    <a:bodyPr/>
+                    <a:lstStyle/>
+                    <a:p>
+                      <a:pPr lvl="0" indent="0" marL="0">
+                        <a:buNone/>
+                      </a:pPr>
+                      <a:r>
+                        <a:rPr/>
                         <a:t>AUC</a:t>
-                      </a:r>
-                    </a:p>
-                  </a:txBody>
-                  <a:tcPr/>
-                </a:tc>
-                <a:tc>
-                  <a:txBody>
-                    <a:bodyPr/>
-                    <a:lstStyle/>
-                    <a:p>
-                      <a:pPr lvl="0" indent="0" marL="0">
-                        <a:buNone/>
-                      </a:pPr>
-                      <a:r>
-                        <a:rPr/>
-                        <a:t>Cost</a:t>
                       </a:r>
                     </a:p>
                   </a:txBody>
@@ -18035,22 +18094,37 @@
                       </a:pPr>
                       <a:r>
                         <a:rPr/>
-                        <a:t>0.566</a:t>
-                      </a:r>
-                    </a:p>
-                  </a:txBody>
-                </a:tc>
-                <a:tc>
-                  <a:txBody>
-                    <a:bodyPr/>
-                    <a:lstStyle/>
-                    <a:p>
-                      <a:pPr lvl="0" indent="0" marL="0">
-                        <a:buNone/>
-                      </a:pPr>
-                      <a:r>
-                        <a:rPr/>
-                        <a:t>0.768</a:t>
+                        <a:t>33</a:t>
+                      </a:r>
+                    </a:p>
+                  </a:txBody>
+                </a:tc>
+                <a:tc>
+                  <a:txBody>
+                    <a:bodyPr/>
+                    <a:lstStyle/>
+                    <a:p>
+                      <a:pPr lvl="0" indent="0" marL="0">
+                        <a:buNone/>
+                      </a:pPr>
+                      <a:r>
+                        <a:rPr/>
+                        <a:t>13</a:t>
+                      </a:r>
+                    </a:p>
+                  </a:txBody>
+                </a:tc>
+                <a:tc>
+                  <a:txBody>
+                    <a:bodyPr/>
+                    <a:lstStyle/>
+                    <a:p>
+                      <a:pPr lvl="0" indent="0" marL="0">
+                        <a:buNone/>
+                      </a:pPr>
+                      <a:r>
+                        <a:rPr/>
+                        <a:t>33 × 2,600 + 13 × 140 = €87,620</a:t>
                       </a:r>
                     </a:p>
                   </a:txBody>
@@ -18066,21 +18140,6 @@
                       <a:r>
                         <a:rPr/>
                         <a:t>0.949</a:t>
-                      </a:r>
-                    </a:p>
-                  </a:txBody>
-                </a:tc>
-                <a:tc>
-                  <a:txBody>
-                    <a:bodyPr/>
-                    <a:lstStyle/>
-                    <a:p>
-                      <a:pPr lvl="0" indent="0" marL="0">
-                        <a:buNone/>
-                      </a:pPr>
-                      <a:r>
-                        <a:rPr/>
-                        <a:t>87,620</a:t>
                       </a:r>
                     </a:p>
                   </a:txBody>
@@ -18112,22 +18171,37 @@
                       </a:pPr>
                       <a:r>
                         <a:rPr/>
-                        <a:t>0.855</a:t>
-                      </a:r>
-                    </a:p>
-                  </a:txBody>
-                </a:tc>
-                <a:tc>
-                  <a:txBody>
-                    <a:bodyPr/>
-                    <a:lstStyle/>
-                    <a:p>
-                      <a:pPr lvl="0" indent="0" marL="0">
-                        <a:buNone/>
-                      </a:pPr>
-                      <a:r>
-                        <a:rPr/>
-                        <a:t>0.349</a:t>
+                        <a:t>11</a:t>
+                      </a:r>
+                    </a:p>
+                  </a:txBody>
+                </a:tc>
+                <a:tc>
+                  <a:txBody>
+                    <a:bodyPr/>
+                    <a:lstStyle/>
+                    <a:p>
+                      <a:pPr lvl="0" indent="0" marL="0">
+                        <a:buNone/>
+                      </a:pPr>
+                      <a:r>
+                        <a:rPr/>
+                        <a:t>121</a:t>
+                      </a:r>
+                    </a:p>
+                  </a:txBody>
+                </a:tc>
+                <a:tc>
+                  <a:txBody>
+                    <a:bodyPr/>
+                    <a:lstStyle/>
+                    <a:p>
+                      <a:pPr lvl="0" indent="0" marL="0">
+                        <a:buNone/>
+                      </a:pPr>
+                      <a:r>
+                        <a:rPr/>
+                        <a:t>11 × 2,600 + 121 × 140 = €45,540</a:t>
                       </a:r>
                     </a:p>
                   </a:txBody>
@@ -18143,21 +18217,6 @@
                       <a:r>
                         <a:rPr/>
                         <a:t>0.949</a:t>
-                      </a:r>
-                    </a:p>
-                  </a:txBody>
-                </a:tc>
-                <a:tc>
-                  <a:txBody>
-                    <a:bodyPr/>
-                    <a:lstStyle/>
-                    <a:p>
-                      <a:pPr lvl="0" indent="0" marL="0">
-                        <a:buNone/>
-                      </a:pPr>
-                      <a:r>
-                        <a:rPr/>
-                        <a:t>45,540</a:t>
                       </a:r>
                     </a:p>
                   </a:txBody>
@@ -18189,22 +18248,37 @@
                       </a:pPr>
                       <a:r>
                         <a:rPr/>
-                        <a:t>0.895</a:t>
-                      </a:r>
-                    </a:p>
-                  </a:txBody>
-                </a:tc>
-                <a:tc>
-                  <a:txBody>
-                    <a:bodyPr/>
-                    <a:lstStyle/>
-                    <a:p>
-                      <a:pPr lvl="0" indent="0" marL="0">
-                        <a:buNone/>
-                      </a:pPr>
-                      <a:r>
-                        <a:rPr/>
-                        <a:t>0.249</a:t>
+                        <a:t>8</a:t>
+                      </a:r>
+                    </a:p>
+                  </a:txBody>
+                </a:tc>
+                <a:tc>
+                  <a:txBody>
+                    <a:bodyPr/>
+                    <a:lstStyle/>
+                    <a:p>
+                      <a:pPr lvl="0" indent="0" marL="0">
+                        <a:buNone/>
+                      </a:pPr>
+                      <a:r>
+                        <a:rPr/>
+                        <a:t>205</a:t>
+                      </a:r>
+                    </a:p>
+                  </a:txBody>
+                </a:tc>
+                <a:tc>
+                  <a:txBody>
+                    <a:bodyPr/>
+                    <a:lstStyle/>
+                    <a:p>
+                      <a:pPr lvl="0" indent="0" marL="0">
+                        <a:buNone/>
+                      </a:pPr>
+                      <a:r>
+                        <a:rPr/>
+                        <a:t>8 × 2,600 + 205 × 140 = €49,500</a:t>
                       </a:r>
                     </a:p>
                   </a:txBody>
@@ -18220,21 +18294,6 @@
                       <a:r>
                         <a:rPr b="1"/>
                         <a:t>0.950</a:t>
-                      </a:r>
-                    </a:p>
-                  </a:txBody>
-                </a:tc>
-                <a:tc>
-                  <a:txBody>
-                    <a:bodyPr/>
-                    <a:lstStyle/>
-                    <a:p>
-                      <a:pPr lvl="0" indent="0" marL="0">
-                        <a:buNone/>
-                      </a:pPr>
-                      <a:r>
-                        <a:rPr/>
-                        <a:t>49,500</a:t>
                       </a:r>
                     </a:p>
                   </a:txBody>
@@ -18757,7 +18816,14 @@
             <a:pPr lvl="0"/>
             <a:r>
               <a:rPr/>
-              <a:t>macro avg F1: </a:t>
+              <a:t>F1 per class: healthy 0.947 (1,665 drives), degraded 0.545 (259), failed 0.629 (76)</a:t>
+            </a:r>
+          </a:p>
+          <a:p>
+            <a:pPr lvl="0"/>
+            <a:r>
+              <a:rPr/>
+              <a:t>macro avg F1 = (0.947 + 0.545 + 0.629) ÷ 3 = </a:t>
             </a:r>
             <a:r>
               <a:rPr b="1"/>
@@ -18768,7 +18834,7 @@
             <a:pPr lvl="0"/>
             <a:r>
               <a:rPr/>
-              <a:t>weighted avg F1: </a:t>
+              <a:t>weighted avg F1 = (1,665 × 0.947 + 259 × 0.545 + 76 × 0.629) ÷ 2,000 = </a:t>
             </a:r>
             <a:r>
               <a:rPr b="1"/>
@@ -19076,18 +19142,18 @@
             <a:pPr lvl="0"/>
             <a:r>
               <a:rPr b="1"/>
-              <a:t>306 of the 8,000 drives failed.</a:t>
-            </a:r>
-            <a:r>
-              <a:rPr/>
-              <a:t> 3.8% of the fleet</a:t>
+              <a:t>306 of the 8,000 drives failed</a:t>
+            </a:r>
+            <a:r>
+              <a:rPr/>
+              <a:t>: 306 ÷ 8,000 = 3.8% of the fleet</a:t>
             </a:r>
           </a:p>
           <a:p>
             <a:pPr lvl="0"/>
             <a:r>
               <a:rPr/>
-              <a:t>Which means 96.2% did not</a:t>
+              <a:t>Which means 100% − 3.8% = 96.2% did not</a:t>
             </a:r>
           </a:p>
         </p:txBody>
@@ -19352,7 +19418,7 @@
             <a:pPr lvl="0"/>
             <a:r>
               <a:rPr/>
-              <a:t>p = 0.01, 0.5, 0.99 → log-odds −4.60, 0, +4.60</a:t>
+              <a:t>p = 0.99: log(0.99 ÷ 0.01) = log 99 = +4.60; p = 0.5: log(0.5 ÷ 0.5) = log 1 = 0</a:t>
             </a:r>
           </a:p>
           <a:p>

</xml_diff>

<commit_message>
Draw lesson 4's sweep, costs and averages, and justify the quiz and notebook numbers
Slides 39, 51 and 54 become figures generated in notebooks 2 and 3: the
threshold sweep as caught failures against false alarms, the three
operating points as bills, macro against weighted F1 per class. Handout
section 2.2 replaces its dense arithmetic with a figure of what the
sectors add to z on the two scales. The quiz and the notebooks' text show
the formula behind each number. Fixes two rounding errors carried by the
deck, handout and quiz: temperature's fitted coefficient is 0.46 (0.46465),
the decoy's odds multiplier 1.02 (1.0246).

Co-Authored-By: Claude Opus 5.5 <noreply@anthropic.com>
Claude-Session: https://claude.ai/code/session_01BdugDqEmUaYq1vzEjdPDKj
</commit_message>
<xml_diff>
--- a/Lessons/04_classification_and_metrics/Slides/classification_and_metrics_slides.pptx
+++ b/Lessons/04_classification_and_metrics/Slides/classification_and_metrics_slides.pptx
@@ -1131,7 +1131,7 @@
             </a:pPr>
             <a:r>
               <a:rPr/>
-              <a:t>Then the last row, which is the one to pause on. seek_error_rate was generated with a coefficient of exactly zero: a real-looking counter with no connection to failure. The model estimates 0.02, an odds multiplier of 1.03 (the table rounds the coefficient; the multiplier is computed from the unrounded value). It did not fall for it.</a:t>
+              <a:t>Then the last row, which is the one to pause on. seek_error_rate was generated with a coefficient of exactly zero: a real-looking counter with no connection to failure. The model estimates 0.02, an odds multiplier of exp(0.02) = 1.02. It did not fall for it.</a:t>
             </a:r>
           </a:p>
           <a:p>
@@ -4433,49 +4433,63 @@
             </a:pPr>
             <a:r>
               <a:rPr/>
-              <a:t>Read it column by column with the room.</a:t>
-            </a:r>
-          </a:p>
-          <a:p>
-            <a:pPr lvl="0" indent="0" marL="0">
-              <a:buNone/>
-            </a:pPr>
-          </a:p>
-          <a:p>
-            <a:pPr lvl="0" indent="0" marL="0">
-              <a:buNone/>
-            </a:pPr>
-            <a:r>
-              <a:rPr/>
-              <a:t>Lower the threshold: recall rises, precision falls. At 0.02 we catch 69 of 76 failures and replace 284 healthy drives to do it. At 0.90 every alarm is justified and we catch 14 of 76, fewer than a quarter.</a:t>
-            </a:r>
-          </a:p>
-          <a:p>
-            <a:pPr lvl="0" indent="0" marL="0">
-              <a:buNone/>
-            </a:pPr>
-          </a:p>
-          <a:p>
-            <a:pPr lvl="0" indent="0" marL="0">
-              <a:buNone/>
-            </a:pPr>
-            <a:r>
-              <a:rPr/>
-              <a:t>Now the accuracy column, which is the slide’s real argument. From 0.10 upwards it moves by 0.977 - 0.942 = 0.035, three and a half percentage points, while recall falls from 0.803 to 0.184. And its maximum is at 0.5 - the threshold that misses 33 of the 76 failures.</a:t>
-            </a:r>
-          </a:p>
-          <a:p>
-            <a:pPr lvl="0" indent="0" marL="0">
-              <a:buNone/>
-            </a:pPr>
-          </a:p>
-          <a:p>
-            <a:pPr lvl="0" indent="0" marL="0">
-              <a:buNone/>
-            </a:pPr>
-            <a:r>
-              <a:rPr/>
-              <a:t>Say the consequence plainly: tune on accuracy and it will quietly recommend catching fewer failures. Most of the alarms a higher threshold drops are false ones, so accuracy rises with each drop, even though some of the dropped alarms were failures being caught. From 0.30 to 0.50 the alarms go from 53 + 25 = 78 to 43 + 13 = 56, 22 fewer: 25 - 13 = 12 were false and 53 - 43 = 10 were caught failures. Accuracy gains 12 right answers and loses 10, two more in all, 0.976 to 0.977.</a:t>
+              <a:t>Notebook 2, the threshold sweep, five of its rows drawn as bars. Each pair of bars is one threshold: teal is the failures caught, out of the 76 in the test set; gold is the healthy drives flagged by mistake. On the right, the accuracy each threshold scores: right answers divided by 2,000.</a:t>
+            </a:r>
+          </a:p>
+          <a:p>
+            <a:pPr lvl="0" indent="0" marL="0">
+              <a:buNone/>
+            </a:pPr>
+          </a:p>
+          <a:p>
+            <a:pPr lvl="0" indent="0" marL="0">
+              <a:buNone/>
+            </a:pPr>
+            <a:r>
+              <a:rPr/>
+              <a:t>Lower the threshold - go up the figure: both bars grow. At 0.02 we catch 69 of 76 failures and replace 284 healthy drives to do it. At 0.90 there are no false alarms at all, and we catch 14 of 76, fewer than a quarter.</a:t>
+            </a:r>
+          </a:p>
+          <a:p>
+            <a:pPr lvl="0" indent="0" marL="0">
+              <a:buNone/>
+            </a:pPr>
+          </a:p>
+          <a:p>
+            <a:pPr lvl="0" indent="0" marL="0">
+              <a:buNone/>
+            </a:pPr>
+            <a:r>
+              <a:rPr/>
+              <a:t>Now the right-hand column, which is the slide’s real argument. For every threshold from 0.10 up to 0.90 it stays between 0.942 and 0.977, a range of 0.977 - 0.942 = 0.035, three and a half percentage points, while the teal bar shrinks from 61 to 14. And its maximum, in bold, is at 0.5 - the threshold that misses 76 - 43 = 33 failures.</a:t>
+            </a:r>
+          </a:p>
+          <a:p>
+            <a:pPr lvl="0" indent="0" marL="0">
+              <a:buNone/>
+            </a:pPr>
+          </a:p>
+          <a:p>
+            <a:pPr lvl="0" indent="0" marL="0">
+              <a:buNone/>
+            </a:pPr>
+            <a:r>
+              <a:rPr/>
+              <a:t>Say the consequence plainly: tune on accuracy and it will quietly recommend catching fewer failures. Most of the alarms a higher threshold drops are false ones, so accuracy rises with each drop, even though some of the dropped alarms were failures being caught. From 0.30 to 0.50 the gold bar loses 25 - 13 = 12 false alarms and the teal bar loses 53 - 43 = 10 caught failures. Accuracy gains 12 right answers and loses 10, two more in all, 0.976 to 0.977.</a:t>
+            </a:r>
+          </a:p>
+          <a:p>
+            <a:pPr lvl="0" indent="0" marL="0">
+              <a:buNone/>
+            </a:pPr>
+          </a:p>
+          <a:p>
+            <a:pPr lvl="0" indent="0" marL="0">
+              <a:buNone/>
+            </a:pPr>
+            <a:r>
+              <a:rPr/>
+              <a:t>Precision and recall at each threshold are in the handout’s table in section 7.1, computed with the formulas of slide 34.</a:t>
             </a:r>
           </a:p>
         </p:txBody>
@@ -6141,7 +6155,21 @@
             </a:pPr>
             <a:r>
               <a:rPr/>
-              <a:t>Point at the AUC column: 0.949 against 0.950. Reweighting taught the model essentially nothing new about disk failure. What it did was move where the model puts its 0.5 line - the same lever as the threshold, pulled at a different moment.</a:t>
+              <a:t>The figure is notebook 3’s comparison drawn as bills, one bar per model. Rust is the cost of the missed failures, FN times 2,600 euros; gold is the cost of the false alarms, FP times 140 euros. The default model misses 33 failures: 33 times 2,600 plus 13 times 140 is 87,620. The threshold at 0.08 misses 11 and raises 121 false alarms: 45,540. Balanced weights miss 8 and raise 205: 8 times 2,600 plus 205 times 140 is 49,500.</a:t>
+            </a:r>
+          </a:p>
+          <a:p>
+            <a:pPr lvl="0" indent="0" marL="0">
+              <a:buNone/>
+            </a:pPr>
+          </a:p>
+          <a:p>
+            <a:pPr lvl="0" indent="0" marL="0">
+              <a:buNone/>
+            </a:pPr>
+            <a:r>
+              <a:rPr/>
+              <a:t>Point at the AUC under each name: 0.949 against 0.950. Reweighting taught the model essentially nothing new about disk failure. What it did was move where the model puts its 0.5 line - the same lever as the threshold, pulled at a different moment.</a:t>
             </a:r>
           </a:p>
           <a:p>
@@ -6485,21 +6513,21 @@
             </a:pPr>
             <a:r>
               <a:rPr/>
-              <a:t>The same choice as before, now with a much starker gap on three classes.</a:t>
-            </a:r>
-          </a:p>
-          <a:p>
-            <a:pPr lvl="0" indent="0" marL="0">
-              <a:buNone/>
-            </a:pPr>
-          </a:p>
-          <a:p>
-            <a:pPr lvl="0" indent="0" marL="0">
-              <a:buNone/>
-            </a:pPr>
-            <a:r>
-              <a:rPr/>
-              <a:t>Macro treats the three conditions as equally important. Weighted lets the healthy class - 1,665 of 2,000, five drives in six - do most of the talking.</a:t>
+              <a:t>The same choice as before, now with a much starker gap on three classes. Notebook 3, the three-class model: one bar per class, its F1 from classification_report, and the two averages as lines.</a:t>
+            </a:r>
+          </a:p>
+          <a:p>
+            <a:pPr lvl="0" indent="0" marL="0">
+              <a:buNone/>
+            </a:pPr>
+          </a:p>
+          <a:p>
+            <a:pPr lvl="0" indent="0" marL="0">
+              <a:buNone/>
+            </a:pPr>
+            <a:r>
+              <a:rPr/>
+              <a:t>Macro treats the three conditions as equally important: (0.947 + 0.545 + 0.629) divided by 3 = 0.707, the dotted line. Weighted multiplies each class by its number of test drives: (1,665 times 0.947 + 259 times 0.545 + 76 times 0.629) divided by 2,000 = 0.883, the dashed line. The healthy class - 1,665 of 2,000, five drives in six - does most of the talking, so the dashed line sits close to the healthy bar.</a:t>
             </a:r>
           </a:p>
           <a:p>
@@ -6981,7 +7009,7 @@
             </a:pPr>
             <a:r>
               <a:rPr/>
-              <a:t>Expect someone to object with slide 7’s right panel. That curve barely moves over the first few reallocated sectors, where 90% of the drives sit (handout section 1.1) - the first four move it from 1.2% to 4.4%, by 0.03 - and it is steepest at 13.2 sectors. So do the first sectors say little? Two separate answers, in this order.</a:t>
+              <a:t>Expect someone to object with slide 7’s right panel. That curve barely moves over the first few reallocated sectors, where 90% of the drives sit (four sectors or fewer), and it is steepest at 13.2 sectors. So do the first sectors say little? Two separate answers, in this order.</a:t>
             </a:r>
           </a:p>
           <a:p>
@@ -7009,21 +7037,7 @@
             </a:pPr>
             <a:r>
               <a:rPr/>
-              <a:t>Second, the flat start comes from using the raw count, not from the drives. A straight line gives every sector the same 0.336 of z, so for that model the first four sectors add 4 times 0.336 = 1.34 to z and take a drive from sigma(-4.43) = 1.2% to sigma(-4.43 + 1.34) = sigma(-3.09) = 4.4%. But the labels were generated from log(1 + count), on which the first sectors weigh the most (handout section 1.1): for a drive whose other counters are average, the first four sectors add 4.7 to z and take it from 0.012% to 1.3%, about a hundred times more. That is why the six-counter model of slide 12 onwards takes log(1 + count) as its input.</a:t>
-            </a:r>
-          </a:p>
-          <a:p>
-            <a:pPr lvl="0" indent="0" marL="0">
-              <a:buNone/>
-            </a:pPr>
-          </a:p>
-          <a:p>
-            <a:pPr lvl="0" indent="0" marL="0">
-              <a:buNone/>
-            </a:pPr>
-            <a:r>
-              <a:rPr/>
-              <a:t>If a sharp student notices that 0.012% to 1.3% is a smaller move in probability than slide 7’s 0.03: compare effects in z, not in probability. That drive starts so deep in the flat tail that even a hundredfold rise moves its probability by only 0.013. Handout section 2.2.</a:t>
+              <a:t>Second, the flat start comes from using the raw count, not from the drives. A straight line in the count gives every sector the same weight: the first adds as much to z as the twentieth. But the labels were generated from log(1 + count), which gives the first sectors the most weight (handout section 1.1). The handout’s figure in section 2.2 draws what the sectors add to z under each of the two. That is why the six-counter model of slide 12 onwards takes log(1 + count) as its input.</a:t>
             </a:r>
           </a:p>
           <a:p>
@@ -11247,7 +11261,7 @@
                       </a:pPr>
                       <a:r>
                         <a:rPr/>
-                        <a:t>0.47</a:t>
+                        <a:t>0.46</a:t>
                       </a:r>
                     </a:p>
                   </a:txBody>
@@ -11386,7 +11400,7 @@
                       </a:pPr>
                       <a:r>
                         <a:rPr b="1"/>
-                        <a:t>1.03</a:t>
+                        <a:t>1.02</a:t>
                       </a:r>
                     </a:p>
                   </a:txBody>
@@ -15971,688 +15985,36 @@
           </a:p>
         </p:txBody>
       </p:sp>
-      <p:graphicFrame>
-        <p:nvGraphicFramePr>
-          <p:cNvPr id="6" name="Content Placeholder 5"/>
-          <p:cNvGraphicFramePr>
-            <a:graphicFrameLocks noGrp="1"/>
-          </p:cNvGraphicFramePr>
-          <p:nvPr>
-            <p:ph idx="1"/>
-          </p:nvPr>
-        </p:nvGraphicFramePr>
-        <p:xfrm>
-          <a:off x="457200" y="1166099"/>
-          <a:ext cx="8229600" cy="3390900"/>
-        </p:xfrm>
-        <a:graphic>
-          <a:graphicData uri="http://schemas.openxmlformats.org/drawingml/2006/table">
-            <a:tbl>
-              <a:tblPr firstRow="1" bandRow="1">
-                <a:tableStyleId>{5C22544A-7EE6-4342-B048-85BDC9FD1C3A}</a:tableStyleId>
-              </a:tblPr>
-              <a:tblGrid>
-                <a:gridCol w="1175657"/>
-                <a:gridCol w="1175657"/>
-                <a:gridCol w="1175657"/>
-                <a:gridCol w="1175657"/>
-                <a:gridCol w="1175657"/>
-                <a:gridCol w="1175657"/>
-                <a:gridCol w="1175658"/>
-              </a:tblGrid>
-              <a:tr h="0">
-                <a:tc>
-                  <a:txBody>
-                    <a:bodyPr/>
-                    <a:lstStyle/>
-                    <a:p>
-                      <a:pPr lvl="0" indent="0" marL="0">
-                        <a:buNone/>
-                      </a:pPr>
-                      <a:r>
-                        <a:rPr/>
-                        <a:t>Threshold</a:t>
-                      </a:r>
-                    </a:p>
-                  </a:txBody>
-                  <a:tcPr/>
-                </a:tc>
-                <a:tc>
-                  <a:txBody>
-                    <a:bodyPr/>
-                    <a:lstStyle/>
-                    <a:p>
-                      <a:pPr lvl="0" indent="0" marL="0">
-                        <a:buNone/>
-                      </a:pPr>
-                      <a:r>
-                        <a:rPr/>
-                        <a:t>TP</a:t>
-                      </a:r>
-                    </a:p>
-                  </a:txBody>
-                  <a:tcPr/>
-                </a:tc>
-                <a:tc>
-                  <a:txBody>
-                    <a:bodyPr/>
-                    <a:lstStyle/>
-                    <a:p>
-                      <a:pPr lvl="0" indent="0" marL="0">
-                        <a:buNone/>
-                      </a:pPr>
-                      <a:r>
-                        <a:rPr/>
-                        <a:t>FP</a:t>
-                      </a:r>
-                    </a:p>
-                  </a:txBody>
-                  <a:tcPr/>
-                </a:tc>
-                <a:tc>
-                  <a:txBody>
-                    <a:bodyPr/>
-                    <a:lstStyle/>
-                    <a:p>
-                      <a:pPr lvl="0" indent="0" marL="0">
-                        <a:buNone/>
-                      </a:pPr>
-                      <a:r>
-                        <a:rPr/>
-                        <a:t>FN</a:t>
-                      </a:r>
-                    </a:p>
-                  </a:txBody>
-                  <a:tcPr/>
-                </a:tc>
-                <a:tc>
-                  <a:txBody>
-                    <a:bodyPr/>
-                    <a:lstStyle/>
-                    <a:p>
-                      <a:pPr lvl="0" indent="0" marL="0">
-                        <a:buNone/>
-                      </a:pPr>
-                      <a:r>
-                        <a:rPr/>
-                        <a:t>Precision, TP ÷ (TP + FP)</a:t>
-                      </a:r>
-                    </a:p>
-                  </a:txBody>
-                  <a:tcPr/>
-                </a:tc>
-                <a:tc>
-                  <a:txBody>
-                    <a:bodyPr/>
-                    <a:lstStyle/>
-                    <a:p>
-                      <a:pPr lvl="0" indent="0" marL="0">
-                        <a:buNone/>
-                      </a:pPr>
-                      <a:r>
-                        <a:rPr/>
-                        <a:t>Recall, TP ÷ (TP + FN)</a:t>
-                      </a:r>
-                    </a:p>
-                  </a:txBody>
-                  <a:tcPr/>
-                </a:tc>
-                <a:tc>
-                  <a:txBody>
-                    <a:bodyPr/>
-                    <a:lstStyle/>
-                    <a:p>
-                      <a:pPr lvl="0" indent="0" marL="0">
-                        <a:buNone/>
-                      </a:pPr>
-                      <a:r>
-                        <a:rPr/>
-                        <a:t>Accuracy, (TP + TN) ÷ 2,000</a:t>
-                      </a:r>
-                    </a:p>
-                  </a:txBody>
-                  <a:tcPr/>
-                </a:tc>
-              </a:tr>
-              <a:tr h="0">
-                <a:tc>
-                  <a:txBody>
-                    <a:bodyPr/>
-                    <a:lstStyle/>
-                    <a:p>
-                      <a:pPr lvl="0" indent="0" marL="0">
-                        <a:buNone/>
-                      </a:pPr>
-                      <a:r>
-                        <a:rPr/>
-                        <a:t>0.02</a:t>
-                      </a:r>
-                    </a:p>
-                  </a:txBody>
-                </a:tc>
-                <a:tc>
-                  <a:txBody>
-                    <a:bodyPr/>
-                    <a:lstStyle/>
-                    <a:p>
-                      <a:pPr lvl="0" indent="0" marL="0">
-                        <a:buNone/>
-                      </a:pPr>
-                      <a:r>
-                        <a:rPr/>
-                        <a:t>69</a:t>
-                      </a:r>
-                    </a:p>
-                  </a:txBody>
-                </a:tc>
-                <a:tc>
-                  <a:txBody>
-                    <a:bodyPr/>
-                    <a:lstStyle/>
-                    <a:p>
-                      <a:pPr lvl="0" indent="0" marL="0">
-                        <a:buNone/>
-                      </a:pPr>
-                      <a:r>
-                        <a:rPr/>
-                        <a:t>284</a:t>
-                      </a:r>
-                    </a:p>
-                  </a:txBody>
-                </a:tc>
-                <a:tc>
-                  <a:txBody>
-                    <a:bodyPr/>
-                    <a:lstStyle/>
-                    <a:p>
-                      <a:pPr lvl="0" indent="0" marL="0">
-                        <a:buNone/>
-                      </a:pPr>
-                      <a:r>
-                        <a:rPr/>
-                        <a:t>7</a:t>
-                      </a:r>
-                    </a:p>
-                  </a:txBody>
-                </a:tc>
-                <a:tc>
-                  <a:txBody>
-                    <a:bodyPr/>
-                    <a:lstStyle/>
-                    <a:p>
-                      <a:pPr lvl="0" indent="0" marL="0">
-                        <a:buNone/>
-                      </a:pPr>
-                      <a:r>
-                        <a:rPr/>
-                        <a:t>0.195</a:t>
-                      </a:r>
-                    </a:p>
-                  </a:txBody>
-                </a:tc>
-                <a:tc>
-                  <a:txBody>
-                    <a:bodyPr/>
-                    <a:lstStyle/>
-                    <a:p>
-                      <a:pPr lvl="0" indent="0" marL="0">
-                        <a:buNone/>
-                      </a:pPr>
-                      <a:r>
-                        <a:rPr/>
-                        <a:t>0.908</a:t>
-                      </a:r>
-                    </a:p>
-                  </a:txBody>
-                </a:tc>
-                <a:tc>
-                  <a:txBody>
-                    <a:bodyPr/>
-                    <a:lstStyle/>
-                    <a:p>
-                      <a:pPr lvl="0" indent="0" marL="0">
-                        <a:buNone/>
-                      </a:pPr>
-                      <a:r>
-                        <a:rPr/>
-                        <a:t>0.855</a:t>
-                      </a:r>
-                    </a:p>
-                  </a:txBody>
-                </a:tc>
-              </a:tr>
-              <a:tr h="0">
-                <a:tc>
-                  <a:txBody>
-                    <a:bodyPr/>
-                    <a:lstStyle/>
-                    <a:p>
-                      <a:pPr lvl="0" indent="0" marL="0">
-                        <a:buNone/>
-                      </a:pPr>
-                      <a:r>
-                        <a:rPr/>
-                        <a:t>0.10</a:t>
-                      </a:r>
-                    </a:p>
-                  </a:txBody>
-                </a:tc>
-                <a:tc>
-                  <a:txBody>
-                    <a:bodyPr/>
-                    <a:lstStyle/>
-                    <a:p>
-                      <a:pPr lvl="0" indent="0" marL="0">
-                        <a:buNone/>
-                      </a:pPr>
-                      <a:r>
-                        <a:rPr/>
-                        <a:t>61</a:t>
-                      </a:r>
-                    </a:p>
-                  </a:txBody>
-                </a:tc>
-                <a:tc>
-                  <a:txBody>
-                    <a:bodyPr/>
-                    <a:lstStyle/>
-                    <a:p>
-                      <a:pPr lvl="0" indent="0" marL="0">
-                        <a:buNone/>
-                      </a:pPr>
-                      <a:r>
-                        <a:rPr/>
-                        <a:t>102</a:t>
-                      </a:r>
-                    </a:p>
-                  </a:txBody>
-                </a:tc>
-                <a:tc>
-                  <a:txBody>
-                    <a:bodyPr/>
-                    <a:lstStyle/>
-                    <a:p>
-                      <a:pPr lvl="0" indent="0" marL="0">
-                        <a:buNone/>
-                      </a:pPr>
-                      <a:r>
-                        <a:rPr/>
-                        <a:t>15</a:t>
-                      </a:r>
-                    </a:p>
-                  </a:txBody>
-                </a:tc>
-                <a:tc>
-                  <a:txBody>
-                    <a:bodyPr/>
-                    <a:lstStyle/>
-                    <a:p>
-                      <a:pPr lvl="0" indent="0" marL="0">
-                        <a:buNone/>
-                      </a:pPr>
-                      <a:r>
-                        <a:rPr/>
-                        <a:t>0.374</a:t>
-                      </a:r>
-                    </a:p>
-                  </a:txBody>
-                </a:tc>
-                <a:tc>
-                  <a:txBody>
-                    <a:bodyPr/>
-                    <a:lstStyle/>
-                    <a:p>
-                      <a:pPr lvl="0" indent="0" marL="0">
-                        <a:buNone/>
-                      </a:pPr>
-                      <a:r>
-                        <a:rPr/>
-                        <a:t>0.803</a:t>
-                      </a:r>
-                    </a:p>
-                  </a:txBody>
-                </a:tc>
-                <a:tc>
-                  <a:txBody>
-                    <a:bodyPr/>
-                    <a:lstStyle/>
-                    <a:p>
-                      <a:pPr lvl="0" indent="0" marL="0">
-                        <a:buNone/>
-                      </a:pPr>
-                      <a:r>
-                        <a:rPr/>
-                        <a:t>0.942</a:t>
-                      </a:r>
-                    </a:p>
-                  </a:txBody>
-                </a:tc>
-              </a:tr>
-              <a:tr h="0">
-                <a:tc>
-                  <a:txBody>
-                    <a:bodyPr/>
-                    <a:lstStyle/>
-                    <a:p>
-                      <a:pPr lvl="0" indent="0" marL="0">
-                        <a:buNone/>
-                      </a:pPr>
-                      <a:r>
-                        <a:rPr/>
-                        <a:t>0.30</a:t>
-                      </a:r>
-                    </a:p>
-                  </a:txBody>
-                </a:tc>
-                <a:tc>
-                  <a:txBody>
-                    <a:bodyPr/>
-                    <a:lstStyle/>
-                    <a:p>
-                      <a:pPr lvl="0" indent="0" marL="0">
-                        <a:buNone/>
-                      </a:pPr>
-                      <a:r>
-                        <a:rPr/>
-                        <a:t>53</a:t>
-                      </a:r>
-                    </a:p>
-                  </a:txBody>
-                </a:tc>
-                <a:tc>
-                  <a:txBody>
-                    <a:bodyPr/>
-                    <a:lstStyle/>
-                    <a:p>
-                      <a:pPr lvl="0" indent="0" marL="0">
-                        <a:buNone/>
-                      </a:pPr>
-                      <a:r>
-                        <a:rPr/>
-                        <a:t>25</a:t>
-                      </a:r>
-                    </a:p>
-                  </a:txBody>
-                </a:tc>
-                <a:tc>
-                  <a:txBody>
-                    <a:bodyPr/>
-                    <a:lstStyle/>
-                    <a:p>
-                      <a:pPr lvl="0" indent="0" marL="0">
-                        <a:buNone/>
-                      </a:pPr>
-                      <a:r>
-                        <a:rPr/>
-                        <a:t>23</a:t>
-                      </a:r>
-                    </a:p>
-                  </a:txBody>
-                </a:tc>
-                <a:tc>
-                  <a:txBody>
-                    <a:bodyPr/>
-                    <a:lstStyle/>
-                    <a:p>
-                      <a:pPr lvl="0" indent="0" marL="0">
-                        <a:buNone/>
-                      </a:pPr>
-                      <a:r>
-                        <a:rPr/>
-                        <a:t>0.679</a:t>
-                      </a:r>
-                    </a:p>
-                  </a:txBody>
-                </a:tc>
-                <a:tc>
-                  <a:txBody>
-                    <a:bodyPr/>
-                    <a:lstStyle/>
-                    <a:p>
-                      <a:pPr lvl="0" indent="0" marL="0">
-                        <a:buNone/>
-                      </a:pPr>
-                      <a:r>
-                        <a:rPr/>
-                        <a:t>0.697</a:t>
-                      </a:r>
-                    </a:p>
-                  </a:txBody>
-                </a:tc>
-                <a:tc>
-                  <a:txBody>
-                    <a:bodyPr/>
-                    <a:lstStyle/>
-                    <a:p>
-                      <a:pPr lvl="0" indent="0" marL="0">
-                        <a:buNone/>
-                      </a:pPr>
-                      <a:r>
-                        <a:rPr/>
-                        <a:t>0.976</a:t>
-                      </a:r>
-                    </a:p>
-                  </a:txBody>
-                </a:tc>
-              </a:tr>
-              <a:tr h="0">
-                <a:tc>
-                  <a:txBody>
-                    <a:bodyPr/>
-                    <a:lstStyle/>
-                    <a:p>
-                      <a:pPr lvl="0" indent="0" marL="0">
-                        <a:buNone/>
-                      </a:pPr>
-                      <a:r>
-                        <a:rPr/>
-                        <a:t>0.50</a:t>
-                      </a:r>
-                    </a:p>
-                  </a:txBody>
-                </a:tc>
-                <a:tc>
-                  <a:txBody>
-                    <a:bodyPr/>
-                    <a:lstStyle/>
-                    <a:p>
-                      <a:pPr lvl="0" indent="0" marL="0">
-                        <a:buNone/>
-                      </a:pPr>
-                      <a:r>
-                        <a:rPr/>
-                        <a:t>43</a:t>
-                      </a:r>
-                    </a:p>
-                  </a:txBody>
-                </a:tc>
-                <a:tc>
-                  <a:txBody>
-                    <a:bodyPr/>
-                    <a:lstStyle/>
-                    <a:p>
-                      <a:pPr lvl="0" indent="0" marL="0">
-                        <a:buNone/>
-                      </a:pPr>
-                      <a:r>
-                        <a:rPr/>
-                        <a:t>13</a:t>
-                      </a:r>
-                    </a:p>
-                  </a:txBody>
-                </a:tc>
-                <a:tc>
-                  <a:txBody>
-                    <a:bodyPr/>
-                    <a:lstStyle/>
-                    <a:p>
-                      <a:pPr lvl="0" indent="0" marL="0">
-                        <a:buNone/>
-                      </a:pPr>
-                      <a:r>
-                        <a:rPr/>
-                        <a:t>33</a:t>
-                      </a:r>
-                    </a:p>
-                  </a:txBody>
-                </a:tc>
-                <a:tc>
-                  <a:txBody>
-                    <a:bodyPr/>
-                    <a:lstStyle/>
-                    <a:p>
-                      <a:pPr lvl="0" indent="0" marL="0">
-                        <a:buNone/>
-                      </a:pPr>
-                      <a:r>
-                        <a:rPr/>
-                        <a:t>0.768</a:t>
-                      </a:r>
-                    </a:p>
-                  </a:txBody>
-                </a:tc>
-                <a:tc>
-                  <a:txBody>
-                    <a:bodyPr/>
-                    <a:lstStyle/>
-                    <a:p>
-                      <a:pPr lvl="0" indent="0" marL="0">
-                        <a:buNone/>
-                      </a:pPr>
-                      <a:r>
-                        <a:rPr/>
-                        <a:t>0.566</a:t>
-                      </a:r>
-                    </a:p>
-                  </a:txBody>
-                </a:tc>
-                <a:tc>
-                  <a:txBody>
-                    <a:bodyPr/>
-                    <a:lstStyle/>
-                    <a:p>
-                      <a:pPr lvl="0" indent="0" marL="0">
-                        <a:buNone/>
-                      </a:pPr>
-                      <a:r>
-                        <a:rPr b="1"/>
-                        <a:t>0.977</a:t>
-                      </a:r>
-                    </a:p>
-                  </a:txBody>
-                </a:tc>
-              </a:tr>
-              <a:tr h="0">
-                <a:tc>
-                  <a:txBody>
-                    <a:bodyPr/>
-                    <a:lstStyle/>
-                    <a:p>
-                      <a:pPr lvl="0" indent="0" marL="0">
-                        <a:buNone/>
-                      </a:pPr>
-                      <a:r>
-                        <a:rPr/>
-                        <a:t>0.90</a:t>
-                      </a:r>
-                    </a:p>
-                  </a:txBody>
-                </a:tc>
-                <a:tc>
-                  <a:txBody>
-                    <a:bodyPr/>
-                    <a:lstStyle/>
-                    <a:p>
-                      <a:pPr lvl="0" indent="0" marL="0">
-                        <a:buNone/>
-                      </a:pPr>
-                      <a:r>
-                        <a:rPr/>
-                        <a:t>14</a:t>
-                      </a:r>
-                    </a:p>
-                  </a:txBody>
-                </a:tc>
-                <a:tc>
-                  <a:txBody>
-                    <a:bodyPr/>
-                    <a:lstStyle/>
-                    <a:p>
-                      <a:pPr lvl="0" indent="0" marL="0">
-                        <a:buNone/>
-                      </a:pPr>
-                      <a:r>
-                        <a:rPr/>
-                        <a:t>0</a:t>
-                      </a:r>
-                    </a:p>
-                  </a:txBody>
-                </a:tc>
-                <a:tc>
-                  <a:txBody>
-                    <a:bodyPr/>
-                    <a:lstStyle/>
-                    <a:p>
-                      <a:pPr lvl="0" indent="0" marL="0">
-                        <a:buNone/>
-                      </a:pPr>
-                      <a:r>
-                        <a:rPr/>
-                        <a:t>62</a:t>
-                      </a:r>
-                    </a:p>
-                  </a:txBody>
-                </a:tc>
-                <a:tc>
-                  <a:txBody>
-                    <a:bodyPr/>
-                    <a:lstStyle/>
-                    <a:p>
-                      <a:pPr lvl="0" indent="0" marL="0">
-                        <a:buNone/>
-                      </a:pPr>
-                      <a:r>
-                        <a:rPr/>
-                        <a:t>1.000</a:t>
-                      </a:r>
-                    </a:p>
-                  </a:txBody>
-                </a:tc>
-                <a:tc>
-                  <a:txBody>
-                    <a:bodyPr/>
-                    <a:lstStyle/>
-                    <a:p>
-                      <a:pPr lvl="0" indent="0" marL="0">
-                        <a:buNone/>
-                      </a:pPr>
-                      <a:r>
-                        <a:rPr/>
-                        <a:t>0.184</a:t>
-                      </a:r>
-                    </a:p>
-                  </a:txBody>
-                </a:tc>
-                <a:tc>
-                  <a:txBody>
-                    <a:bodyPr/>
-                    <a:lstStyle/>
-                    <a:p>
-                      <a:pPr lvl="0" indent="0" marL="0">
-                        <a:buNone/>
-                      </a:pPr>
-                      <a:r>
-                        <a:rPr/>
-                        <a:t>0.969</a:t>
-                      </a:r>
-                    </a:p>
-                  </a:txBody>
-                </a:tc>
-              </a:tr>
-            </a:tbl>
-          </a:graphicData>
-        </a:graphic>
-      </p:graphicFrame>
+      <p:pic>
+        <p:nvPicPr>
+          <p:cNvPr descr="sweep_outcomes.png" id="0" name="Picture 1"/>
+          <p:cNvPicPr>
+            <a:picLocks noGrp="1" noChangeAspect="1"/>
+          </p:cNvPicPr>
+          <p:nvPr/>
+        </p:nvPicPr>
+        <p:blipFill>
+          <a:blip r:embed="rId3"/>
+          <a:stretch>
+            <a:fillRect/>
+          </a:stretch>
+        </p:blipFill>
+        <p:spPr bwMode="auto">
+          <a:xfrm>
+            <a:off x="1023045" y="1166099"/>
+            <a:ext cx="7097910" cy="3360181"/>
+          </a:xfrm>
+          <a:prstGeom prst="rect">
+            <a:avLst/>
+          </a:prstGeom>
+          <a:noFill/>
+          <a:ln w="9525">
+            <a:noFill/>
+            <a:headEnd/>
+            <a:tailEnd/>
+          </a:ln>
+        </p:spPr>
+      </p:pic>
     </p:spTree>
   </p:cSld>
 </p:sld>
@@ -17959,350 +17321,36 @@
           </a:p>
         </p:txBody>
       </p:sp>
-      <p:graphicFrame>
-        <p:nvGraphicFramePr>
-          <p:cNvPr id="6" name="Content Placeholder 5"/>
-          <p:cNvGraphicFramePr>
-            <a:graphicFrameLocks noGrp="1"/>
-          </p:cNvGraphicFramePr>
-          <p:nvPr>
-            <p:ph idx="1"/>
-          </p:nvPr>
-        </p:nvGraphicFramePr>
-        <p:xfrm>
-          <a:off x="457200" y="1166099"/>
-          <a:ext cx="8229600" cy="3390900"/>
-        </p:xfrm>
-        <a:graphic>
-          <a:graphicData uri="http://schemas.openxmlformats.org/drawingml/2006/table">
-            <a:tbl>
-              <a:tblPr firstRow="1" bandRow="1">
-                <a:tableStyleId>{5C22544A-7EE6-4342-B048-85BDC9FD1C3A}</a:tableStyleId>
-              </a:tblPr>
-              <a:tblGrid>
-                <a:gridCol w="1645920"/>
-                <a:gridCol w="1645920"/>
-                <a:gridCol w="1645920"/>
-                <a:gridCol w="1645920"/>
-                <a:gridCol w="1645920"/>
-              </a:tblGrid>
-              <a:tr h="0">
-                <a:tc>
-                  <a:txBody>
-                    <a:bodyPr/>
-                    <a:lstStyle/>
-                    <a:p>
-                      <a:pPr lvl="0" indent="0" marL="0">
-                        <a:buNone/>
-                      </a:pPr>
-                      <a:r>
-                        <a:rPr/>
-                        <a:t>Model</a:t>
-                      </a:r>
-                    </a:p>
-                  </a:txBody>
-                  <a:tcPr/>
-                </a:tc>
-                <a:tc>
-                  <a:txBody>
-                    <a:bodyPr/>
-                    <a:lstStyle/>
-                    <a:p>
-                      <a:pPr lvl="0" indent="0" marL="0">
-                        <a:buNone/>
-                      </a:pPr>
-                      <a:r>
-                        <a:rPr/>
-                        <a:t>Failures missed, FN</a:t>
-                      </a:r>
-                    </a:p>
-                  </a:txBody>
-                  <a:tcPr/>
-                </a:tc>
-                <a:tc>
-                  <a:txBody>
-                    <a:bodyPr/>
-                    <a:lstStyle/>
-                    <a:p>
-                      <a:pPr lvl="0" indent="0" marL="0">
-                        <a:buNone/>
-                      </a:pPr>
-                      <a:r>
-                        <a:rPr/>
-                        <a:t>False alarms, FP</a:t>
-                      </a:r>
-                    </a:p>
-                  </a:txBody>
-                  <a:tcPr/>
-                </a:tc>
-                <a:tc>
-                  <a:txBody>
-                    <a:bodyPr/>
-                    <a:lstStyle/>
-                    <a:p>
-                      <a:pPr lvl="0" indent="0" marL="0">
-                        <a:buNone/>
-                      </a:pPr>
-                      <a:r>
-                        <a:rPr/>
-                        <a:t>Cost = FN × €2,600 + FP × €140</a:t>
-                      </a:r>
-                    </a:p>
-                  </a:txBody>
-                  <a:tcPr/>
-                </a:tc>
-                <a:tc>
-                  <a:txBody>
-                    <a:bodyPr/>
-                    <a:lstStyle/>
-                    <a:p>
-                      <a:pPr lvl="0" indent="0" marL="0">
-                        <a:buNone/>
-                      </a:pPr>
-                      <a:r>
-                        <a:rPr/>
-                        <a:t>AUC</a:t>
-                      </a:r>
-                    </a:p>
-                  </a:txBody>
-                  <a:tcPr/>
-                </a:tc>
-              </a:tr>
-              <a:tr h="0">
-                <a:tc>
-                  <a:txBody>
-                    <a:bodyPr/>
-                    <a:lstStyle/>
-                    <a:p>
-                      <a:pPr lvl="0" indent="0" marL="0">
-                        <a:buNone/>
-                      </a:pPr>
-                      <a:r>
-                        <a:rPr/>
-                        <a:t>Plain, threshold 0.50</a:t>
-                      </a:r>
-                    </a:p>
-                  </a:txBody>
-                </a:tc>
-                <a:tc>
-                  <a:txBody>
-                    <a:bodyPr/>
-                    <a:lstStyle/>
-                    <a:p>
-                      <a:pPr lvl="0" indent="0" marL="0">
-                        <a:buNone/>
-                      </a:pPr>
-                      <a:r>
-                        <a:rPr/>
-                        <a:t>33</a:t>
-                      </a:r>
-                    </a:p>
-                  </a:txBody>
-                </a:tc>
-                <a:tc>
-                  <a:txBody>
-                    <a:bodyPr/>
-                    <a:lstStyle/>
-                    <a:p>
-                      <a:pPr lvl="0" indent="0" marL="0">
-                        <a:buNone/>
-                      </a:pPr>
-                      <a:r>
-                        <a:rPr/>
-                        <a:t>13</a:t>
-                      </a:r>
-                    </a:p>
-                  </a:txBody>
-                </a:tc>
-                <a:tc>
-                  <a:txBody>
-                    <a:bodyPr/>
-                    <a:lstStyle/>
-                    <a:p>
-                      <a:pPr lvl="0" indent="0" marL="0">
-                        <a:buNone/>
-                      </a:pPr>
-                      <a:r>
-                        <a:rPr/>
-                        <a:t>33 × 2,600 + 13 × 140 = €87,620</a:t>
-                      </a:r>
-                    </a:p>
-                  </a:txBody>
-                </a:tc>
-                <a:tc>
-                  <a:txBody>
-                    <a:bodyPr/>
-                    <a:lstStyle/>
-                    <a:p>
-                      <a:pPr lvl="0" indent="0" marL="0">
-                        <a:buNone/>
-                      </a:pPr>
-                      <a:r>
-                        <a:rPr/>
-                        <a:t>0.949</a:t>
-                      </a:r>
-                    </a:p>
-                  </a:txBody>
-                </a:tc>
-              </a:tr>
-              <a:tr h="0">
-                <a:tc>
-                  <a:txBody>
-                    <a:bodyPr/>
-                    <a:lstStyle/>
-                    <a:p>
-                      <a:pPr lvl="0" indent="0" marL="0">
-                        <a:buNone/>
-                      </a:pPr>
-                      <a:r>
-                        <a:rPr/>
-                        <a:t>Plain, threshold 0.08</a:t>
-                      </a:r>
-                    </a:p>
-                  </a:txBody>
-                </a:tc>
-                <a:tc>
-                  <a:txBody>
-                    <a:bodyPr/>
-                    <a:lstStyle/>
-                    <a:p>
-                      <a:pPr lvl="0" indent="0" marL="0">
-                        <a:buNone/>
-                      </a:pPr>
-                      <a:r>
-                        <a:rPr/>
-                        <a:t>11</a:t>
-                      </a:r>
-                    </a:p>
-                  </a:txBody>
-                </a:tc>
-                <a:tc>
-                  <a:txBody>
-                    <a:bodyPr/>
-                    <a:lstStyle/>
-                    <a:p>
-                      <a:pPr lvl="0" indent="0" marL="0">
-                        <a:buNone/>
-                      </a:pPr>
-                      <a:r>
-                        <a:rPr/>
-                        <a:t>121</a:t>
-                      </a:r>
-                    </a:p>
-                  </a:txBody>
-                </a:tc>
-                <a:tc>
-                  <a:txBody>
-                    <a:bodyPr/>
-                    <a:lstStyle/>
-                    <a:p>
-                      <a:pPr lvl="0" indent="0" marL="0">
-                        <a:buNone/>
-                      </a:pPr>
-                      <a:r>
-                        <a:rPr/>
-                        <a:t>11 × 2,600 + 121 × 140 = €45,540</a:t>
-                      </a:r>
-                    </a:p>
-                  </a:txBody>
-                </a:tc>
-                <a:tc>
-                  <a:txBody>
-                    <a:bodyPr/>
-                    <a:lstStyle/>
-                    <a:p>
-                      <a:pPr lvl="0" indent="0" marL="0">
-                        <a:buNone/>
-                      </a:pPr>
-                      <a:r>
-                        <a:rPr/>
-                        <a:t>0.949</a:t>
-                      </a:r>
-                    </a:p>
-                  </a:txBody>
-                </a:tc>
-              </a:tr>
-              <a:tr h="0">
-                <a:tc>
-                  <a:txBody>
-                    <a:bodyPr/>
-                    <a:lstStyle/>
-                    <a:p>
-                      <a:pPr lvl="0" indent="0" marL="0">
-                        <a:buNone/>
-                      </a:pPr>
-                      <a:r>
-                        <a:rPr/>
-                        <a:t>Balanced class weights, 0.50</a:t>
-                      </a:r>
-                    </a:p>
-                  </a:txBody>
-                </a:tc>
-                <a:tc>
-                  <a:txBody>
-                    <a:bodyPr/>
-                    <a:lstStyle/>
-                    <a:p>
-                      <a:pPr lvl="0" indent="0" marL="0">
-                        <a:buNone/>
-                      </a:pPr>
-                      <a:r>
-                        <a:rPr/>
-                        <a:t>8</a:t>
-                      </a:r>
-                    </a:p>
-                  </a:txBody>
-                </a:tc>
-                <a:tc>
-                  <a:txBody>
-                    <a:bodyPr/>
-                    <a:lstStyle/>
-                    <a:p>
-                      <a:pPr lvl="0" indent="0" marL="0">
-                        <a:buNone/>
-                      </a:pPr>
-                      <a:r>
-                        <a:rPr/>
-                        <a:t>205</a:t>
-                      </a:r>
-                    </a:p>
-                  </a:txBody>
-                </a:tc>
-                <a:tc>
-                  <a:txBody>
-                    <a:bodyPr/>
-                    <a:lstStyle/>
-                    <a:p>
-                      <a:pPr lvl="0" indent="0" marL="0">
-                        <a:buNone/>
-                      </a:pPr>
-                      <a:r>
-                        <a:rPr/>
-                        <a:t>8 × 2,600 + 205 × 140 = €49,500</a:t>
-                      </a:r>
-                    </a:p>
-                  </a:txBody>
-                </a:tc>
-                <a:tc>
-                  <a:txBody>
-                    <a:bodyPr/>
-                    <a:lstStyle/>
-                    <a:p>
-                      <a:pPr lvl="0" indent="0" marL="0">
-                        <a:buNone/>
-                      </a:pPr>
-                      <a:r>
-                        <a:rPr b="1"/>
-                        <a:t>0.950</a:t>
-                      </a:r>
-                    </a:p>
-                  </a:txBody>
-                </a:tc>
-              </a:tr>
-            </a:tbl>
-          </a:graphicData>
-        </a:graphic>
-      </p:graphicFrame>
+      <p:pic>
+        <p:nvPicPr>
+          <p:cNvPr descr="class_weight_costs.png" id="0" name="Picture 1"/>
+          <p:cNvPicPr>
+            <a:picLocks noGrp="1" noChangeAspect="1"/>
+          </p:cNvPicPr>
+          <p:nvPr/>
+        </p:nvPicPr>
+        <p:blipFill>
+          <a:blip r:embed="rId3"/>
+          <a:stretch>
+            <a:fillRect/>
+          </a:stretch>
+        </p:blipFill>
+        <p:spPr bwMode="auto">
+          <a:xfrm>
+            <a:off x="457200" y="1284089"/>
+            <a:ext cx="8229600" cy="3124200"/>
+          </a:xfrm>
+          <a:prstGeom prst="rect">
+            <a:avLst/>
+          </a:prstGeom>
+          <a:noFill/>
+          <a:ln w="9525">
+            <a:noFill/>
+            <a:headEnd/>
+            <a:tailEnd/>
+          </a:ln>
+        </p:spPr>
+      </p:pic>
     </p:spTree>
   </p:cSld>
 </p:sld>
@@ -18793,56 +17841,36 @@
           </a:p>
         </p:txBody>
       </p:sp>
-      <p:sp>
-        <p:nvSpPr>
-          <p:cNvPr id="3" name="Content Placeholder 2"/>
-          <p:cNvSpPr>
-            <a:spLocks noGrp="1"/>
-          </p:cNvSpPr>
-          <p:nvPr>
-            <p:ph idx="1"/>
-          </p:nvPr>
-        </p:nvSpPr>
-        <p:spPr>
+      <p:pic>
+        <p:nvPicPr>
+          <p:cNvPr descr="macro_vs_weighted.png" id="0" name="Picture 1"/>
+          <p:cNvPicPr>
+            <a:picLocks noGrp="1" noChangeAspect="1"/>
+          </p:cNvPicPr>
+          <p:nvPr/>
+        </p:nvPicPr>
+        <p:blipFill>
+          <a:blip r:embed="rId3"/>
+          <a:stretch>
+            <a:fillRect/>
+          </a:stretch>
+        </p:blipFill>
+        <p:spPr bwMode="auto">
           <a:xfrm>
-            <a:off x="457200" y="1200151"/>
-            <a:ext cx="8229600" cy="3394472"/>
+            <a:off x="1306206" y="1166099"/>
+            <a:ext cx="6531587" cy="3360181"/>
           </a:xfrm>
+          <a:prstGeom prst="rect">
+            <a:avLst/>
+          </a:prstGeom>
+          <a:noFill/>
+          <a:ln w="9525">
+            <a:noFill/>
+            <a:headEnd/>
+            <a:tailEnd/>
+          </a:ln>
         </p:spPr>
-        <p:txBody>
-          <a:bodyPr/>
-          <a:lstStyle/>
-          <a:p>
-            <a:pPr lvl="0"/>
-            <a:r>
-              <a:rPr/>
-              <a:t>F1 per class: healthy 0.947 (1,665 drives), degraded 0.545 (259), failed 0.629 (76)</a:t>
-            </a:r>
-          </a:p>
-          <a:p>
-            <a:pPr lvl="0"/>
-            <a:r>
-              <a:rPr/>
-              <a:t>macro avg F1 = (0.947 + 0.545 + 0.629) ÷ 3 = </a:t>
-            </a:r>
-            <a:r>
-              <a:rPr b="1"/>
-              <a:t>0.707</a:t>
-            </a:r>
-          </a:p>
-          <a:p>
-            <a:pPr lvl="0"/>
-            <a:r>
-              <a:rPr/>
-              <a:t>weighted avg F1 = (1,665 × 0.947 + 259 × 0.545 + 76 × 0.629) ÷ 2,000 = </a:t>
-            </a:r>
-            <a:r>
-              <a:rPr b="1"/>
-              <a:t>0.883</a:t>
-            </a:r>
-          </a:p>
-        </p:txBody>
-      </p:sp>
+      </p:pic>
     </p:spTree>
   </p:cSld>
 </p:sld>

</xml_diff>

<commit_message>
Define 'reading' in lesson 4's section 2.3 and stop using it for 'interpretation'
Co-Authored-By: Claude Opus 5.5 <noreply@anthropic.com>
Claude-Session: https://claude.ai/code/session_01BdugDqEmUaYq1vzEjdPDKj
</commit_message>
<xml_diff>
--- a/Lessons/04_classification_and_metrics/Slides/classification_and_metrics_slides.pptx
+++ b/Lessons/04_classification_and_metrics/Slides/classification_and_metrics_slides.pptx
@@ -2346,7 +2346,7 @@
             </a:pPr>
             <a:r>
               <a:rPr/>
-              <a:t>The reading that makes it stick: the cost of an outcome is the SURPRISE of seeing it. Something you called certain costs nothing. Something you gave a probability of one in a thousand costs log 1000, about 6.9 (natural logarithm, as everywhere in this lesson). Something you declared impossible costs infinity.</a:t>
+              <a:t>The interpretation that makes it stick: the cost of an outcome is the SURPRISE of seeing it. Something you called certain costs nothing. Something you gave a probability of one in a thousand costs log 1000, about 6.9 (natural logarithm, as everywhere in this lesson). Something you declared impossible costs infinity.</a:t>
             </a:r>
           </a:p>
           <a:p>
@@ -6586,7 +6586,7 @@
             </a:pPr>
             <a:r>
               <a:rPr/>
-              <a:t>The same reading holds for resampling and for SMOTE (synthetic minority oversampling technique, which builds artificial minority examples): they move the operating point too. And both must be applied to the training rows only - inside each cross-validation fold, once lesson 5 introduces folds. Duplicated or synthetic failures in the test set would be scored as if they were real drives, and the test score would stop describing the real fleet; lesson 2 made the same argument for fitting the imputer on the training rows only.</a:t>
+              <a:t>The same argument holds for resampling and for SMOTE (synthetic minority oversampling technique, which builds artificial minority examples): they move the operating point too. And both must be applied to the training rows only - inside each cross-validation fold, once lesson 5 introduces folds. Duplicated or synthetic failures in the test set would be scored as if they were real drives, and the test score would stop describing the real fleet; lesson 2 made the same argument for fitting the imputer on the training rows only.</a:t>
             </a:r>
           </a:p>
         </p:txBody>
@@ -7600,7 +7600,7 @@
             </a:pPr>
             <a:r>
               <a:rPr/>
-              <a:t>The predictable mistake: students think the sigmoid was picked because it looks like the right S-shape. A reasonable reading, because the shape is what slide 8 shows first. But many curves have that shape; what singles this one out is the log-odds behind it. Handout section 2.3.</a:t>
+              <a:t>The predictable mistake: students think the sigmoid was picked because it looks like the right S-shape. A reasonable interpretation, because the shape is what slide 8 shows first. But many curves have that shape; what singles this one out is the log-odds behind it. Handout section 2.3.</a:t>
             </a:r>
           </a:p>
         </p:txBody>
@@ -7710,7 +7710,7 @@
             </a:pPr>
             <a:r>
               <a:rPr/>
-              <a:t>The picture shows three drives, marked by the yellow dots: an average drive at 0.2%, one at 50% and one at 95%. Each receives the same reading, one that is six times more common among drives that fail than among healthy ones. Bayes’ rule says such a reading multiplies the odds - the probability of failing divided by the probability of not failing - by 6, whatever they were before (handout section 2.3 shows it by counting 1,000 drives). On the horizontal axis, the log-odds, multiplying by 6 is always the same step: the three teal arrows have the same length.</a:t>
+              <a:t>The picture shows three drives, marked by the yellow dots: an average drive at 0.2%, one at 50% and one at 95%. Each receives the same reading - a value one of its counters reports, say a high count of reallocated sectors - and it is a reading six times more common among drives that fail than among healthy ones. Bayes’ rule says such a reading multiplies the odds - the probability of failing divided by the probability of not failing - by 6, whatever they were before (handout section 2.3 shows it by counting 1,000 drives). On the horizontal axis, the log-odds, multiplying by 6 is always the same step: the three teal arrows have the same length.</a:t>
             </a:r>
           </a:p>
           <a:p>

</xml_diff>

<commit_message>
Say what one standard deviation of a log-scale counter means on lesson 4's slide 13
Co-Authored-By: Claude Opus 5.5 <noreply@anthropic.com>
Claude-Session: https://claude.ai/code/session_01BdugDqEmUaYq1vzEjdPDKj
</commit_message>
<xml_diff>
--- a/Lessons/04_classification_and_metrics/Slides/classification_and_metrics_slides.pptx
+++ b/Lessons/04_classification_and_metrics/Slides/classification_and_metrics_slides.pptx
@@ -940,7 +940,21 @@
             </a:pPr>
             <a:r>
               <a:rPr/>
-              <a:t>First bullet, its first half. Standardising first (StandardScaler, lesson 3) puts every feature in the same unit, one standard deviation, so the coefficients can be compared with each other. For the four counters that the data puts on a logarithmic scale, it is one standard deviation of the transformed column.</a:t>
+              <a:t>First bullet, its first half: why “standardised” comes first. A coefficient says how much z grows when its feature rises by one unit, and the raw units differ - a sector, a degree, an hour in service - so raw coefficients cannot be compared. StandardScaler (lesson 3) rescales every feature to mean 0 and standard deviation 1: from then on, one unit means one standard deviation for every feature, and the coefficients can be compared with each other.</a:t>
+            </a:r>
+          </a:p>
+          <a:p>
+            <a:pPr lvl="0" indent="0" marL="0">
+              <a:buNone/>
+            </a:pPr>
+          </a:p>
+          <a:p>
+            <a:pPr lvl="0" indent="0" marL="0">
+              <a:buNone/>
+            </a:pPr>
+            <a:r>
+              <a:rPr/>
+              <a:t>Say what one standard deviation means for this counter, because it is not “one sector more”. The four counters on a logarithmic scale are standardised after log(1 + x), so reallocated sectors contribute 1.80 times (log(1 + x) minus 0.96) divided by 0.62 to z, where 0.96 and 0.62 are the mean and the standard deviation of log(1 + x) over the fleet. One standard deviation more adds 0.62 to log(1 + x), which multiplies 1 + x by e to the 0.62 = 1.86: from 1 sector to 2.7, from 4 to 8.3, from 10 to 19.5. Roughly, the count doubles - and each such step multiplies the odds by the same 6.05. That is why the first sectors weigh so much: 1 to 2.7 sectors counts as much as 10 to 19.5. Temperature and hours are standardised on their own values, so for them one standard deviation is an ordinary additive step.</a:t>
             </a:r>
           </a:p>
           <a:p>
@@ -11217,7 +11231,7 @@
             <a:pPr lvl="0"/>
             <a:r>
               <a:rPr/>
-              <a:t>Standardised: one standard deviation more of reallocated sectors adds 1.80 to the log-odds</a:t>
+              <a:t>Standardised (mean 0, SD 1): one SD more of reallocated sectors adds its true coefficient, 1.80 (slide 14), to the log-odds</a:t>
             </a:r>
           </a:p>
           <a:p>

</xml_diff>

<commit_message>
Say what x is in lesson 4's model: standardised counters, so x = 0 is the average drive
Co-Authored-By: Claude Opus 5.5 <noreply@anthropic.com>
Claude-Session: https://claude.ai/code/session_01BdugDqEmUaYq1vzEjdPDKj
</commit_message>
<xml_diff>
--- a/Lessons/04_classification_and_metrics/Slides/classification_and_metrics_slides.pptx
+++ b/Lessons/04_classification_and_metrics/Slides/classification_and_metrics_slides.pptx
@@ -1258,7 +1258,21 @@
             </a:pPr>
             <a:r>
               <a:rPr/>
-              <a:t>Say first what the intercept is NOT: it is not the base rate. The fleet fails at 3.8%; the intercept describes a drive whose every counter sits at the average, and such a drive almost never fails. The failures come from the small group of drives far above average on one or more counters. Handout section 2.4.</a:t>
+              <a:t>Start with what x = 0 means. The intercept is the value of the log-odds when every x is 0 - but the x are standardised (slide 13), so x = 0 is not a drive with no sectors and no errors: it is a drive sitting exactly at the fleet average on every counter.</a:t>
+            </a:r>
+          </a:p>
+          <a:p>
+            <a:pPr lvl="0" indent="0" marL="0">
+              <a:buNone/>
+            </a:pPr>
+          </a:p>
+          <a:p>
+            <a:pPr lvl="0" indent="0" marL="0">
+              <a:buNone/>
+            </a:pPr>
+            <a:r>
+              <a:rPr/>
+              <a:t>Then say what the intercept is NOT: it is not the base rate. The fleet fails at 3.8%; the intercept describes a drive whose every counter sits at the average, and such a drive almost never fails. The failures come from the small group of drives far above average on one or more counters. Handout section 2.4.</a:t>
             </a:r>
           </a:p>
           <a:p>
@@ -11882,7 +11896,7 @@
             </a:r>
             <a:r>
               <a:rPr/>
-              <a:t>, the log-odds of a drive average on every counter (all x = 0)</a:t>
+              <a:t>, the log-odds of a drive average on every counter (all standardised x = 0)</a:t>
             </a:r>
           </a:p>
           <a:p>

</xml_diff>

<commit_message>
Name lesson 4's predictable slips in the notes and handout
From the instructor's study: p as a vague 'probability of trouble', x = 0
read as zero counters, the factor column read as P(fail), one drive's factor
called its likelihood. Slide 19's title now says 'one drive, then the
likelihood'.

Co-Authored-By: Claude Opus 5.5 <noreply@anthropic.com>
Claude-Session: https://claude.ai/code/session_01BdugDqEmUaYq1vzEjdPDKj
</commit_message>
<xml_diff>
--- a/Lessons/04_classification_and_metrics/Slides/classification_and_metrics_slides.pptx
+++ b/Lessons/04_classification_and_metrics/Slides/classification_and_metrics_slides.pptx
@@ -737,6 +737,20 @@
               <a:t>The handout runs the same algebra in the other direction, from the sigmoid to the log-odds, in section 2.3.</a:t>
             </a:r>
           </a:p>
+          <a:p>
+            <a:pPr lvl="0" indent="0" marL="0">
+              <a:buNone/>
+            </a:pPr>
+          </a:p>
+          <a:p>
+            <a:pPr lvl="0" indent="0" marL="0">
+              <a:buNone/>
+            </a:pPr>
+            <a:r>
+              <a:rPr/>
+              <a:t>Two predictable slips, worth correcting as soon as you hear them. First, p is not a vague “probability that the drive has problems”: it is P(y = 1 | x), the probability that this drive fails within thirty days, given its six counters. Second, the line has the same form as lesson 3’s, but it is not fitted by least squares: w and b are chosen by maximum likelihood, which slides 16 to 21 build.</a:t>
+            </a:r>
+          </a:p>
         </p:txBody>
       </p:sp>
       <p:sp>
@@ -1523,6 +1537,20 @@
               <a:t>Ask the room: is setting 1 a good setting? Let them argue it from the table. It gave the drive that failed a high p, and the two that survived a low one, so it looks good. The next slide turns that impression into a number.</a:t>
             </a:r>
           </a:p>
+          <a:p>
+            <a:pPr lvl="0" indent="0" marL="0">
+              <a:buNone/>
+            </a:pPr>
+          </a:p>
+          <a:p>
+            <a:pPr lvl="0" indent="0" marL="0">
+              <a:buNone/>
+            </a:pPr>
+            <a:r>
+              <a:rPr/>
+              <a:t>A predictable slip: reading B’s 0.1 as “the probability of what happened to B”. It is not. p is the probability of FAILING for every drive, including the two that stayed healthy; the probability of what happened to B is 1 - 0.1 = 0.9, and that conversion is exactly the next slide.</a:t>
+            </a:r>
+          </a:p>
         </p:txBody>
       </p:sp>
       <p:sp>
@@ -1647,6 +1675,20 @@
               <a:t>That product has a name: the likelihood of the setting. The next slide writes the same two rules as formulas.</a:t>
             </a:r>
           </a:p>
+          <a:p>
+            <a:pPr lvl="0" indent="0" marL="0">
+              <a:buNone/>
+            </a:pPr>
+          </a:p>
+          <a:p>
+            <a:pPr lvl="0" indent="0" marL="0">
+              <a:buNone/>
+            </a:pPr>
+            <a:r>
+              <a:rPr/>
+              <a:t>A predictable slip: describing this slide as “the probability of failing for the three drives”. The last column is the probability of WHAT HAPPENED - of failing for A, of staying healthy for B and C. And the multiplication needs its condition said aloud: the drives must be independent, as two coin tosses are, for the probability of all three outcomes to be the product.</a:t>
+            </a:r>
+          </a:p>
         </p:txBody>
       </p:sp>
       <p:sp>
@@ -1769,6 +1811,20 @@
             <a:r>
               <a:rPr/>
               <a:t>The p inside depends on w and b, through p = sigma(w-transpose-x + b). That is why L is written as a function of w and b: change the setting, every p changes, and the likelihood changes with them. Handout section 3.2.</a:t>
+            </a:r>
+          </a:p>
+          <a:p>
+            <a:pPr lvl="0" indent="0" marL="0">
+              <a:buNone/>
+            </a:pPr>
+          </a:p>
+          <a:p>
+            <a:pPr lvl="0" indent="0" marL="0">
+              <a:buNone/>
+            </a:pPr>
+            <a:r>
+              <a:rPr/>
+              <a:t>A predictable slip of language: calling the top line “the likelihood of one example”. It is one drive’s factor, the probability of what happened to that drive. The likelihood is the product on the bottom line, read as a function of w and b with the data held fixed - which is why it is written L(w, b).</a:t>
             </a:r>
           </a:p>
         </p:txBody>
@@ -12771,7 +12827,7 @@
             </a:pPr>
             <a:r>
               <a:rPr/>
-              <a:t>Step 2 as formulas: the likelihood</a:t>
+              <a:t>Step 2 as formulas: one drive, then the likelihood</a:t>
             </a:r>
           </a:p>
         </p:txBody>

</xml_diff>

<commit_message>
Retitle lesson 4's slide 10 and say why evidence multiplies the odds; setting 1 is not the maximum
Co-Authored-By: Claude Opus 5.5 <noreply@anthropic.com>
Claude-Session: https://claude.ai/code/session_01BdugDqEmUaYq1vzEjdPDKj
</commit_message>
<xml_diff>
--- a/Lessons/04_classification_and_metrics/Slides/classification_and_metrics_slides.pptx
+++ b/Lessons/04_classification_and_metrics/Slides/classification_and_metrics_slides.pptx
@@ -1906,6 +1906,20 @@
             </a:pPr>
             <a:r>
               <a:rPr/>
+              <a:t>Why a second setting at all: 0.576 on its own means nothing - there is no scale on which it is “high” or “low”. A likelihood is only useful as a comparison between settings, so we need a second one to compare against.</a:t>
+            </a:r>
+          </a:p>
+          <a:p>
+            <a:pPr lvl="0" indent="0" marL="0">
+              <a:buNone/>
+            </a:pPr>
+          </a:p>
+          <a:p>
+            <a:pPr lvl="0" indent="0" marL="0">
+              <a:buNone/>
+            </a:pPr>
+            <a:r>
+              <a:rPr/>
               <a:t>Now a second setting, a different choice of w and b. It gives the three drives p = 0.3, 0.6 and 0.5: a low p to the drive that failed, a high p to one that survived. It looks worse, and the likelihood says how much worse.</a:t>
             </a:r>
           </a:p>
@@ -2168,6 +2182,20 @@
             </a:pPr>
             <a:r>
               <a:rPr/>
+              <a:t>A predictable slip: calling setting 1 “the maximum” and 0.55 “the minimum cost”. Setting 1 only beats setting 2; other choices of w and b would surely make these three outcomes more probable still. The maximum likelihood over every possible (w, b) - the same point as the minimum cost - is what fitting finds.</a:t>
+            </a:r>
+          </a:p>
+          <a:p>
+            <a:pPr lvl="0" indent="0" marL="0">
+              <a:buNone/>
+            </a:pPr>
+          </a:p>
+          <a:p>
+            <a:pPr lvl="0" indent="0" marL="0">
+              <a:buNone/>
+            </a:pPr>
+            <a:r>
+              <a:rPr/>
               <a:t>Read the per-drive numbers too. Minus the log of a probability is called the surprise of an outcome: 0 for something you were certain of, large for something you said was unlikely. Setting 2 is most surprised by drive A, 1.20, because it gave A’s failure only 0.3. Maximum likelihood and least total surprise are the same choice.</a:t>
             </a:r>
           </a:p>
@@ -7766,7 +7794,21 @@
             </a:pPr>
             <a:r>
               <a:rPr/>
-              <a:t>Slide 9 said the log-odds has the range a line needs. That is true, but it is not a reason: plenty of other functions also stretch (0, 1) onto the whole line. This picture gives the reason.</a:t>
+              <a:t>Slide 9 said the log-odds has the range a line needs. That is true, but it is not a reason: plenty of other functions also stretch (0, 1) onto the whole line. This slide gives the reason, in two steps: first why evidence multiplies the odds, then what that looks like.</a:t>
+            </a:r>
+          </a:p>
+          <a:p>
+            <a:pPr lvl="0" indent="0" marL="0">
+              <a:buNone/>
+            </a:pPr>
+          </a:p>
+          <a:p>
+            <a:pPr lvl="0" indent="0" marL="0">
+              <a:buNone/>
+            </a:pPr>
+            <a:r>
+              <a:rPr/>
+              <a:t>Why it multiplies, by counting, before pointing at the figure. Take 1,000 drives at 50% risk: 500 will fail, 500 will not. A reading shows up on 60% of the failing drives and on 10% of the healthy ones. Among the drives that show it, 300 will fail and 50 will not: the odds, failing divided by healthy, go from 500 / 500 = 1 to 300 / 50 = 6. The reading scales the failing drives by 0.6 and the healthy ones by 0.1, so their ratio is multiplied by 0.6 / 0.1 = 6 whatever it was before - start from 950 and 50 and you get 570 and 5, odds 19 to 114. That is Bayes’ rule written with odds. The figure takes it as given and shows the consequence.</a:t>
             </a:r>
           </a:p>
           <a:p>
@@ -11027,7 +11069,7 @@
             </a:pPr>
             <a:r>
               <a:rPr/>
-              <a:t>Evidence multiplies the odds</a:t>
+              <a:t>The same evidence on three drives</a:t>
             </a:r>
           </a:p>
         </p:txBody>

</xml_diff>

<commit_message>
Say why minus log p is called surprise, in lesson 4's slide 22 notes and handout 3.1
Co-Authored-By: Claude Opus 5.5 <noreply@anthropic.com>
Claude-Session: https://claude.ai/code/session_01BdugDqEmUaYq1vzEjdPDKj
</commit_message>
<xml_diff>
--- a/Lessons/04_classification_and_metrics/Slides/classification_and_metrics_slides.pptx
+++ b/Lessons/04_classification_and_metrics/Slides/classification_and_metrics_slides.pptx
@@ -2335,6 +2335,20 @@
             <a:r>
               <a:rPr/>
               <a:t>Now the six dots. Setting 1’s factors, 0.8, 0.9 and 0.8, sit on the flat right-hand part: small surprises, 0.22 + 0.11 + 0.22 = 0.55 in all. Setting 2’s, 0.3, 0.4 and 0.5, sit higher up: 1.20 + 0.92 + 0.69 = 2.81. The highest dot is drive A under setting 2: it failed, and setting 2 had given its failure only 0.3, so minus log 0.3 = 1.20.</a:t>
+            </a:r>
+          </a:p>
+          <a:p>
+            <a:pPr lvl="0" indent="0" marL="0">
+              <a:buNone/>
+            </a:pPr>
+          </a:p>
+          <a:p>
+            <a:pPr lvl="0" indent="0" marL="0">
+              <a:buNone/>
+            </a:pPr>
+            <a:r>
+              <a:rPr/>
+              <a:t>Why it is called surprise: minus log p behaves the way surprise does. Zero when the model was certain and was right (minus log 1 = 0); large when it had called the outcome unlikely (minus log 0.001 = 6.9); infinite when it had called it impossible. And for independent outcomes the surprises add up, because the log of a product is the sum of the logs - which is why three drives cost the sum of their three surprises. The name comes from information theory, Shannon’s work, and is not examinable. The useful reading: the cost is the model’s average surprise at what really happened, and fitting makes the data as unsurprising as possible - the same thing as making it as likely as possible.</a:t>
             </a:r>
           </a:p>
           <a:p>

</xml_diff>

<commit_message>
Name two more predictable slips in lesson 4: 0 times log 0, and a larger cost read as better descent
Co-Authored-By: Claude Opus 5.5 <noreply@anthropic.com>
Claude-Session: https://claude.ai/code/session_01BdugDqEmUaYq1vzEjdPDKj
</commit_message>
<xml_diff>
--- a/Lessons/04_classification_and_metrics/Slides/classification_and_metrics_slides.pptx
+++ b/Lessons/04_classification_and_metrics/Slides/classification_and_metrics_slides.pptx
@@ -2500,6 +2500,20 @@
             </a:pPr>
             <a:r>
               <a:rPr/>
+              <a:t>A predictable slip: “with y = 1 the second term is 0 times log 0, which is 0 times minus infinity”. The coefficient is 1 - y, but the logarithm’s argument is 1 - p, the model’s probability - and p = sigma(z) lies strictly between 0 and 1, so log(1 - p) is finite and 0 times it is 0. Only p exactly 1 would give log 0, and the sigmoid never reaches it. In a computer p can round to 1.0 when z is large, which is why code clips p into [epsilon, 1 - epsilon]: notebook 1 adds 1e-12 inside the log, and scikit-learn’s log_loss clips too.</a:t>
+            </a:r>
+          </a:p>
+          <a:p>
+            <a:pPr lvl="0" indent="0" marL="0">
+              <a:buNone/>
+            </a:pPr>
+          </a:p>
+          <a:p>
+            <a:pPr lvl="0" indent="0" marL="0">
+              <a:buNone/>
+            </a:pPr>
+            <a:r>
+              <a:rPr/>
               <a:t>And the headline: nobody designed this function. It fell out of asking for the parameters that make the data least surprising.</a:t>
             </a:r>
           </a:p>
@@ -2791,6 +2805,20 @@
             <a:r>
               <a:rPr/>
               <a:t>That is the failure. Not that squared error scores badly - that it stops teaching.</a:t>
+            </a:r>
+          </a:p>
+          <a:p>
+            <a:pPr lvl="0" indent="0" marL="0">
+              <a:buNone/>
+            </a:pPr>
+          </a:p>
+          <a:p>
+            <a:pPr lvl="0" indent="0" marL="0">
+              <a:buNone/>
+            </a:pPr>
+            <a:r>
+              <a:rPr/>
+              <a:t>A predictable slip, from the left panel alone: “log loss charges more, so gradient descent works better with it”. The size of a cost does not matter to gradient descent - multiply a cost by 100 and its minimum is in the same place. What matters is the gradient, the right panel: the push squared error gives dies away exactly when the model is confidently wrong, and log loss’s does not.</a:t>
             </a:r>
           </a:p>
         </p:txBody>

</xml_diff>

<commit_message>
Apply lesson 4's study fixes for slides 43-47: the ranking, the pairs behind the AUC, calibration
Slide 43 defines the ranking and the threshold as a cut in it. The ROC axes
carry TPR = recall and FPR = 1 - specificity; the notes and handout 8.1 count
the steps (1/76 up, 1/1,924 right) and say how the ROC reading differs from
the precision-recall curve's. Notebook 3 now counts the 146,224 pairs exactly
(7,409 in the wrong order, the worst failure alone 1,408) and shows dividing
by 10 (56 flagged, then none, AUC unchanged) and a constant 0.038 (calibrated,
AUC 0.5). Slide 47 defines calibration on the slide body. The histogram slip
(heights read as counts) is named in the notes and handout. Ranking and
calibration enter the concepts index; worked_examples.py checks 248 numbers.

Co-Authored-By: Claude Opus 5.5 <noreply@anthropic.com>
Claude-Session: https://claude.ai/code/session_01BdugDqEmUaYq1vzEjdPDKj
</commit_message>
<xml_diff>
--- a/Lessons/04_classification_and_metrics/Slides/classification_and_metrics_slides.pptx
+++ b/Lessons/04_classification_and_metrics/Slides/classification_and_metrics_slides.pptx
@@ -5410,6 +5410,34 @@
               <a:t>The move is to stop asking “how many did it get right” and start asking “did it put the failures at the top of the list”. That is a question about ranking, and ranking has no threshold in it.</a:t>
             </a:r>
           </a:p>
+          <a:p>
+            <a:pPr lvl="0" indent="0" marL="0">
+              <a:buNone/>
+            </a:pPr>
+          </a:p>
+          <a:p>
+            <a:pPr lvl="0" indent="0" marL="0">
+              <a:buNone/>
+            </a:pPr>
+            <a:r>
+              <a:rPr/>
+              <a:t>Say what the ranking is before using the word: sort the 2,000 test drives by the probability the model gave them, highest first. Then a threshold is nothing but a place to cut that list - everything above the cut is flagged - and lowering the threshold moves the cut down. So a threshold-free evaluation does not throw the threshold away: it looks at every cut of the same list at once. The precision-recall curve of slide 42 was already a first step, every threshold on one curve.</a:t>
+            </a:r>
+          </a:p>
+          <a:p>
+            <a:pPr lvl="0" indent="0" marL="0">
+              <a:buNone/>
+            </a:pPr>
+          </a:p>
+          <a:p>
+            <a:pPr lvl="0" indent="0" marL="0">
+              <a:buNone/>
+            </a:pPr>
+            <a:r>
+              <a:rPr/>
+              <a:t>Two conditions to keep in mind, both coming back later: only the order counts, not the values of p, so a ranking measure cannot see calibration (slide 47); and the day the model is used, one cut still has to be chosen (slides 51-53).</a:t>
+            </a:r>
+          </a:p>
         </p:txBody>
       </p:sp>
       <p:sp>
@@ -5534,6 +5562,34 @@
               <a:t>So the curve asks: as we grow more willing to raise alarms, do we catch failures faster than we annoy technicians?</a:t>
             </a:r>
           </a:p>
+          <a:p>
+            <a:pPr lvl="0" indent="0" marL="0">
+              <a:buNone/>
+            </a:pPr>
+          </a:p>
+          <a:p>
+            <a:pPr lvl="0" indent="0" marL="0">
+              <a:buNone/>
+            </a:pPr>
+            <a:r>
+              <a:rPr/>
+              <a:t>Make the steps concrete. Walk down the ranking one drive at a time: a failing drive moves the curve up by 1/76, a healthy one moves it right by 1/1,924. A steep start means the top of the ranking is failures. The ideal curve goes straight up to (0, 1), then across. Every curve ends at (1, 1), so a curve that is steep at the start is flat at the end - and the area under it, next slide, measures exactly that. Check one point: threshold 0.5 gives TPR = 43 ÷ 76 = 0.57 and FPR = 13 ÷ 1,924 = 0.007.</a:t>
+            </a:r>
+          </a:p>
+          <a:p>
+            <a:pPr lvl="0" indent="0" marL="0">
+              <a:buNone/>
+            </a:pPr>
+          </a:p>
+          <a:p>
+            <a:pPr lvl="0" indent="0" marL="0">
+              <a:buNone/>
+            </a:pPr>
+            <a:r>
+              <a:rPr/>
+              <a:t>The sweep is the same as the precision-recall curve’s; the reading is not. The precision-recall curve’s ideal is the top-right corner, and precision divides by the alarms raised. The ROC’s ideal is the top-left corner, and FPR divides by the 1,924 healthy drives, so its random baseline is the diagonal whatever the class balance, against 0.038 for precision-recall. That denominator is why ROC can hide imbalance (slides 48-49).</a:t>
+            </a:r>
+          </a:p>
         </p:txBody>
       </p:sp>
       <p:sp>
@@ -5658,6 +5714,20 @@
               <a:t>The identity with the Mann-Whitney U statistic - a classical test that compares two groups by counting, over every pair, which member ranks higher - is in the handout, section 8.2, for anyone who wants the proof. But notebook 3 does something better than a proof for this audience: it draws 200,000 random pairs and counts. 0.9488 against roc_auc_score’s 0.9493.</a:t>
             </a:r>
           </a:p>
+          <a:p>
+            <a:pPr lvl="0" indent="0" marL="0">
+              <a:buNone/>
+            </a:pPr>
+          </a:p>
+          <a:p>
+            <a:pPr lvl="0" indent="0" marL="0">
+              <a:buNone/>
+            </a:pPr>
+            <a:r>
+              <a:rPr/>
+              <a:t>Which pairs, and why the two differ. The test set has 76 × 1,924 = 146,224 (failing, healthy) pairs. The exact AUC is the share of them in which the failing drive scores higher, a tie counting half: notebook 3 counts 7,409 pairs in the wrong order, and 1 − 7,409 ÷ 146,224 = 0.9493. So “probability” and “share of pairs” are the same number. The 200,000 random pairs are an estimate of that share, which is why they give 0.9488: sampling noise.</a:t>
+            </a:r>
+          </a:p>
         </p:txBody>
       </p:sp>
       <p:sp>
@@ -5782,6 +5852,34 @@
               <a:t>Note what the figure does not show: where to put the threshold. Any vertical line splits it, and the AUC is the same whichever you pick - the next slide.</a:t>
             </a:r>
           </a:p>
+          <a:p>
+            <a:pPr lvl="0" indent="0" marL="0">
+              <a:buNone/>
+            </a:pPr>
+          </a:p>
+          <a:p>
+            <a:pPr lvl="0" indent="0" marL="0">
+              <a:buNone/>
+            </a:pPr>
+            <a:r>
+              <a:rPr/>
+              <a:t>A predictable slip: reading the heights as numbers of drives. They are shares of each group, each colour adding up to 1; as counts the 76 rust drives would be invisible next to the 1,924 teal ones. The reading is reasonable because a histogram usually counts. Notebook 3 converts back: the tallest rust bar, 0.342, is 26 drives; the tallest teal bar, 0.056, is 108. The low bar holds four times as many drives.</a:t>
+            </a:r>
+          </a:p>
+          <a:p>
+            <a:pPr lvl="0" indent="0" marL="0">
+              <a:buNone/>
+            </a:pPr>
+          </a:p>
+          <a:p>
+            <a:pPr lvl="0" indent="0" marL="0">
+              <a:buNone/>
+            </a:pPr>
+            <a:r>
+              <a:rPr/>
+              <a:t>Where the 5% comes from, counted in notebook 3: 7,409 of the 146,224 pairs are in the wrong order. A failing drive costs one wrong pair for every healthy drive scored above it, so a failure far to the left costs a lot: the lowest-scoring one (p = 0.0004) is outscored by 1,408 healthy drives, a fifth of all the wrong pairs by itself. The 5 worst failures make 61% of them; 19 failures score above every healthy drive and cost nothing.</a:t>
+            </a:r>
+          </a:p>
         </p:txBody>
       </p:sp>
       <p:sp>
@@ -5904,6 +6002,34 @@
             <a:r>
               <a:rPr/>
               <a:t>Good place to mention that calibration - whether a predicted 0.7 really comes true 70% of the time - is a topic of its own, without going into it.</a:t>
+            </a:r>
+          </a:p>
+          <a:p>
+            <a:pPr lvl="0" indent="0" marL="0">
+              <a:buNone/>
+            </a:pPr>
+          </a:p>
+          <a:p>
+            <a:pPr lvl="0" indent="0" marL="0">
+              <a:buNone/>
+            </a:pPr>
+            <a:r>
+              <a:rPr/>
+              <a:t>The 56: at threshold 0.5 the fitted model flags 43 + 13 = 56 drives. Divided by 10, the largest score is 0.100, so nothing reaches 0.5: recall 0, AUC still 0.949. The condition: this holds for any change that keeps the order, that is any strictly increasing one; a change that reverses the order turns the AUC into 1 − AUC. “Multiply by 10” would keep the AUC too, but the scores would stop being probabilities.</a:t>
+            </a:r>
+          </a:p>
+          <a:p>
+            <a:pPr lvl="0" indent="0" marL="0">
+              <a:buNone/>
+            </a:pPr>
+          </a:p>
+          <a:p>
+            <a:pPr lvl="0" indent="0" marL="0">
+              <a:buNone/>
+            </a:pPr>
+            <a:r>
+              <a:rPr/>
+              <a:t>The converse is worth one sentence, because it shows the two properties are independent: give every drive 0.038, the fleet’s failure rate. On average that is right - calibrated - and it ranks nothing: AUC 0.5 (notebook 3).</a:t>
             </a:r>
           </a:p>
         </p:txBody>
@@ -17138,7 +17264,7 @@
             <a:pPr lvl="0"/>
             <a:r>
               <a:rPr/>
-              <a:t>What if we score the whole </a:t>
+              <a:t>The </a:t>
             </a:r>
             <a:r>
               <a:rPr b="1"/>
@@ -17146,7 +17272,21 @@
             </a:r>
             <a:r>
               <a:rPr/>
-              <a:t> instead?</a:t>
+              <a:t>: the 2,000 test drives sorted by predicted probability, riskiest first</a:t>
+            </a:r>
+          </a:p>
+          <a:p>
+            <a:pPr lvl="0"/>
+            <a:r>
+              <a:rPr/>
+              <a:t>A threshold is a cut in this list: every drive above the cut is flagged</a:t>
+            </a:r>
+          </a:p>
+          <a:p>
+            <a:pPr lvl="0"/>
+            <a:r>
+              <a:rPr/>
+              <a:t>What if we score the whole ranking, every cut at once?</a:t>
             </a:r>
           </a:p>
         </p:txBody>
@@ -17522,7 +17662,29 @@
             </a:r>
             <a:r>
               <a:rPr/>
-              <a:t>; every decision changes</a:t>
+              <a:t>, 0.949: the order of the drives is the same</a:t>
+            </a:r>
+          </a:p>
+          <a:p>
+            <a:pPr lvl="0"/>
+            <a:r>
+              <a:rPr/>
+              <a:t>Every decision changes: at threshold 0.5, 56 drives flagged before, none after (notebook 3)</a:t>
+            </a:r>
+          </a:p>
+          <a:p>
+            <a:pPr lvl="0"/>
+            <a:r>
+              <a:rPr/>
+              <a:t>The model is now badly </a:t>
+            </a:r>
+            <a:r>
+              <a:rPr b="1"/>
+              <a:t>calibrated</a:t>
+            </a:r>
+            <a:r>
+              <a:rPr/>
+              <a:t>: calibrated means a predicted 0.7 comes true about 70% of the time</a:t>
             </a:r>
           </a:p>
         </p:txBody>

</xml_diff>

<commit_message>
Add lesson 4's commentary, from the study questions and the independent review
- Docs/classification_and_metrics_commentary.md: all 62 slides, with the questions
  raised while the lesson was studied and by the review answered under their
  slide, the notebooks' questions under the slide that introduces each, and
  the lesson's figures
- Docs/commentary_examples.py: ten worked examples with invented values (odds,
  odds multipliers, log loss, a gradient step, a confusion matrix, AUC by
  pairs, average precision, the cost threshold, class weights, softmax), each
  checked by a second route where one exists
- Slide notes 38, 49 and 56 aligned with the review fixes: minority class then
  macro, AUC unmoved by the class balance, class weights almost a
  reparameterisation here

Co-Authored-By: Claude Opus 5.5 <noreply@anthropic.com>
Claude-Session: https://claude.ai/code/session_01BdugDqEmUaYq1vzEjdPDKj
</commit_message>
<xml_diff>
--- a/Lessons/04_classification_and_metrics/Slides/classification_and_metrics_slides.pptx
+++ b/Lessons/04_classification_and_metrics/Slides/classification_and_metrics_slides.pptx
@@ -4679,7 +4679,7 @@
             </a:pPr>
             <a:r>
               <a:rPr/>
-              <a:t>The rule: on an imbalanced problem, quote the macro average or the minority class directly. Reporting the weighted average is not incorrect - it is the number that makes a mediocre model look finished, and choosing it without saying so is how a result gets oversold.</a:t>
+              <a:t>The rule: on an imbalanced problem, quote the minority class directly, and the macro average when the classes should count equally. Reporting the weighted average is not incorrect - it is the number that makes a mediocre model look finished, and choosing it without saying so is how a result gets oversold.</a:t>
             </a:r>
           </a:p>
           <a:p>
@@ -6321,7 +6321,7 @@
             </a:pPr>
             <a:r>
               <a:rPr/>
-              <a:t>This is the lesson’s second big predictable mistake, after trusting accuracy on slide 31, and again defend the instinct: AUC is threshold-free, comparable across models and datasets, bounded in a familiar range. Those are real virtues. It simply answers a question about ranking when the question was about the alarm queue.</a:t>
+              <a:t>This is the lesson’s second big predictable mistake, after trusting accuracy on slide 31, and again defend the instinct: AUC is threshold-free, comparable across models, unmoved by the class balance. Those are real virtues. It simply answers a question about ranking when the question was about the alarm queue.</a:t>
             </a:r>
           </a:p>
         </p:txBody>
@@ -7341,7 +7341,7 @@
             </a:pPr>
             <a:r>
               <a:rPr/>
-              <a:t>That matters because class weighting is usually presented as a REMEDY for imbalance. It is not a remedy; it is another way of setting the same decision. The remedy, where one exists, is more positive examples.</a:t>
+              <a:t>That matters because class weighting is usually presented as a REMEDY for imbalance. It is not a remedy; here it is almost exactly another way of setting the same decision. The remedy, where one exists, is more positive examples.</a:t>
             </a:r>
           </a:p>
           <a:p>

</xml_diff>

<commit_message>
Move the calendar one week: lesson 4 ends on 6 November, lesson 5 follows in two hours and a quarter
Lesson 4 reached its slide 42 on 30 October; its last slides open
6 November, where exercise 4 is set. Lesson 5 keeps all its material and
marks slides 16-17, 27-28, 42-43 and notebook 2 as optional self-study; its
plan is rewritten for that day and its opening slide says so. Exercises 4
and 5 are both discussed on 13 November, which lesson 6's opening now
covers. Every date from lesson 5 on moves by a week, lesson 10 to
11 December; SCHEDULE.md and the README follow. Lesson 8's dates are left
for the rewrite in progress there.

Co-Authored-By: Claude Opus 5.5 <noreply@anthropic.com>
</commit_message>
<xml_diff>
--- a/Lessons/04_classification_and_metrics/Slides/classification_and_metrics_slides.pptx
+++ b/Lessons/04_classification_and_metrics/Slides/classification_and_metrics_slides.pptx
@@ -8279,7 +8279,7 @@
             </a:pPr>
             <a:r>
               <a:rPr/>
-              <a:t>Set it explicitly and say out loud when it comes back: the first ten minutes of next Friday, 6 November.</a:t>
+              <a:t>Set it explicitly and say out loud when it comes back: the start of Friday 13 November, together with exercise 5. (Lesson 4 ran over two Fridays: this slide is reached on 6 November, after which lesson 5 begins the same day.)</a:t>
             </a:r>
           </a:p>
           <a:p>
@@ -8321,7 +8321,7 @@
             </a:pPr>
             <a:r>
               <a:rPr/>
-              <a:t>Next week: experimental methodology. Cross-validation, bias-variance, and the honest way to make every choice we made by hand today.</a:t>
+              <a:t>Next: experimental methodology, straight after this slide. Cross-validation, bias-variance, and the honest way to make every choice we made by hand in this lesson.</a:t>
             </a:r>
           </a:p>
         </p:txBody>
@@ -20201,7 +20201,7 @@
             </a:r>
             <a:r>
               <a:rPr b="1"/>
-              <a:t>Friday 6 November</a:t>
+              <a:t>Friday 13 November</a:t>
             </a:r>
           </a:p>
           <a:p>

</xml_diff>